<commit_message>
Rename p1LoadRawDeviceData to p1LoadRawCc
</commit_message>
<xml_diff>
--- a/spec/diagrams/hl_process.pptx
+++ b/spec/diagrams/hl_process.pptx
@@ -7471,7 +7471,7 @@
         <p:spPr>
           <a:xfrm>
             <a:off x="1133121" y="5437540"/>
-            <a:ext cx="1281120" cy="461665"/>
+            <a:ext cx="889987" cy="461665"/>
           </a:xfrm>
           <a:prstGeom prst="rect">
             <a:avLst/>
@@ -7495,9 +7495,10 @@
               <a:t>- </a:t>
             </a:r>
             <a:r>
-              <a:rPr lang="en-US" sz="800" dirty="0"/>
-              <a:t>p1LoadRawDeviceData</a:t>
+              <a:rPr lang="de-DE" sz="800" dirty="0"/>
+              <a:t>p1LoadRawCc</a:t>
             </a:r>
+            <a:endParaRPr lang="en-US" sz="800" dirty="0"/>
           </a:p>
           <a:p>
             <a:r>
@@ -10297,14 +10298,14 @@
         <p:spPr>
           <a:xfrm>
             <a:off x="4730611" y="2213275"/>
-            <a:ext cx="2624922" cy="215444"/>
+            <a:ext cx="1250577" cy="215444"/>
           </a:xfrm>
           <a:prstGeom prst="borderCallout1">
             <a:avLst>
               <a:gd name="adj1" fmla="val 51908"/>
               <a:gd name="adj2" fmla="val -1600"/>
-              <a:gd name="adj3" fmla="val 115388"/>
-              <a:gd name="adj4" fmla="val -23167"/>
+              <a:gd name="adj3" fmla="val 138539"/>
+              <a:gd name="adj4" fmla="val -35132"/>
             </a:avLst>
           </a:prstGeom>
           <a:noFill/>
@@ -10323,13 +10324,14 @@
           <a:lstStyle/>
           <a:p>
             <a:r>
-              <a:rPr lang="de-DE" sz="800" dirty="0">
-                <a:solidFill>
-                  <a:schemeClr val="tx1"/>
-                </a:solidFill>
-              </a:rPr>
-              <a:t>p1ProcessingOrchestratorForHistoricalPmData</a:t>
+              <a:rPr lang="de-DE" sz="800" dirty="0"/>
+              <a:t>p1ProcessingPmData</a:t>
             </a:r>
+            <a:endParaRPr lang="de-DE" sz="800" dirty="0">
+              <a:solidFill>
+                <a:schemeClr val="tx1"/>
+              </a:solidFill>
+            </a:endParaRPr>
           </a:p>
         </p:txBody>
       </p:sp>
@@ -11099,176 +11101,6 @@
             <a:r>
               <a:rPr lang="de-DE" sz="800" dirty="0"/>
               <a:t>DPMDP ES</a:t>
-            </a:r>
-          </a:p>
-        </p:txBody>
-      </p:sp>
-      <p:sp>
-        <p:nvSpPr>
-          <p:cNvPr id="48" name="Sprechblase: rechteckig 47">
-            <a:extLst>
-              <a:ext uri="{FF2B5EF4-FFF2-40B4-BE49-F238E27FC236}">
-                <a16:creationId xmlns:a16="http://schemas.microsoft.com/office/drawing/2014/main" id="{F51B8E48-A238-C91B-0F18-945FE0634F2D}"/>
-              </a:ext>
-            </a:extLst>
-          </p:cNvPr>
-          <p:cNvSpPr/>
-          <p:nvPr/>
-        </p:nvSpPr>
-        <p:spPr>
-          <a:xfrm>
-            <a:off x="5650799" y="1730600"/>
-            <a:ext cx="2502407" cy="314997"/>
-          </a:xfrm>
-          <a:prstGeom prst="wedgeRectCallout">
-            <a:avLst>
-              <a:gd name="adj1" fmla="val -44897"/>
-              <a:gd name="adj2" fmla="val 107858"/>
-            </a:avLst>
-          </a:prstGeom>
-          <a:solidFill>
-            <a:srgbClr val="FFFF00"/>
-          </a:solidFill>
-          <a:ln>
-            <a:noFill/>
-          </a:ln>
-        </p:spPr>
-        <p:style>
-          <a:lnRef idx="2">
-            <a:schemeClr val="accent1">
-              <a:shade val="15000"/>
-            </a:schemeClr>
-          </a:lnRef>
-          <a:fillRef idx="1">
-            <a:schemeClr val="accent1"/>
-          </a:fillRef>
-          <a:effectRef idx="0">
-            <a:schemeClr val="accent1"/>
-          </a:effectRef>
-          <a:fontRef idx="minor">
-            <a:schemeClr val="lt1"/>
-          </a:fontRef>
-        </p:style>
-        <p:txBody>
-          <a:bodyPr rtlCol="0" anchor="t"/>
-          <a:lstStyle/>
-          <a:p>
-            <a:r>
-              <a:rPr lang="de-DE" sz="800" dirty="0" err="1">
-                <a:solidFill>
-                  <a:schemeClr val="tx1"/>
-                </a:solidFill>
-              </a:rPr>
-              <a:t>rename</a:t>
-            </a:r>
-            <a:r>
-              <a:rPr lang="de-DE" sz="800" dirty="0">
-                <a:solidFill>
-                  <a:schemeClr val="tx1"/>
-                </a:solidFill>
-              </a:rPr>
-              <a:t> </a:t>
-            </a:r>
-            <a:r>
-              <a:rPr lang="de-DE" sz="800" dirty="0" err="1">
-                <a:solidFill>
-                  <a:schemeClr val="tx1"/>
-                </a:solidFill>
-              </a:rPr>
-              <a:t>to</a:t>
-            </a:r>
-            <a:r>
-              <a:rPr lang="de-DE" sz="800" dirty="0">
-                <a:solidFill>
-                  <a:schemeClr val="tx1"/>
-                </a:solidFill>
-              </a:rPr>
-              <a:t>     p1ProcessingPmData</a:t>
-            </a:r>
-          </a:p>
-        </p:txBody>
-      </p:sp>
-      <p:sp>
-        <p:nvSpPr>
-          <p:cNvPr id="50" name="Sprechblase: rechteckig 49">
-            <a:extLst>
-              <a:ext uri="{FF2B5EF4-FFF2-40B4-BE49-F238E27FC236}">
-                <a16:creationId xmlns:a16="http://schemas.microsoft.com/office/drawing/2014/main" id="{685F77F7-E728-F0BE-FD5F-F4BB5E71152D}"/>
-              </a:ext>
-            </a:extLst>
-          </p:cNvPr>
-          <p:cNvSpPr/>
-          <p:nvPr/>
-        </p:nvSpPr>
-        <p:spPr>
-          <a:xfrm>
-            <a:off x="76774" y="5968496"/>
-            <a:ext cx="1380552" cy="215444"/>
-          </a:xfrm>
-          <a:prstGeom prst="wedgeRectCallout">
-            <a:avLst>
-              <a:gd name="adj1" fmla="val 36538"/>
-              <a:gd name="adj2" fmla="val -179474"/>
-            </a:avLst>
-          </a:prstGeom>
-          <a:solidFill>
-            <a:srgbClr val="FFFF00"/>
-          </a:solidFill>
-          <a:ln>
-            <a:noFill/>
-          </a:ln>
-        </p:spPr>
-        <p:style>
-          <a:lnRef idx="2">
-            <a:schemeClr val="accent1">
-              <a:shade val="15000"/>
-            </a:schemeClr>
-          </a:lnRef>
-          <a:fillRef idx="1">
-            <a:schemeClr val="accent1"/>
-          </a:fillRef>
-          <a:effectRef idx="0">
-            <a:schemeClr val="accent1"/>
-          </a:effectRef>
-          <a:fontRef idx="minor">
-            <a:schemeClr val="lt1"/>
-          </a:fontRef>
-        </p:style>
-        <p:txBody>
-          <a:bodyPr rtlCol="0" anchor="t"/>
-          <a:lstStyle/>
-          <a:p>
-            <a:r>
-              <a:rPr lang="de-DE" sz="800" dirty="0" err="1">
-                <a:solidFill>
-                  <a:schemeClr val="tx1"/>
-                </a:solidFill>
-              </a:rPr>
-              <a:t>rename</a:t>
-            </a:r>
-            <a:r>
-              <a:rPr lang="de-DE" sz="800" dirty="0">
-                <a:solidFill>
-                  <a:schemeClr val="tx1"/>
-                </a:solidFill>
-              </a:rPr>
-              <a:t> </a:t>
-            </a:r>
-            <a:r>
-              <a:rPr lang="de-DE" sz="800" dirty="0" err="1">
-                <a:solidFill>
-                  <a:schemeClr val="tx1"/>
-                </a:solidFill>
-              </a:rPr>
-              <a:t>to</a:t>
-            </a:r>
-            <a:r>
-              <a:rPr lang="de-DE" sz="800" dirty="0">
-                <a:solidFill>
-                  <a:schemeClr val="tx1"/>
-                </a:solidFill>
-              </a:rPr>
-              <a:t>     p1LoadRawCc</a:t>
             </a:r>
           </a:p>
         </p:txBody>

</xml_diff>

<commit_message>
Clean up functions; Review p1DiscardIrrelevantPmRecords
</commit_message>
<xml_diff>
--- a/spec/diagrams/hl_process.pptx
+++ b/spec/diagrams/hl_process.pptx
@@ -5,17 +5,18 @@
     <p:sldMasterId id="2147483648" r:id="rId1"/>
   </p:sldMasterIdLst>
   <p:notesMasterIdLst>
-    <p:notesMasterId r:id="rId10"/>
+    <p:notesMasterId r:id="rId11"/>
   </p:notesMasterIdLst>
   <p:sldIdLst>
-    <p:sldId id="276" r:id="rId2"/>
-    <p:sldId id="277" r:id="rId3"/>
-    <p:sldId id="274" r:id="rId4"/>
-    <p:sldId id="273" r:id="rId5"/>
-    <p:sldId id="272" r:id="rId6"/>
-    <p:sldId id="269" r:id="rId7"/>
-    <p:sldId id="268" r:id="rId8"/>
-    <p:sldId id="271" r:id="rId9"/>
+    <p:sldId id="278" r:id="rId2"/>
+    <p:sldId id="276" r:id="rId3"/>
+    <p:sldId id="277" r:id="rId4"/>
+    <p:sldId id="274" r:id="rId5"/>
+    <p:sldId id="273" r:id="rId6"/>
+    <p:sldId id="272" r:id="rId7"/>
+    <p:sldId id="269" r:id="rId8"/>
+    <p:sldId id="268" r:id="rId9"/>
+    <p:sldId id="271" r:id="rId10"/>
   </p:sldIdLst>
   <p:sldSz cx="12192000" cy="6858000"/>
   <p:notesSz cx="6858000" cy="9144000"/>
@@ -2972,7 +2973,7 @@
           <a:p>
             <a:fld id="{A0820F88-7D74-4DCC-B89C-03CB220DA755}" type="datetimeFigureOut">
               <a:rPr lang="de-DE" smtClean="0"/>
-              <a:t>28.11.2025</a:t>
+              <a:t>28.12.2025</a:t>
             </a:fld>
             <a:endParaRPr lang="de-DE"/>
           </a:p>
@@ -3313,7 +3314,7 @@
     </p:spTree>
     <p:extLst>
       <p:ext uri="{BB962C8B-B14F-4D97-AF65-F5344CB8AC3E}">
-        <p14:creationId xmlns:p14="http://schemas.microsoft.com/office/powerpoint/2010/main" val="3810606055"/>
+        <p14:creationId xmlns:p14="http://schemas.microsoft.com/office/powerpoint/2010/main" val="1847890744"/>
       </p:ext>
     </p:extLst>
   </p:cSld>
@@ -3397,7 +3398,7 @@
     </p:spTree>
     <p:extLst>
       <p:ext uri="{BB962C8B-B14F-4D97-AF65-F5344CB8AC3E}">
-        <p14:creationId xmlns:p14="http://schemas.microsoft.com/office/powerpoint/2010/main" val="2986779705"/>
+        <p14:creationId xmlns:p14="http://schemas.microsoft.com/office/powerpoint/2010/main" val="3810606055"/>
       </p:ext>
     </p:extLst>
   </p:cSld>
@@ -3481,7 +3482,7 @@
     </p:spTree>
     <p:extLst>
       <p:ext uri="{BB962C8B-B14F-4D97-AF65-F5344CB8AC3E}">
-        <p14:creationId xmlns:p14="http://schemas.microsoft.com/office/powerpoint/2010/main" val="2747679539"/>
+        <p14:creationId xmlns:p14="http://schemas.microsoft.com/office/powerpoint/2010/main" val="2986779705"/>
       </p:ext>
     </p:extLst>
   </p:cSld>
@@ -3556,7 +3557,7 @@
           <a:p>
             <a:fld id="{A89F7A99-4242-439B-9281-B79B11F83AA9}" type="slidenum">
               <a:rPr lang="de-DE" smtClean="0"/>
-              <a:t>5</a:t>
+              <a:t>4</a:t>
             </a:fld>
             <a:endParaRPr lang="de-DE"/>
           </a:p>
@@ -3565,7 +3566,7 @@
     </p:spTree>
     <p:extLst>
       <p:ext uri="{BB962C8B-B14F-4D97-AF65-F5344CB8AC3E}">
-        <p14:creationId xmlns:p14="http://schemas.microsoft.com/office/powerpoint/2010/main" val="3983321730"/>
+        <p14:creationId xmlns:p14="http://schemas.microsoft.com/office/powerpoint/2010/main" val="2747679539"/>
       </p:ext>
     </p:extLst>
   </p:cSld>
@@ -3649,7 +3650,7 @@
     </p:spTree>
     <p:extLst>
       <p:ext uri="{BB962C8B-B14F-4D97-AF65-F5344CB8AC3E}">
-        <p14:creationId xmlns:p14="http://schemas.microsoft.com/office/powerpoint/2010/main" val="2317112694"/>
+        <p14:creationId xmlns:p14="http://schemas.microsoft.com/office/powerpoint/2010/main" val="3983321730"/>
       </p:ext>
     </p:extLst>
   </p:cSld>
@@ -3733,7 +3734,7 @@
     </p:spTree>
     <p:extLst>
       <p:ext uri="{BB962C8B-B14F-4D97-AF65-F5344CB8AC3E}">
-        <p14:creationId xmlns:p14="http://schemas.microsoft.com/office/powerpoint/2010/main" val="4166922"/>
+        <p14:creationId xmlns:p14="http://schemas.microsoft.com/office/powerpoint/2010/main" val="2317112694"/>
       </p:ext>
     </p:extLst>
   </p:cSld>
@@ -3809,6 +3810,90 @@
             <a:fld id="{A89F7A99-4242-439B-9281-B79B11F83AA9}" type="slidenum">
               <a:rPr lang="de-DE" smtClean="0"/>
               <a:t>8</a:t>
+            </a:fld>
+            <a:endParaRPr lang="de-DE"/>
+          </a:p>
+        </p:txBody>
+      </p:sp>
+    </p:spTree>
+    <p:extLst>
+      <p:ext uri="{BB962C8B-B14F-4D97-AF65-F5344CB8AC3E}">
+        <p14:creationId xmlns:p14="http://schemas.microsoft.com/office/powerpoint/2010/main" val="4166922"/>
+      </p:ext>
+    </p:extLst>
+  </p:cSld>
+  <p:clrMapOvr>
+    <a:masterClrMapping/>
+  </p:clrMapOvr>
+</p:notes>
+</file>
+
+<file path=ppt/notesSlides/notesSlide8.xml><?xml version="1.0" encoding="utf-8"?>
+<p:notes xmlns:a="http://schemas.openxmlformats.org/drawingml/2006/main" xmlns:r="http://schemas.openxmlformats.org/officeDocument/2006/relationships" xmlns:p="http://schemas.openxmlformats.org/presentationml/2006/main">
+  <p:cSld>
+    <p:spTree>
+      <p:nvGrpSpPr>
+        <p:cNvPr id="1" name=""/>
+        <p:cNvGrpSpPr/>
+        <p:nvPr/>
+      </p:nvGrpSpPr>
+      <p:grpSpPr>
+        <a:xfrm>
+          <a:off x="0" y="0"/>
+          <a:ext cx="0" cy="0"/>
+          <a:chOff x="0" y="0"/>
+          <a:chExt cx="0" cy="0"/>
+        </a:xfrm>
+      </p:grpSpPr>
+      <p:sp>
+        <p:nvSpPr>
+          <p:cNvPr id="2" name="Folienbildplatzhalter 1"/>
+          <p:cNvSpPr>
+            <a:spLocks noGrp="1" noRot="1" noChangeAspect="1"/>
+          </p:cNvSpPr>
+          <p:nvPr>
+            <p:ph type="sldImg"/>
+          </p:nvPr>
+        </p:nvSpPr>
+        <p:spPr/>
+      </p:sp>
+      <p:sp>
+        <p:nvSpPr>
+          <p:cNvPr id="3" name="Notizenplatzhalter 2"/>
+          <p:cNvSpPr>
+            <a:spLocks noGrp="1"/>
+          </p:cNvSpPr>
+          <p:nvPr>
+            <p:ph type="body" idx="1"/>
+          </p:nvPr>
+        </p:nvSpPr>
+        <p:spPr/>
+        <p:txBody>
+          <a:bodyPr/>
+          <a:lstStyle/>
+          <a:p>
+            <a:endParaRPr lang="de-DE" dirty="0"/>
+          </a:p>
+        </p:txBody>
+      </p:sp>
+      <p:sp>
+        <p:nvSpPr>
+          <p:cNvPr id="4" name="Foliennummernplatzhalter 3"/>
+          <p:cNvSpPr>
+            <a:spLocks noGrp="1"/>
+          </p:cNvSpPr>
+          <p:nvPr>
+            <p:ph type="sldNum" sz="quarter" idx="5"/>
+          </p:nvPr>
+        </p:nvSpPr>
+        <p:spPr/>
+        <p:txBody>
+          <a:bodyPr/>
+          <a:lstStyle/>
+          <a:p>
+            <a:fld id="{A89F7A99-4242-439B-9281-B79B11F83AA9}" type="slidenum">
+              <a:rPr lang="de-DE" smtClean="0"/>
+              <a:t>9</a:t>
             </a:fld>
             <a:endParaRPr lang="de-DE"/>
           </a:p>
@@ -3976,7 +4061,7 @@
           <a:p>
             <a:fld id="{0DDF7243-AACD-40BA-BA1A-14CD6D7CD372}" type="datetimeFigureOut">
               <a:rPr lang="en-GB" smtClean="0"/>
-              <a:t>28/11/2025</a:t>
+              <a:t>28/12/2025</a:t>
             </a:fld>
             <a:endParaRPr lang="en-GB"/>
           </a:p>
@@ -4176,7 +4261,7 @@
           <a:p>
             <a:fld id="{0DDF7243-AACD-40BA-BA1A-14CD6D7CD372}" type="datetimeFigureOut">
               <a:rPr lang="en-GB" smtClean="0"/>
-              <a:t>28/11/2025</a:t>
+              <a:t>28/12/2025</a:t>
             </a:fld>
             <a:endParaRPr lang="en-GB"/>
           </a:p>
@@ -4386,7 +4471,7 @@
           <a:p>
             <a:fld id="{0DDF7243-AACD-40BA-BA1A-14CD6D7CD372}" type="datetimeFigureOut">
               <a:rPr lang="en-GB" smtClean="0"/>
-              <a:t>28/11/2025</a:t>
+              <a:t>28/12/2025</a:t>
             </a:fld>
             <a:endParaRPr lang="en-GB"/>
           </a:p>
@@ -4586,7 +4671,7 @@
           <a:p>
             <a:fld id="{0DDF7243-AACD-40BA-BA1A-14CD6D7CD372}" type="datetimeFigureOut">
               <a:rPr lang="en-GB" smtClean="0"/>
-              <a:t>28/11/2025</a:t>
+              <a:t>28/12/2025</a:t>
             </a:fld>
             <a:endParaRPr lang="en-GB"/>
           </a:p>
@@ -4862,7 +4947,7 @@
           <a:p>
             <a:fld id="{0DDF7243-AACD-40BA-BA1A-14CD6D7CD372}" type="datetimeFigureOut">
               <a:rPr lang="en-GB" smtClean="0"/>
-              <a:t>28/11/2025</a:t>
+              <a:t>28/12/2025</a:t>
             </a:fld>
             <a:endParaRPr lang="en-GB"/>
           </a:p>
@@ -5130,7 +5215,7 @@
           <a:p>
             <a:fld id="{0DDF7243-AACD-40BA-BA1A-14CD6D7CD372}" type="datetimeFigureOut">
               <a:rPr lang="en-GB" smtClean="0"/>
-              <a:t>28/11/2025</a:t>
+              <a:t>28/12/2025</a:t>
             </a:fld>
             <a:endParaRPr lang="en-GB"/>
           </a:p>
@@ -5545,7 +5630,7 @@
           <a:p>
             <a:fld id="{0DDF7243-AACD-40BA-BA1A-14CD6D7CD372}" type="datetimeFigureOut">
               <a:rPr lang="en-GB" smtClean="0"/>
-              <a:t>28/11/2025</a:t>
+              <a:t>28/12/2025</a:t>
             </a:fld>
             <a:endParaRPr lang="en-GB"/>
           </a:p>
@@ -5687,7 +5772,7 @@
           <a:p>
             <a:fld id="{0DDF7243-AACD-40BA-BA1A-14CD6D7CD372}" type="datetimeFigureOut">
               <a:rPr lang="en-GB" smtClean="0"/>
-              <a:t>28/11/2025</a:t>
+              <a:t>28/12/2025</a:t>
             </a:fld>
             <a:endParaRPr lang="en-GB"/>
           </a:p>
@@ -5800,7 +5885,7 @@
           <a:p>
             <a:fld id="{0DDF7243-AACD-40BA-BA1A-14CD6D7CD372}" type="datetimeFigureOut">
               <a:rPr lang="en-GB" smtClean="0"/>
-              <a:t>28/11/2025</a:t>
+              <a:t>28/12/2025</a:t>
             </a:fld>
             <a:endParaRPr lang="en-GB"/>
           </a:p>
@@ -6113,7 +6198,7 @@
           <a:p>
             <a:fld id="{0DDF7243-AACD-40BA-BA1A-14CD6D7CD372}" type="datetimeFigureOut">
               <a:rPr lang="en-GB" smtClean="0"/>
-              <a:t>28/11/2025</a:t>
+              <a:t>28/12/2025</a:t>
             </a:fld>
             <a:endParaRPr lang="en-GB"/>
           </a:p>
@@ -6402,7 +6487,7 @@
           <a:p>
             <a:fld id="{0DDF7243-AACD-40BA-BA1A-14CD6D7CD372}" type="datetimeFigureOut">
               <a:rPr lang="en-GB" smtClean="0"/>
-              <a:t>28/11/2025</a:t>
+              <a:t>28/12/2025</a:t>
             </a:fld>
             <a:endParaRPr lang="en-GB"/>
           </a:p>
@@ -6717,7 +6802,7 @@
           <a:p>
             <a:fld id="{0DDF7243-AACD-40BA-BA1A-14CD6D7CD372}" type="datetimeFigureOut">
               <a:rPr lang="en-GB" smtClean="0"/>
-              <a:t>28/11/2025</a:t>
+              <a:t>28/12/2025</a:t>
             </a:fld>
             <a:endParaRPr lang="en-GB"/>
           </a:p>
@@ -7118,6 +7203,4546 @@
 </file>
 
 <file path=ppt/slides/slide1.xml><?xml version="1.0" encoding="utf-8"?>
+<p:sld xmlns:a="http://schemas.openxmlformats.org/drawingml/2006/main" xmlns:r="http://schemas.openxmlformats.org/officeDocument/2006/relationships" xmlns:p="http://schemas.openxmlformats.org/presentationml/2006/main">
+  <p:cSld>
+    <p:spTree>
+      <p:nvGrpSpPr>
+        <p:cNvPr id="1" name=""/>
+        <p:cNvGrpSpPr/>
+        <p:nvPr/>
+      </p:nvGrpSpPr>
+      <p:grpSpPr>
+        <a:xfrm>
+          <a:off x="0" y="0"/>
+          <a:ext cx="0" cy="0"/>
+          <a:chOff x="0" y="0"/>
+          <a:chExt cx="0" cy="0"/>
+        </a:xfrm>
+      </p:grpSpPr>
+      <p:graphicFrame>
+        <p:nvGraphicFramePr>
+          <p:cNvPr id="4" name="think-cell data - do not delete" hidden="1">
+            <a:extLst>
+              <a:ext uri="{FF2B5EF4-FFF2-40B4-BE49-F238E27FC236}">
+                <a16:creationId xmlns:a16="http://schemas.microsoft.com/office/drawing/2014/main" id="{4BAC62AA-97C4-E4D0-224F-DE49B6347163}"/>
+              </a:ext>
+            </a:extLst>
+          </p:cNvPr>
+          <p:cNvGraphicFramePr>
+            <a:graphicFrameLocks noChangeAspect="1"/>
+          </p:cNvGraphicFramePr>
+          <p:nvPr>
+            <p:custDataLst>
+              <p:tags r:id="rId1"/>
+            </p:custDataLst>
+          </p:nvPr>
+        </p:nvGraphicFramePr>
+        <p:xfrm>
+          <a:off x="1588" y="1588"/>
+          <a:ext cx="1588" cy="1588"/>
+        </p:xfrm>
+        <a:graphic>
+          <a:graphicData uri="http://schemas.openxmlformats.org/presentationml/2006/ole">
+            <mc:AlternateContent xmlns:mc="http://schemas.openxmlformats.org/markup-compatibility/2006">
+              <mc:Choice xmlns:v="urn:schemas-microsoft-com:vml" Requires="v">
+                <p:oleObj name="think-cell Folie" r:id="rId4" imgW="523" imgH="514" progId="TCLayout.ActiveDocument.1">
+                  <p:embed/>
+                </p:oleObj>
+              </mc:Choice>
+              <mc:Fallback>
+                <p:oleObj name="think-cell Folie" r:id="rId4" imgW="523" imgH="514" progId="TCLayout.ActiveDocument.1">
+                  <p:embed/>
+                  <p:pic>
+                    <p:nvPicPr>
+                      <p:cNvPr id="4" name="think-cell data - do not delete" hidden="1">
+                        <a:extLst>
+                          <a:ext uri="{FF2B5EF4-FFF2-40B4-BE49-F238E27FC236}">
+                            <a16:creationId xmlns:a16="http://schemas.microsoft.com/office/drawing/2014/main" id="{4BAC62AA-97C4-E4D0-224F-DE49B6347163}"/>
+                          </a:ext>
+                        </a:extLst>
+                      </p:cNvPr>
+                      <p:cNvPicPr/>
+                      <p:nvPr/>
+                    </p:nvPicPr>
+                    <p:blipFill>
+                      <a:blip r:embed="rId5"/>
+                      <a:stretch>
+                        <a:fillRect/>
+                      </a:stretch>
+                    </p:blipFill>
+                    <p:spPr>
+                      <a:xfrm>
+                        <a:off x="1588" y="1588"/>
+                        <a:ext cx="1588" cy="1588"/>
+                      </a:xfrm>
+                      <a:prstGeom prst="rect">
+                        <a:avLst/>
+                      </a:prstGeom>
+                    </p:spPr>
+                  </p:pic>
+                </p:oleObj>
+              </mc:Fallback>
+            </mc:AlternateContent>
+          </a:graphicData>
+        </a:graphic>
+      </p:graphicFrame>
+      <p:pic>
+        <p:nvPicPr>
+          <p:cNvPr id="6" name="Grafik 5">
+            <a:extLst>
+              <a:ext uri="{FF2B5EF4-FFF2-40B4-BE49-F238E27FC236}">
+                <a16:creationId xmlns:a16="http://schemas.microsoft.com/office/drawing/2014/main" id="{1F8250AD-6338-F129-16DF-0339FC7BBF42}"/>
+              </a:ext>
+            </a:extLst>
+          </p:cNvPr>
+          <p:cNvPicPr>
+            <a:picLocks noChangeAspect="1"/>
+          </p:cNvPicPr>
+          <p:nvPr/>
+        </p:nvPicPr>
+        <p:blipFill>
+          <a:blip r:embed="rId6"/>
+          <a:stretch>
+            <a:fillRect/>
+          </a:stretch>
+        </p:blipFill>
+        <p:spPr>
+          <a:xfrm>
+            <a:off x="408666" y="1122630"/>
+            <a:ext cx="640203" cy="678361"/>
+          </a:xfrm>
+          <a:prstGeom prst="rect">
+            <a:avLst/>
+          </a:prstGeom>
+        </p:spPr>
+      </p:pic>
+      <p:sp>
+        <p:nvSpPr>
+          <p:cNvPr id="8" name="Rechteck 7">
+            <a:extLst>
+              <a:ext uri="{FF2B5EF4-FFF2-40B4-BE49-F238E27FC236}">
+                <a16:creationId xmlns:a16="http://schemas.microsoft.com/office/drawing/2014/main" id="{12B7CDF3-F4FF-B04D-0D33-DACB53C6FB1E}"/>
+              </a:ext>
+            </a:extLst>
+          </p:cNvPr>
+          <p:cNvSpPr/>
+          <p:nvPr/>
+        </p:nvSpPr>
+        <p:spPr>
+          <a:xfrm>
+            <a:off x="220157" y="1800991"/>
+            <a:ext cx="1017219" cy="1813066"/>
+          </a:xfrm>
+          <a:prstGeom prst="rect">
+            <a:avLst/>
+          </a:prstGeom>
+        </p:spPr>
+        <p:style>
+          <a:lnRef idx="2">
+            <a:schemeClr val="accent1">
+              <a:shade val="15000"/>
+            </a:schemeClr>
+          </a:lnRef>
+          <a:fillRef idx="1">
+            <a:schemeClr val="accent1"/>
+          </a:fillRef>
+          <a:effectRef idx="0">
+            <a:schemeClr val="accent1"/>
+          </a:effectRef>
+          <a:fontRef idx="minor">
+            <a:schemeClr val="lt1"/>
+          </a:fontRef>
+        </p:style>
+        <p:txBody>
+          <a:bodyPr rtlCol="0" anchor="t"/>
+          <a:lstStyle/>
+          <a:p>
+            <a:pPr algn="ctr"/>
+            <a:r>
+              <a:rPr lang="de-DE" dirty="0"/>
+              <a:t>MWDI</a:t>
+            </a:r>
+          </a:p>
+        </p:txBody>
+      </p:sp>
+      <p:pic>
+        <p:nvPicPr>
+          <p:cNvPr id="12" name="Grafik 11">
+            <a:extLst>
+              <a:ext uri="{FF2B5EF4-FFF2-40B4-BE49-F238E27FC236}">
+                <a16:creationId xmlns:a16="http://schemas.microsoft.com/office/drawing/2014/main" id="{F09424E2-6E76-4559-C09C-DD894196F902}"/>
+              </a:ext>
+            </a:extLst>
+          </p:cNvPr>
+          <p:cNvPicPr>
+            <a:picLocks noChangeAspect="1"/>
+          </p:cNvPicPr>
+          <p:nvPr/>
+        </p:nvPicPr>
+        <p:blipFill>
+          <a:blip r:embed="rId7"/>
+          <a:stretch>
+            <a:fillRect/>
+          </a:stretch>
+        </p:blipFill>
+        <p:spPr>
+          <a:xfrm>
+            <a:off x="318133" y="2126886"/>
+            <a:ext cx="828712" cy="516726"/>
+          </a:xfrm>
+          <a:prstGeom prst="rect">
+            <a:avLst/>
+          </a:prstGeom>
+        </p:spPr>
+      </p:pic>
+      <p:grpSp>
+        <p:nvGrpSpPr>
+          <p:cNvPr id="58" name="Gruppieren 57">
+            <a:extLst>
+              <a:ext uri="{FF2B5EF4-FFF2-40B4-BE49-F238E27FC236}">
+                <a16:creationId xmlns:a16="http://schemas.microsoft.com/office/drawing/2014/main" id="{1005F076-1CA8-DBC0-3E19-EB204FC8D409}"/>
+              </a:ext>
+            </a:extLst>
+          </p:cNvPr>
+          <p:cNvGrpSpPr/>
+          <p:nvPr/>
+        </p:nvGrpSpPr>
+        <p:grpSpPr>
+          <a:xfrm>
+            <a:off x="487631" y="4834806"/>
+            <a:ext cx="686327" cy="443000"/>
+            <a:chOff x="192731" y="2614049"/>
+            <a:chExt cx="686327" cy="443000"/>
+          </a:xfrm>
+        </p:grpSpPr>
+        <p:pic>
+          <p:nvPicPr>
+            <p:cNvPr id="44" name="Grafik 43">
+              <a:extLst>
+                <a:ext uri="{FF2B5EF4-FFF2-40B4-BE49-F238E27FC236}">
+                  <a16:creationId xmlns:a16="http://schemas.microsoft.com/office/drawing/2014/main" id="{0B14513B-4C28-6A89-DD10-38D370238127}"/>
+                </a:ext>
+              </a:extLst>
+            </p:cNvPr>
+            <p:cNvPicPr>
+              <a:picLocks noChangeAspect="1"/>
+            </p:cNvPicPr>
+            <p:nvPr/>
+          </p:nvPicPr>
+          <p:blipFill>
+            <a:blip r:embed="rId8"/>
+            <a:stretch>
+              <a:fillRect/>
+            </a:stretch>
+          </p:blipFill>
+          <p:spPr>
+            <a:xfrm>
+              <a:off x="680139" y="2704922"/>
+              <a:ext cx="198919" cy="195335"/>
+            </a:xfrm>
+            <a:prstGeom prst="rect">
+              <a:avLst/>
+            </a:prstGeom>
+          </p:spPr>
+        </p:pic>
+        <p:pic>
+          <p:nvPicPr>
+            <p:cNvPr id="19" name="Grafik 18">
+              <a:extLst>
+                <a:ext uri="{FF2B5EF4-FFF2-40B4-BE49-F238E27FC236}">
+                  <a16:creationId xmlns:a16="http://schemas.microsoft.com/office/drawing/2014/main" id="{65AF4849-1A8F-C8A3-1D42-CBE4FFFAD2BE}"/>
+                </a:ext>
+              </a:extLst>
+            </p:cNvPr>
+            <p:cNvPicPr>
+              <a:picLocks noChangeAspect="1"/>
+            </p:cNvPicPr>
+            <p:nvPr/>
+          </p:nvPicPr>
+          <p:blipFill>
+            <a:blip r:embed="rId9"/>
+            <a:stretch>
+              <a:fillRect/>
+            </a:stretch>
+          </p:blipFill>
+          <p:spPr>
+            <a:xfrm>
+              <a:off x="192731" y="2614049"/>
+              <a:ext cx="511431" cy="443000"/>
+            </a:xfrm>
+            <a:prstGeom prst="rect">
+              <a:avLst/>
+            </a:prstGeom>
+          </p:spPr>
+        </p:pic>
+      </p:grpSp>
+      <p:pic>
+        <p:nvPicPr>
+          <p:cNvPr id="33" name="Grafik 32">
+            <a:extLst>
+              <a:ext uri="{FF2B5EF4-FFF2-40B4-BE49-F238E27FC236}">
+                <a16:creationId xmlns:a16="http://schemas.microsoft.com/office/drawing/2014/main" id="{C9E9494A-3014-F7AB-1FE7-EFA213CD49CC}"/>
+              </a:ext>
+            </a:extLst>
+          </p:cNvPr>
+          <p:cNvPicPr>
+            <a:picLocks noChangeAspect="1"/>
+          </p:cNvPicPr>
+          <p:nvPr/>
+        </p:nvPicPr>
+        <p:blipFill>
+          <a:blip r:embed="rId10"/>
+          <a:stretch>
+            <a:fillRect/>
+          </a:stretch>
+        </p:blipFill>
+        <p:spPr>
+          <a:xfrm>
+            <a:off x="1308541" y="4549027"/>
+            <a:ext cx="1472709" cy="819223"/>
+          </a:xfrm>
+          <a:prstGeom prst="rect">
+            <a:avLst/>
+          </a:prstGeom>
+        </p:spPr>
+      </p:pic>
+      <p:pic>
+        <p:nvPicPr>
+          <p:cNvPr id="34" name="Grafik 33">
+            <a:extLst>
+              <a:ext uri="{FF2B5EF4-FFF2-40B4-BE49-F238E27FC236}">
+                <a16:creationId xmlns:a16="http://schemas.microsoft.com/office/drawing/2014/main" id="{DFD04A5C-A058-78C3-22EF-2E64A96FFC20}"/>
+              </a:ext>
+            </a:extLst>
+          </p:cNvPr>
+          <p:cNvPicPr>
+            <a:picLocks noChangeAspect="1"/>
+          </p:cNvPicPr>
+          <p:nvPr/>
+        </p:nvPicPr>
+        <p:blipFill>
+          <a:blip r:embed="rId9"/>
+          <a:stretch>
+            <a:fillRect/>
+          </a:stretch>
+        </p:blipFill>
+        <p:spPr>
+          <a:xfrm>
+            <a:off x="3555397" y="2384014"/>
+            <a:ext cx="511431" cy="443000"/>
+          </a:xfrm>
+          <a:prstGeom prst="rect">
+            <a:avLst/>
+          </a:prstGeom>
+        </p:spPr>
+      </p:pic>
+      <p:sp>
+        <p:nvSpPr>
+          <p:cNvPr id="40" name="Textfeld 39">
+            <a:extLst>
+              <a:ext uri="{FF2B5EF4-FFF2-40B4-BE49-F238E27FC236}">
+                <a16:creationId xmlns:a16="http://schemas.microsoft.com/office/drawing/2014/main" id="{8907AD76-EC29-B97E-46FA-A65E1765852B}"/>
+              </a:ext>
+            </a:extLst>
+          </p:cNvPr>
+          <p:cNvSpPr txBox="1"/>
+          <p:nvPr/>
+        </p:nvSpPr>
+        <p:spPr>
+          <a:xfrm>
+            <a:off x="1128358" y="5437540"/>
+            <a:ext cx="1677062" cy="584775"/>
+          </a:xfrm>
+          <a:prstGeom prst="rect">
+            <a:avLst/>
+          </a:prstGeom>
+          <a:noFill/>
+        </p:spPr>
+        <p:txBody>
+          <a:bodyPr wrap="none" rtlCol="0">
+            <a:spAutoFit/>
+          </a:bodyPr>
+          <a:lstStyle/>
+          <a:p>
+            <a:r>
+              <a:rPr lang="en-US" sz="800" noProof="0" dirty="0"/>
+              <a:t>Pre-Processing</a:t>
+            </a:r>
+          </a:p>
+          <a:p>
+            <a:r>
+              <a:rPr lang="en-US" sz="800" noProof="0" dirty="0"/>
+              <a:t>- </a:t>
+            </a:r>
+            <a:r>
+              <a:rPr lang="de-DE" sz="800" dirty="0"/>
+              <a:t>p1LoadRawCc</a:t>
+            </a:r>
+            <a:endParaRPr lang="en-US" sz="800" dirty="0"/>
+          </a:p>
+          <a:p>
+            <a:r>
+              <a:rPr lang="en-US" sz="800" noProof="0" dirty="0"/>
+              <a:t>  - p1FieldsFilter</a:t>
+            </a:r>
+          </a:p>
+          <a:p>
+            <a:r>
+              <a:rPr lang="en-US" sz="800" dirty="0"/>
+              <a:t>  - p1DiscardIrrelevantPmRecords</a:t>
+            </a:r>
+            <a:endParaRPr lang="en-US" sz="800" noProof="0" dirty="0"/>
+          </a:p>
+        </p:txBody>
+      </p:sp>
+      <p:pic>
+        <p:nvPicPr>
+          <p:cNvPr id="43" name="Grafik 42">
+            <a:extLst>
+              <a:ext uri="{FF2B5EF4-FFF2-40B4-BE49-F238E27FC236}">
+                <a16:creationId xmlns:a16="http://schemas.microsoft.com/office/drawing/2014/main" id="{32482BBE-ECD5-041D-3EA3-8D09CFA32C3B}"/>
+              </a:ext>
+            </a:extLst>
+          </p:cNvPr>
+          <p:cNvPicPr>
+            <a:picLocks noChangeAspect="1"/>
+          </p:cNvPicPr>
+          <p:nvPr/>
+        </p:nvPicPr>
+        <p:blipFill>
+          <a:blip r:embed="rId8"/>
+          <a:stretch>
+            <a:fillRect/>
+          </a:stretch>
+        </p:blipFill>
+        <p:spPr>
+          <a:xfrm>
+            <a:off x="4047809" y="2507846"/>
+            <a:ext cx="198919" cy="195335"/>
+          </a:xfrm>
+          <a:prstGeom prst="rect">
+            <a:avLst/>
+          </a:prstGeom>
+        </p:spPr>
+      </p:pic>
+      <p:pic>
+        <p:nvPicPr>
+          <p:cNvPr id="36" name="Grafik 35">
+            <a:extLst>
+              <a:ext uri="{FF2B5EF4-FFF2-40B4-BE49-F238E27FC236}">
+                <a16:creationId xmlns:a16="http://schemas.microsoft.com/office/drawing/2014/main" id="{E5BBA2EA-CF61-0A77-8808-E0A28893892D}"/>
+              </a:ext>
+            </a:extLst>
+          </p:cNvPr>
+          <p:cNvPicPr>
+            <a:picLocks noChangeAspect="1"/>
+          </p:cNvPicPr>
+          <p:nvPr/>
+        </p:nvPicPr>
+        <p:blipFill>
+          <a:blip r:embed="rId9"/>
+          <a:stretch>
+            <a:fillRect/>
+          </a:stretch>
+        </p:blipFill>
+        <p:spPr>
+          <a:xfrm>
+            <a:off x="2950326" y="4834806"/>
+            <a:ext cx="511431" cy="443000"/>
+          </a:xfrm>
+          <a:prstGeom prst="rect">
+            <a:avLst/>
+          </a:prstGeom>
+        </p:spPr>
+      </p:pic>
+      <p:pic>
+        <p:nvPicPr>
+          <p:cNvPr id="39" name="Grafik 38">
+            <a:extLst>
+              <a:ext uri="{FF2B5EF4-FFF2-40B4-BE49-F238E27FC236}">
+                <a16:creationId xmlns:a16="http://schemas.microsoft.com/office/drawing/2014/main" id="{34655857-CA98-8D54-CB61-37BD04B45DFE}"/>
+              </a:ext>
+            </a:extLst>
+          </p:cNvPr>
+          <p:cNvPicPr>
+            <a:picLocks noChangeAspect="1"/>
+          </p:cNvPicPr>
+          <p:nvPr/>
+        </p:nvPicPr>
+        <p:blipFill>
+          <a:blip r:embed="rId11"/>
+          <a:stretch>
+            <a:fillRect/>
+          </a:stretch>
+        </p:blipFill>
+        <p:spPr>
+          <a:xfrm>
+            <a:off x="3288108" y="4887563"/>
+            <a:ext cx="149626" cy="149626"/>
+          </a:xfrm>
+          <a:prstGeom prst="rect">
+            <a:avLst/>
+          </a:prstGeom>
+        </p:spPr>
+      </p:pic>
+      <p:pic>
+        <p:nvPicPr>
+          <p:cNvPr id="45" name="Grafik 44">
+            <a:extLst>
+              <a:ext uri="{FF2B5EF4-FFF2-40B4-BE49-F238E27FC236}">
+                <a16:creationId xmlns:a16="http://schemas.microsoft.com/office/drawing/2014/main" id="{863BCEB8-8D1C-3113-A3F9-BED90C7EFA7C}"/>
+              </a:ext>
+            </a:extLst>
+          </p:cNvPr>
+          <p:cNvPicPr>
+            <a:picLocks noChangeAspect="1"/>
+          </p:cNvPicPr>
+          <p:nvPr/>
+        </p:nvPicPr>
+        <p:blipFill>
+          <a:blip r:embed="rId8"/>
+          <a:stretch>
+            <a:fillRect/>
+          </a:stretch>
+        </p:blipFill>
+        <p:spPr>
+          <a:xfrm>
+            <a:off x="3437734" y="4925679"/>
+            <a:ext cx="198919" cy="195335"/>
+          </a:xfrm>
+          <a:prstGeom prst="rect">
+            <a:avLst/>
+          </a:prstGeom>
+        </p:spPr>
+      </p:pic>
+      <p:grpSp>
+        <p:nvGrpSpPr>
+          <p:cNvPr id="56" name="Gruppieren 55">
+            <a:extLst>
+              <a:ext uri="{FF2B5EF4-FFF2-40B4-BE49-F238E27FC236}">
+                <a16:creationId xmlns:a16="http://schemas.microsoft.com/office/drawing/2014/main" id="{E1E805A9-BC69-DCB7-FD54-165D9C2D39AB}"/>
+              </a:ext>
+            </a:extLst>
+          </p:cNvPr>
+          <p:cNvGrpSpPr/>
+          <p:nvPr/>
+        </p:nvGrpSpPr>
+        <p:grpSpPr>
+          <a:xfrm rot="559622">
+            <a:off x="3062453" y="4647154"/>
+            <a:ext cx="418250" cy="147871"/>
+            <a:chOff x="3664801" y="2485737"/>
+            <a:chExt cx="418250" cy="147871"/>
+          </a:xfrm>
+        </p:grpSpPr>
+        <p:sp>
+          <p:nvSpPr>
+            <p:cNvPr id="55" name="Rechteck 54">
+              <a:extLst>
+                <a:ext uri="{FF2B5EF4-FFF2-40B4-BE49-F238E27FC236}">
+                  <a16:creationId xmlns:a16="http://schemas.microsoft.com/office/drawing/2014/main" id="{E2B0FB8C-CFBE-3CF2-DF58-87A9B70307E4}"/>
+                </a:ext>
+              </a:extLst>
+            </p:cNvPr>
+            <p:cNvSpPr/>
+            <p:nvPr/>
+          </p:nvSpPr>
+          <p:spPr>
+            <a:xfrm>
+              <a:off x="3664801" y="2485737"/>
+              <a:ext cx="418250" cy="147871"/>
+            </a:xfrm>
+            <a:prstGeom prst="rect">
+              <a:avLst/>
+            </a:prstGeom>
+            <a:ln w="12700"/>
+          </p:spPr>
+          <p:style>
+            <a:lnRef idx="2">
+              <a:schemeClr val="dk1"/>
+            </a:lnRef>
+            <a:fillRef idx="1">
+              <a:schemeClr val="lt1"/>
+            </a:fillRef>
+            <a:effectRef idx="0">
+              <a:schemeClr val="dk1"/>
+            </a:effectRef>
+            <a:fontRef idx="minor">
+              <a:schemeClr val="dk1"/>
+            </a:fontRef>
+          </p:style>
+          <p:txBody>
+            <a:bodyPr rtlCol="0" anchor="ctr"/>
+            <a:lstStyle/>
+            <a:p>
+              <a:pPr algn="ctr"/>
+              <a:endParaRPr lang="de-DE"/>
+            </a:p>
+          </p:txBody>
+        </p:sp>
+        <p:grpSp>
+          <p:nvGrpSpPr>
+            <p:cNvPr id="52" name="Gruppieren 51">
+              <a:extLst>
+                <a:ext uri="{FF2B5EF4-FFF2-40B4-BE49-F238E27FC236}">
+                  <a16:creationId xmlns:a16="http://schemas.microsoft.com/office/drawing/2014/main" id="{0D04E791-E34D-90D4-BD3F-3E52106B6D37}"/>
+                </a:ext>
+              </a:extLst>
+            </p:cNvPr>
+            <p:cNvGrpSpPr>
+              <a:grpSpLocks noChangeAspect="1"/>
+            </p:cNvGrpSpPr>
+            <p:nvPr/>
+          </p:nvGrpSpPr>
+          <p:grpSpPr>
+            <a:xfrm>
+              <a:off x="3677500" y="2507962"/>
+              <a:ext cx="384335" cy="106087"/>
+              <a:chOff x="5533092" y="3218340"/>
+              <a:chExt cx="1789608" cy="493977"/>
+            </a:xfrm>
+          </p:grpSpPr>
+          <p:pic>
+            <p:nvPicPr>
+              <p:cNvPr id="47" name="Grafik 46">
+                <a:extLst>
+                  <a:ext uri="{FF2B5EF4-FFF2-40B4-BE49-F238E27FC236}">
+                    <a16:creationId xmlns:a16="http://schemas.microsoft.com/office/drawing/2014/main" id="{AD930E0F-7A80-E3DA-61D5-E1C2FDC75CB9}"/>
+                  </a:ext>
+                </a:extLst>
+              </p:cNvPr>
+              <p:cNvPicPr>
+                <a:picLocks noChangeAspect="1"/>
+              </p:cNvPicPr>
+              <p:nvPr/>
+            </p:nvPicPr>
+            <p:blipFill>
+              <a:blip r:embed="rId12"/>
+              <a:stretch>
+                <a:fillRect/>
+              </a:stretch>
+            </p:blipFill>
+            <p:spPr>
+              <a:xfrm>
+                <a:off x="5533092" y="3218340"/>
+                <a:ext cx="728718" cy="468462"/>
+              </a:xfrm>
+              <a:prstGeom prst="rect">
+                <a:avLst/>
+              </a:prstGeom>
+            </p:spPr>
+          </p:pic>
+          <p:pic>
+            <p:nvPicPr>
+              <p:cNvPr id="49" name="Grafik 48">
+                <a:extLst>
+                  <a:ext uri="{FF2B5EF4-FFF2-40B4-BE49-F238E27FC236}">
+                    <a16:creationId xmlns:a16="http://schemas.microsoft.com/office/drawing/2014/main" id="{B5A154C8-2E67-F855-7F61-6BC88CB9F995}"/>
+                  </a:ext>
+                </a:extLst>
+              </p:cNvPr>
+              <p:cNvPicPr>
+                <a:picLocks noChangeAspect="1"/>
+              </p:cNvPicPr>
+              <p:nvPr/>
+            </p:nvPicPr>
+            <p:blipFill>
+              <a:blip r:embed="rId13"/>
+              <a:stretch>
+                <a:fillRect/>
+              </a:stretch>
+            </p:blipFill>
+            <p:spPr>
+              <a:xfrm>
+                <a:off x="6261810" y="3226943"/>
+                <a:ext cx="485889" cy="459859"/>
+              </a:xfrm>
+              <a:prstGeom prst="rect">
+                <a:avLst/>
+              </a:prstGeom>
+            </p:spPr>
+          </p:pic>
+          <p:pic>
+            <p:nvPicPr>
+              <p:cNvPr id="51" name="Grafik 50">
+                <a:extLst>
+                  <a:ext uri="{FF2B5EF4-FFF2-40B4-BE49-F238E27FC236}">
+                    <a16:creationId xmlns:a16="http://schemas.microsoft.com/office/drawing/2014/main" id="{23B98640-4E4A-8C2E-BFDB-C4CB5CA2CBF3}"/>
+                  </a:ext>
+                </a:extLst>
+              </p:cNvPr>
+              <p:cNvPicPr>
+                <a:picLocks noChangeAspect="1"/>
+              </p:cNvPicPr>
+              <p:nvPr/>
+            </p:nvPicPr>
+            <p:blipFill>
+              <a:blip r:embed="rId14"/>
+              <a:stretch>
+                <a:fillRect/>
+              </a:stretch>
+            </p:blipFill>
+            <p:spPr>
+              <a:xfrm>
+                <a:off x="6789226" y="3269433"/>
+                <a:ext cx="533474" cy="442884"/>
+              </a:xfrm>
+              <a:prstGeom prst="rect">
+                <a:avLst/>
+              </a:prstGeom>
+            </p:spPr>
+          </p:pic>
+        </p:grpSp>
+      </p:grpSp>
+      <p:cxnSp>
+        <p:nvCxnSpPr>
+          <p:cNvPr id="54" name="Gerader Verbinder 53">
+            <a:extLst>
+              <a:ext uri="{FF2B5EF4-FFF2-40B4-BE49-F238E27FC236}">
+                <a16:creationId xmlns:a16="http://schemas.microsoft.com/office/drawing/2014/main" id="{BE3847BB-2E30-97B2-FBE6-E057D35DD9E3}"/>
+              </a:ext>
+            </a:extLst>
+          </p:cNvPr>
+          <p:cNvCxnSpPr>
+            <a:cxnSpLocks/>
+          </p:cNvCxnSpPr>
+          <p:nvPr/>
+        </p:nvCxnSpPr>
+        <p:spPr>
+          <a:xfrm flipV="1">
+            <a:off x="3028457" y="4607374"/>
+            <a:ext cx="60654" cy="280189"/>
+          </a:xfrm>
+          <a:prstGeom prst="line">
+            <a:avLst/>
+          </a:prstGeom>
+          <a:ln w="12700"/>
+        </p:spPr>
+        <p:style>
+          <a:lnRef idx="2">
+            <a:schemeClr val="dk1"/>
+          </a:lnRef>
+          <a:fillRef idx="1">
+            <a:schemeClr val="lt1"/>
+          </a:fillRef>
+          <a:effectRef idx="0">
+            <a:schemeClr val="dk1"/>
+          </a:effectRef>
+          <a:fontRef idx="minor">
+            <a:schemeClr val="dk1"/>
+          </a:fontRef>
+        </p:style>
+      </p:cxnSp>
+      <p:grpSp>
+        <p:nvGrpSpPr>
+          <p:cNvPr id="121" name="Gruppieren 120">
+            <a:extLst>
+              <a:ext uri="{FF2B5EF4-FFF2-40B4-BE49-F238E27FC236}">
+                <a16:creationId xmlns:a16="http://schemas.microsoft.com/office/drawing/2014/main" id="{C52A8DF6-600F-088C-203C-D708DA02E922}"/>
+              </a:ext>
+            </a:extLst>
+          </p:cNvPr>
+          <p:cNvGrpSpPr/>
+          <p:nvPr/>
+        </p:nvGrpSpPr>
+        <p:grpSpPr>
+          <a:xfrm>
+            <a:off x="3948646" y="4293542"/>
+            <a:ext cx="1557712" cy="1143998"/>
+            <a:chOff x="3510182" y="2584141"/>
+            <a:chExt cx="2051083" cy="1424834"/>
+          </a:xfrm>
+        </p:grpSpPr>
+        <p:pic>
+          <p:nvPicPr>
+            <p:cNvPr id="65" name="Grafik 64">
+              <a:extLst>
+                <a:ext uri="{FF2B5EF4-FFF2-40B4-BE49-F238E27FC236}">
+                  <a16:creationId xmlns:a16="http://schemas.microsoft.com/office/drawing/2014/main" id="{F1E34E5E-4087-9CD1-7C1E-039481049A6B}"/>
+                </a:ext>
+              </a:extLst>
+            </p:cNvPr>
+            <p:cNvPicPr>
+              <a:picLocks noChangeAspect="1"/>
+            </p:cNvPicPr>
+            <p:nvPr/>
+          </p:nvPicPr>
+          <p:blipFill>
+            <a:blip r:embed="rId15"/>
+            <a:stretch>
+              <a:fillRect/>
+            </a:stretch>
+          </p:blipFill>
+          <p:spPr>
+            <a:xfrm>
+              <a:off x="3510182" y="3230530"/>
+              <a:ext cx="656074" cy="720000"/>
+            </a:xfrm>
+            <a:prstGeom prst="rect">
+              <a:avLst/>
+            </a:prstGeom>
+          </p:spPr>
+        </p:pic>
+        <p:pic>
+          <p:nvPicPr>
+            <p:cNvPr id="67" name="Grafik 66">
+              <a:extLst>
+                <a:ext uri="{FF2B5EF4-FFF2-40B4-BE49-F238E27FC236}">
+                  <a16:creationId xmlns:a16="http://schemas.microsoft.com/office/drawing/2014/main" id="{440851F6-C2D8-05F5-9869-FD80AF8E982A}"/>
+                </a:ext>
+              </a:extLst>
+            </p:cNvPr>
+            <p:cNvPicPr>
+              <a:picLocks noChangeAspect="1"/>
+            </p:cNvPicPr>
+            <p:nvPr/>
+          </p:nvPicPr>
+          <p:blipFill>
+            <a:blip r:embed="rId16"/>
+            <a:stretch>
+              <a:fillRect/>
+            </a:stretch>
+          </p:blipFill>
+          <p:spPr>
+            <a:xfrm>
+              <a:off x="3952390" y="2584141"/>
+              <a:ext cx="604930" cy="720000"/>
+            </a:xfrm>
+            <a:prstGeom prst="rect">
+              <a:avLst/>
+            </a:prstGeom>
+          </p:spPr>
+        </p:pic>
+        <p:pic>
+          <p:nvPicPr>
+            <p:cNvPr id="69" name="Grafik 68">
+              <a:extLst>
+                <a:ext uri="{FF2B5EF4-FFF2-40B4-BE49-F238E27FC236}">
+                  <a16:creationId xmlns:a16="http://schemas.microsoft.com/office/drawing/2014/main" id="{04A1A20E-194A-3EDA-493C-3833350F4802}"/>
+                </a:ext>
+              </a:extLst>
+            </p:cNvPr>
+            <p:cNvPicPr>
+              <a:picLocks noChangeAspect="1"/>
+            </p:cNvPicPr>
+            <p:nvPr/>
+          </p:nvPicPr>
+          <p:blipFill>
+            <a:blip r:embed="rId17"/>
+            <a:stretch>
+              <a:fillRect/>
+            </a:stretch>
+          </p:blipFill>
+          <p:spPr>
+            <a:xfrm>
+              <a:off x="4379737" y="3304141"/>
+              <a:ext cx="715847" cy="704834"/>
+            </a:xfrm>
+            <a:prstGeom prst="rect">
+              <a:avLst/>
+            </a:prstGeom>
+          </p:spPr>
+        </p:pic>
+        <p:pic>
+          <p:nvPicPr>
+            <p:cNvPr id="71" name="Grafik 70">
+              <a:extLst>
+                <a:ext uri="{FF2B5EF4-FFF2-40B4-BE49-F238E27FC236}">
+                  <a16:creationId xmlns:a16="http://schemas.microsoft.com/office/drawing/2014/main" id="{374B6FFA-25F7-07DA-FB97-03539B2E908A}"/>
+                </a:ext>
+              </a:extLst>
+            </p:cNvPr>
+            <p:cNvPicPr>
+              <a:picLocks noChangeAspect="1"/>
+            </p:cNvPicPr>
+            <p:nvPr/>
+          </p:nvPicPr>
+          <p:blipFill>
+            <a:blip r:embed="rId18"/>
+            <a:stretch>
+              <a:fillRect/>
+            </a:stretch>
+          </p:blipFill>
+          <p:spPr>
+            <a:xfrm>
+              <a:off x="4905437" y="2675081"/>
+              <a:ext cx="655828" cy="629060"/>
+            </a:xfrm>
+            <a:prstGeom prst="rect">
+              <a:avLst/>
+            </a:prstGeom>
+          </p:spPr>
+        </p:pic>
+      </p:grpSp>
+      <p:sp>
+        <p:nvSpPr>
+          <p:cNvPr id="72" name="Textfeld 71">
+            <a:extLst>
+              <a:ext uri="{FF2B5EF4-FFF2-40B4-BE49-F238E27FC236}">
+                <a16:creationId xmlns:a16="http://schemas.microsoft.com/office/drawing/2014/main" id="{605DB929-80E8-C77E-C3CF-BCF020AE488D}"/>
+              </a:ext>
+            </a:extLst>
+          </p:cNvPr>
+          <p:cNvSpPr txBox="1"/>
+          <p:nvPr/>
+        </p:nvSpPr>
+        <p:spPr>
+          <a:xfrm>
+            <a:off x="3862663" y="5480663"/>
+            <a:ext cx="1558440" cy="954107"/>
+          </a:xfrm>
+          <a:prstGeom prst="rect">
+            <a:avLst/>
+          </a:prstGeom>
+          <a:noFill/>
+        </p:spPr>
+        <p:txBody>
+          <a:bodyPr wrap="none" rtlCol="0">
+            <a:spAutoFit/>
+          </a:bodyPr>
+          <a:lstStyle/>
+          <a:p>
+            <a:r>
+              <a:rPr lang="en-US" sz="800" noProof="0" dirty="0"/>
+              <a:t>Processing</a:t>
+            </a:r>
+          </a:p>
+          <a:p>
+            <a:r>
+              <a:rPr lang="en-US" sz="800" noProof="0" dirty="0"/>
+              <a:t>- </a:t>
+            </a:r>
+            <a:r>
+              <a:rPr lang="en-US" sz="800" dirty="0"/>
+              <a:t>p1CreateResultCc</a:t>
+            </a:r>
+          </a:p>
+          <a:p>
+            <a:r>
+              <a:rPr lang="en-US" sz="800" dirty="0"/>
+              <a:t>  - p1PrepareTxModes</a:t>
+            </a:r>
+          </a:p>
+          <a:p>
+            <a:r>
+              <a:rPr lang="en-US" sz="800" dirty="0"/>
+              <a:t>  - p1CalculateAiCapacity</a:t>
+            </a:r>
+          </a:p>
+          <a:p>
+            <a:r>
+              <a:rPr lang="en-US" sz="800" dirty="0"/>
+              <a:t>  - p1CalculateIntervalCapacity</a:t>
+            </a:r>
+          </a:p>
+          <a:p>
+            <a:r>
+              <a:rPr lang="en-US" sz="800" dirty="0"/>
+              <a:t>  - p1CalculateEthernetKpis</a:t>
+            </a:r>
+          </a:p>
+          <a:p>
+            <a:r>
+              <a:rPr lang="en-US" sz="800" noProof="0" dirty="0"/>
+              <a:t>- p1FormattingOutputApt</a:t>
+            </a:r>
+          </a:p>
+        </p:txBody>
+      </p:sp>
+      <p:grpSp>
+        <p:nvGrpSpPr>
+          <p:cNvPr id="122" name="Gruppieren 121">
+            <a:extLst>
+              <a:ext uri="{FF2B5EF4-FFF2-40B4-BE49-F238E27FC236}">
+                <a16:creationId xmlns:a16="http://schemas.microsoft.com/office/drawing/2014/main" id="{8D5DDB59-4F49-AE33-08FC-B3451DA7F38B}"/>
+              </a:ext>
+            </a:extLst>
+          </p:cNvPr>
+          <p:cNvGrpSpPr/>
+          <p:nvPr/>
+        </p:nvGrpSpPr>
+        <p:grpSpPr>
+          <a:xfrm>
+            <a:off x="5707261" y="4591309"/>
+            <a:ext cx="686327" cy="701282"/>
+            <a:chOff x="6096000" y="2727718"/>
+            <a:chExt cx="686327" cy="701282"/>
+          </a:xfrm>
+        </p:grpSpPr>
+        <p:grpSp>
+          <p:nvGrpSpPr>
+            <p:cNvPr id="73" name="Gruppieren 72">
+              <a:extLst>
+                <a:ext uri="{FF2B5EF4-FFF2-40B4-BE49-F238E27FC236}">
+                  <a16:creationId xmlns:a16="http://schemas.microsoft.com/office/drawing/2014/main" id="{5E413AD2-0712-8B92-C7D3-05ABB5086781}"/>
+                </a:ext>
+              </a:extLst>
+            </p:cNvPr>
+            <p:cNvGrpSpPr/>
+            <p:nvPr/>
+          </p:nvGrpSpPr>
+          <p:grpSpPr>
+            <a:xfrm>
+              <a:off x="6096000" y="2758568"/>
+              <a:ext cx="686327" cy="670432"/>
+              <a:chOff x="2307218" y="2484284"/>
+              <a:chExt cx="686327" cy="670432"/>
+            </a:xfrm>
+          </p:grpSpPr>
+          <p:pic>
+            <p:nvPicPr>
+              <p:cNvPr id="74" name="Grafik 73">
+                <a:extLst>
+                  <a:ext uri="{FF2B5EF4-FFF2-40B4-BE49-F238E27FC236}">
+                    <a16:creationId xmlns:a16="http://schemas.microsoft.com/office/drawing/2014/main" id="{EA90B825-9B0C-6B86-D688-138A79F243F9}"/>
+                  </a:ext>
+                </a:extLst>
+              </p:cNvPr>
+              <p:cNvPicPr>
+                <a:picLocks noChangeAspect="1"/>
+              </p:cNvPicPr>
+              <p:nvPr/>
+            </p:nvPicPr>
+            <p:blipFill>
+              <a:blip r:embed="rId9"/>
+              <a:stretch>
+                <a:fillRect/>
+              </a:stretch>
+            </p:blipFill>
+            <p:spPr>
+              <a:xfrm>
+                <a:off x="2307218" y="2711716"/>
+                <a:ext cx="511431" cy="443000"/>
+              </a:xfrm>
+              <a:prstGeom prst="rect">
+                <a:avLst/>
+              </a:prstGeom>
+            </p:spPr>
+          </p:pic>
+          <p:pic>
+            <p:nvPicPr>
+              <p:cNvPr id="76" name="Grafik 75">
+                <a:extLst>
+                  <a:ext uri="{FF2B5EF4-FFF2-40B4-BE49-F238E27FC236}">
+                    <a16:creationId xmlns:a16="http://schemas.microsoft.com/office/drawing/2014/main" id="{C66CF0BF-D27E-9259-8680-E6F7811A095E}"/>
+                  </a:ext>
+                </a:extLst>
+              </p:cNvPr>
+              <p:cNvPicPr>
+                <a:picLocks noChangeAspect="1"/>
+              </p:cNvPicPr>
+              <p:nvPr/>
+            </p:nvPicPr>
+            <p:blipFill>
+              <a:blip r:embed="rId11"/>
+              <a:stretch>
+                <a:fillRect/>
+              </a:stretch>
+            </p:blipFill>
+            <p:spPr>
+              <a:xfrm>
+                <a:off x="2581145" y="2700618"/>
+                <a:ext cx="213481" cy="213481"/>
+              </a:xfrm>
+              <a:prstGeom prst="rect">
+                <a:avLst/>
+              </a:prstGeom>
+            </p:spPr>
+          </p:pic>
+          <p:pic>
+            <p:nvPicPr>
+              <p:cNvPr id="77" name="Grafik 76">
+                <a:extLst>
+                  <a:ext uri="{FF2B5EF4-FFF2-40B4-BE49-F238E27FC236}">
+                    <a16:creationId xmlns:a16="http://schemas.microsoft.com/office/drawing/2014/main" id="{BB763704-2444-5612-D631-50559F3AF11A}"/>
+                  </a:ext>
+                </a:extLst>
+              </p:cNvPr>
+              <p:cNvPicPr>
+                <a:picLocks noChangeAspect="1"/>
+              </p:cNvPicPr>
+              <p:nvPr/>
+            </p:nvPicPr>
+            <p:blipFill>
+              <a:blip r:embed="rId8"/>
+              <a:stretch>
+                <a:fillRect/>
+              </a:stretch>
+            </p:blipFill>
+            <p:spPr>
+              <a:xfrm>
+                <a:off x="2794626" y="2802589"/>
+                <a:ext cx="198919" cy="195335"/>
+              </a:xfrm>
+              <a:prstGeom prst="rect">
+                <a:avLst/>
+              </a:prstGeom>
+            </p:spPr>
+          </p:pic>
+          <p:grpSp>
+            <p:nvGrpSpPr>
+              <p:cNvPr id="78" name="Gruppieren 77">
+                <a:extLst>
+                  <a:ext uri="{FF2B5EF4-FFF2-40B4-BE49-F238E27FC236}">
+                    <a16:creationId xmlns:a16="http://schemas.microsoft.com/office/drawing/2014/main" id="{4D66D110-3EE0-D205-BAB2-B71385695066}"/>
+                  </a:ext>
+                </a:extLst>
+              </p:cNvPr>
+              <p:cNvGrpSpPr/>
+              <p:nvPr/>
+            </p:nvGrpSpPr>
+            <p:grpSpPr>
+              <a:xfrm rot="559622">
+                <a:off x="2419345" y="2524064"/>
+                <a:ext cx="418250" cy="147871"/>
+                <a:chOff x="3664801" y="2485737"/>
+                <a:chExt cx="418250" cy="147871"/>
+              </a:xfrm>
+            </p:grpSpPr>
+            <p:sp>
+              <p:nvSpPr>
+                <p:cNvPr id="80" name="Rechteck 79">
+                  <a:extLst>
+                    <a:ext uri="{FF2B5EF4-FFF2-40B4-BE49-F238E27FC236}">
+                      <a16:creationId xmlns:a16="http://schemas.microsoft.com/office/drawing/2014/main" id="{603795F0-4EF4-4A9C-044B-BDF3AC37735A}"/>
+                    </a:ext>
+                  </a:extLst>
+                </p:cNvPr>
+                <p:cNvSpPr/>
+                <p:nvPr/>
+              </p:nvSpPr>
+              <p:spPr>
+                <a:xfrm>
+                  <a:off x="3664801" y="2485737"/>
+                  <a:ext cx="418250" cy="147871"/>
+                </a:xfrm>
+                <a:prstGeom prst="rect">
+                  <a:avLst/>
+                </a:prstGeom>
+                <a:ln w="12700"/>
+              </p:spPr>
+              <p:style>
+                <a:lnRef idx="2">
+                  <a:schemeClr val="dk1"/>
+                </a:lnRef>
+                <a:fillRef idx="1">
+                  <a:schemeClr val="lt1"/>
+                </a:fillRef>
+                <a:effectRef idx="0">
+                  <a:schemeClr val="dk1"/>
+                </a:effectRef>
+                <a:fontRef idx="minor">
+                  <a:schemeClr val="dk1"/>
+                </a:fontRef>
+              </p:style>
+              <p:txBody>
+                <a:bodyPr rtlCol="0" anchor="ctr"/>
+                <a:lstStyle/>
+                <a:p>
+                  <a:pPr algn="ctr"/>
+                  <a:endParaRPr lang="de-DE"/>
+                </a:p>
+              </p:txBody>
+            </p:sp>
+            <p:grpSp>
+              <p:nvGrpSpPr>
+                <p:cNvPr id="81" name="Gruppieren 80">
+                  <a:extLst>
+                    <a:ext uri="{FF2B5EF4-FFF2-40B4-BE49-F238E27FC236}">
+                      <a16:creationId xmlns:a16="http://schemas.microsoft.com/office/drawing/2014/main" id="{628F30B6-2F9C-1554-963B-A80761E4451B}"/>
+                    </a:ext>
+                  </a:extLst>
+                </p:cNvPr>
+                <p:cNvGrpSpPr>
+                  <a:grpSpLocks noChangeAspect="1"/>
+                </p:cNvGrpSpPr>
+                <p:nvPr/>
+              </p:nvGrpSpPr>
+              <p:grpSpPr>
+                <a:xfrm>
+                  <a:off x="3677500" y="2507962"/>
+                  <a:ext cx="384335" cy="106087"/>
+                  <a:chOff x="5533092" y="3218340"/>
+                  <a:chExt cx="1789608" cy="493977"/>
+                </a:xfrm>
+              </p:grpSpPr>
+              <p:pic>
+                <p:nvPicPr>
+                  <p:cNvPr id="82" name="Grafik 81">
+                    <a:extLst>
+                      <a:ext uri="{FF2B5EF4-FFF2-40B4-BE49-F238E27FC236}">
+                        <a16:creationId xmlns:a16="http://schemas.microsoft.com/office/drawing/2014/main" id="{238A36E2-6941-6C6F-5269-C1744F6AA8DE}"/>
+                      </a:ext>
+                    </a:extLst>
+                  </p:cNvPr>
+                  <p:cNvPicPr>
+                    <a:picLocks noChangeAspect="1"/>
+                  </p:cNvPicPr>
+                  <p:nvPr/>
+                </p:nvPicPr>
+                <p:blipFill>
+                  <a:blip r:embed="rId12"/>
+                  <a:stretch>
+                    <a:fillRect/>
+                  </a:stretch>
+                </p:blipFill>
+                <p:spPr>
+                  <a:xfrm>
+                    <a:off x="5533092" y="3218340"/>
+                    <a:ext cx="728718" cy="468462"/>
+                  </a:xfrm>
+                  <a:prstGeom prst="rect">
+                    <a:avLst/>
+                  </a:prstGeom>
+                </p:spPr>
+              </p:pic>
+              <p:pic>
+                <p:nvPicPr>
+                  <p:cNvPr id="83" name="Grafik 82">
+                    <a:extLst>
+                      <a:ext uri="{FF2B5EF4-FFF2-40B4-BE49-F238E27FC236}">
+                        <a16:creationId xmlns:a16="http://schemas.microsoft.com/office/drawing/2014/main" id="{96D6A6F2-9742-2713-BAC8-87E25DE3A9F6}"/>
+                      </a:ext>
+                    </a:extLst>
+                  </p:cNvPr>
+                  <p:cNvPicPr>
+                    <a:picLocks noChangeAspect="1"/>
+                  </p:cNvPicPr>
+                  <p:nvPr/>
+                </p:nvPicPr>
+                <p:blipFill>
+                  <a:blip r:embed="rId13"/>
+                  <a:stretch>
+                    <a:fillRect/>
+                  </a:stretch>
+                </p:blipFill>
+                <p:spPr>
+                  <a:xfrm>
+                    <a:off x="6261810" y="3226943"/>
+                    <a:ext cx="485889" cy="459859"/>
+                  </a:xfrm>
+                  <a:prstGeom prst="rect">
+                    <a:avLst/>
+                  </a:prstGeom>
+                </p:spPr>
+              </p:pic>
+              <p:pic>
+                <p:nvPicPr>
+                  <p:cNvPr id="84" name="Grafik 83">
+                    <a:extLst>
+                      <a:ext uri="{FF2B5EF4-FFF2-40B4-BE49-F238E27FC236}">
+                        <a16:creationId xmlns:a16="http://schemas.microsoft.com/office/drawing/2014/main" id="{D6CE6D1E-9F41-9560-8106-D9E25A639A19}"/>
+                      </a:ext>
+                    </a:extLst>
+                  </p:cNvPr>
+                  <p:cNvPicPr>
+                    <a:picLocks noChangeAspect="1"/>
+                  </p:cNvPicPr>
+                  <p:nvPr/>
+                </p:nvPicPr>
+                <p:blipFill>
+                  <a:blip r:embed="rId14"/>
+                  <a:stretch>
+                    <a:fillRect/>
+                  </a:stretch>
+                </p:blipFill>
+                <p:spPr>
+                  <a:xfrm>
+                    <a:off x="6789226" y="3269433"/>
+                    <a:ext cx="533474" cy="442884"/>
+                  </a:xfrm>
+                  <a:prstGeom prst="rect">
+                    <a:avLst/>
+                  </a:prstGeom>
+                </p:spPr>
+              </p:pic>
+            </p:grpSp>
+          </p:grpSp>
+          <p:cxnSp>
+            <p:nvCxnSpPr>
+              <p:cNvPr id="79" name="Gerader Verbinder 78">
+                <a:extLst>
+                  <a:ext uri="{FF2B5EF4-FFF2-40B4-BE49-F238E27FC236}">
+                    <a16:creationId xmlns:a16="http://schemas.microsoft.com/office/drawing/2014/main" id="{D3EDDFFF-45C1-40D6-FBE1-64AEBCCF509C}"/>
+                  </a:ext>
+                </a:extLst>
+              </p:cNvPr>
+              <p:cNvCxnSpPr>
+                <a:cxnSpLocks/>
+              </p:cNvCxnSpPr>
+              <p:nvPr/>
+            </p:nvCxnSpPr>
+            <p:spPr>
+              <a:xfrm flipV="1">
+                <a:off x="2385349" y="2484284"/>
+                <a:ext cx="60654" cy="280189"/>
+              </a:xfrm>
+              <a:prstGeom prst="line">
+                <a:avLst/>
+              </a:prstGeom>
+              <a:ln w="12700"/>
+            </p:spPr>
+            <p:style>
+              <a:lnRef idx="2">
+                <a:schemeClr val="dk1"/>
+              </a:lnRef>
+              <a:fillRef idx="1">
+                <a:schemeClr val="lt1"/>
+              </a:fillRef>
+              <a:effectRef idx="0">
+                <a:schemeClr val="dk1"/>
+              </a:effectRef>
+              <a:fontRef idx="minor">
+                <a:schemeClr val="dk1"/>
+              </a:fontRef>
+            </p:style>
+          </p:cxnSp>
+        </p:grpSp>
+        <p:pic>
+          <p:nvPicPr>
+            <p:cNvPr id="86" name="Grafik 85">
+              <a:extLst>
+                <a:ext uri="{FF2B5EF4-FFF2-40B4-BE49-F238E27FC236}">
+                  <a16:creationId xmlns:a16="http://schemas.microsoft.com/office/drawing/2014/main" id="{89D81E6F-1935-0951-8B27-C4EC418D7AAA}"/>
+                </a:ext>
+              </a:extLst>
+            </p:cNvPr>
+            <p:cNvPicPr>
+              <a:picLocks noChangeAspect="1"/>
+            </p:cNvPicPr>
+            <p:nvPr/>
+          </p:nvPicPr>
+          <p:blipFill>
+            <a:blip r:embed="rId19"/>
+            <a:stretch>
+              <a:fillRect/>
+            </a:stretch>
+          </p:blipFill>
+          <p:spPr>
+            <a:xfrm>
+              <a:off x="6284127" y="2731205"/>
+              <a:ext cx="67588" cy="82608"/>
+            </a:xfrm>
+            <a:prstGeom prst="rect">
+              <a:avLst/>
+            </a:prstGeom>
+          </p:spPr>
+        </p:pic>
+        <p:pic>
+          <p:nvPicPr>
+            <p:cNvPr id="87" name="Grafik 86">
+              <a:extLst>
+                <a:ext uri="{FF2B5EF4-FFF2-40B4-BE49-F238E27FC236}">
+                  <a16:creationId xmlns:a16="http://schemas.microsoft.com/office/drawing/2014/main" id="{83DB95FB-6BEE-1FAD-D24A-0E0E853867C7}"/>
+                </a:ext>
+              </a:extLst>
+            </p:cNvPr>
+            <p:cNvPicPr>
+              <a:picLocks noChangeAspect="1"/>
+            </p:cNvPicPr>
+            <p:nvPr/>
+          </p:nvPicPr>
+          <p:blipFill>
+            <a:blip r:embed="rId19"/>
+            <a:stretch>
+              <a:fillRect/>
+            </a:stretch>
+          </p:blipFill>
+          <p:spPr>
+            <a:xfrm>
+              <a:off x="6429415" y="2727718"/>
+              <a:ext cx="67588" cy="82608"/>
+            </a:xfrm>
+            <a:prstGeom prst="rect">
+              <a:avLst/>
+            </a:prstGeom>
+          </p:spPr>
+        </p:pic>
+        <p:pic>
+          <p:nvPicPr>
+            <p:cNvPr id="88" name="Grafik 87">
+              <a:extLst>
+                <a:ext uri="{FF2B5EF4-FFF2-40B4-BE49-F238E27FC236}">
+                  <a16:creationId xmlns:a16="http://schemas.microsoft.com/office/drawing/2014/main" id="{650C77BD-D2EB-7383-B36A-2C6BCD4E2FD2}"/>
+                </a:ext>
+              </a:extLst>
+            </p:cNvPr>
+            <p:cNvPicPr>
+              <a:picLocks noChangeAspect="1"/>
+            </p:cNvPicPr>
+            <p:nvPr/>
+          </p:nvPicPr>
+          <p:blipFill>
+            <a:blip r:embed="rId19"/>
+            <a:stretch>
+              <a:fillRect/>
+            </a:stretch>
+          </p:blipFill>
+          <p:spPr>
+            <a:xfrm>
+              <a:off x="6546502" y="2769022"/>
+              <a:ext cx="67588" cy="82608"/>
+            </a:xfrm>
+            <a:prstGeom prst="rect">
+              <a:avLst/>
+            </a:prstGeom>
+          </p:spPr>
+        </p:pic>
+      </p:grpSp>
+      <p:pic>
+        <p:nvPicPr>
+          <p:cNvPr id="90" name="Grafik 89">
+            <a:extLst>
+              <a:ext uri="{FF2B5EF4-FFF2-40B4-BE49-F238E27FC236}">
+                <a16:creationId xmlns:a16="http://schemas.microsoft.com/office/drawing/2014/main" id="{A0ED1B7E-C8AC-B10D-DFF9-8A603311FB5D}"/>
+              </a:ext>
+            </a:extLst>
+          </p:cNvPr>
+          <p:cNvPicPr>
+            <a:picLocks noChangeAspect="1"/>
+          </p:cNvPicPr>
+          <p:nvPr/>
+        </p:nvPicPr>
+        <p:blipFill>
+          <a:blip r:embed="rId20"/>
+          <a:stretch>
+            <a:fillRect/>
+          </a:stretch>
+        </p:blipFill>
+        <p:spPr>
+          <a:xfrm>
+            <a:off x="6652825" y="4193357"/>
+            <a:ext cx="1168222" cy="1163473"/>
+          </a:xfrm>
+          <a:prstGeom prst="rect">
+            <a:avLst/>
+          </a:prstGeom>
+        </p:spPr>
+      </p:pic>
+      <p:pic>
+        <p:nvPicPr>
+          <p:cNvPr id="94" name="Grafik 93">
+            <a:extLst>
+              <a:ext uri="{FF2B5EF4-FFF2-40B4-BE49-F238E27FC236}">
+                <a16:creationId xmlns:a16="http://schemas.microsoft.com/office/drawing/2014/main" id="{0653A2BA-FDB7-4C3C-C3C0-91E79886BF85}"/>
+              </a:ext>
+            </a:extLst>
+          </p:cNvPr>
+          <p:cNvPicPr>
+            <a:picLocks noChangeAspect="1"/>
+          </p:cNvPicPr>
+          <p:nvPr/>
+        </p:nvPicPr>
+        <p:blipFill>
+          <a:blip r:embed="rId11"/>
+          <a:stretch>
+            <a:fillRect/>
+          </a:stretch>
+        </p:blipFill>
+        <p:spPr>
+          <a:xfrm>
+            <a:off x="7939725" y="3962776"/>
+            <a:ext cx="213481" cy="213481"/>
+          </a:xfrm>
+          <a:prstGeom prst="rect">
+            <a:avLst/>
+          </a:prstGeom>
+        </p:spPr>
+      </p:pic>
+      <p:sp>
+        <p:nvSpPr>
+          <p:cNvPr id="103" name="Textfeld 102">
+            <a:extLst>
+              <a:ext uri="{FF2B5EF4-FFF2-40B4-BE49-F238E27FC236}">
+                <a16:creationId xmlns:a16="http://schemas.microsoft.com/office/drawing/2014/main" id="{C9C67CF9-403A-5E1D-82D8-02D48B1A34B4}"/>
+              </a:ext>
+            </a:extLst>
+          </p:cNvPr>
+          <p:cNvSpPr txBox="1"/>
+          <p:nvPr/>
+        </p:nvSpPr>
+        <p:spPr>
+          <a:xfrm>
+            <a:off x="6641703" y="5390614"/>
+            <a:ext cx="1152880" cy="338554"/>
+          </a:xfrm>
+          <a:prstGeom prst="rect">
+            <a:avLst/>
+          </a:prstGeom>
+          <a:noFill/>
+        </p:spPr>
+        <p:txBody>
+          <a:bodyPr wrap="none" rtlCol="0">
+            <a:spAutoFit/>
+          </a:bodyPr>
+          <a:lstStyle/>
+          <a:p>
+            <a:r>
+              <a:rPr lang="en-US" sz="800" noProof="0" dirty="0"/>
+              <a:t>Transmitting</a:t>
+            </a:r>
+          </a:p>
+          <a:p>
+            <a:r>
+              <a:rPr lang="en-US" sz="800" noProof="0" dirty="0"/>
+              <a:t>- </a:t>
+            </a:r>
+            <a:r>
+              <a:rPr lang="en-US" sz="800" dirty="0"/>
+              <a:t>p1TransmittingKafka</a:t>
+            </a:r>
+            <a:endParaRPr lang="en-US" sz="800" noProof="0" dirty="0"/>
+          </a:p>
+        </p:txBody>
+      </p:sp>
+      <p:grpSp>
+        <p:nvGrpSpPr>
+          <p:cNvPr id="13" name="Gruppieren 12">
+            <a:extLst>
+              <a:ext uri="{FF2B5EF4-FFF2-40B4-BE49-F238E27FC236}">
+                <a16:creationId xmlns:a16="http://schemas.microsoft.com/office/drawing/2014/main" id="{5021F0CD-6289-D2E5-02B3-40C8BD41C766}"/>
+              </a:ext>
+            </a:extLst>
+          </p:cNvPr>
+          <p:cNvGrpSpPr/>
+          <p:nvPr/>
+        </p:nvGrpSpPr>
+        <p:grpSpPr>
+          <a:xfrm>
+            <a:off x="8069572" y="4591309"/>
+            <a:ext cx="686327" cy="701282"/>
+            <a:chOff x="8062071" y="3642118"/>
+            <a:chExt cx="686327" cy="701282"/>
+          </a:xfrm>
+        </p:grpSpPr>
+        <p:pic>
+          <p:nvPicPr>
+            <p:cNvPr id="128" name="Grafik 127">
+              <a:extLst>
+                <a:ext uri="{FF2B5EF4-FFF2-40B4-BE49-F238E27FC236}">
+                  <a16:creationId xmlns:a16="http://schemas.microsoft.com/office/drawing/2014/main" id="{1082E7CE-26E0-691B-1E14-E9F89BDC53ED}"/>
+                </a:ext>
+              </a:extLst>
+            </p:cNvPr>
+            <p:cNvPicPr>
+              <a:picLocks noChangeAspect="1"/>
+            </p:cNvPicPr>
+            <p:nvPr/>
+          </p:nvPicPr>
+          <p:blipFill>
+            <a:blip r:embed="rId9"/>
+            <a:stretch>
+              <a:fillRect/>
+            </a:stretch>
+          </p:blipFill>
+          <p:spPr>
+            <a:xfrm>
+              <a:off x="8062071" y="3900400"/>
+              <a:ext cx="511431" cy="443000"/>
+            </a:xfrm>
+            <a:prstGeom prst="rect">
+              <a:avLst/>
+            </a:prstGeom>
+          </p:spPr>
+        </p:pic>
+        <p:pic>
+          <p:nvPicPr>
+            <p:cNvPr id="130" name="Grafik 129">
+              <a:extLst>
+                <a:ext uri="{FF2B5EF4-FFF2-40B4-BE49-F238E27FC236}">
+                  <a16:creationId xmlns:a16="http://schemas.microsoft.com/office/drawing/2014/main" id="{50CD65C5-3114-9903-B6C3-26096636C734}"/>
+                </a:ext>
+              </a:extLst>
+            </p:cNvPr>
+            <p:cNvPicPr>
+              <a:picLocks noChangeAspect="1"/>
+            </p:cNvPicPr>
+            <p:nvPr/>
+          </p:nvPicPr>
+          <p:blipFill>
+            <a:blip r:embed="rId11"/>
+            <a:stretch>
+              <a:fillRect/>
+            </a:stretch>
+          </p:blipFill>
+          <p:spPr>
+            <a:xfrm>
+              <a:off x="8335998" y="3889302"/>
+              <a:ext cx="213481" cy="213481"/>
+            </a:xfrm>
+            <a:prstGeom prst="rect">
+              <a:avLst/>
+            </a:prstGeom>
+          </p:spPr>
+        </p:pic>
+        <p:pic>
+          <p:nvPicPr>
+            <p:cNvPr id="131" name="Grafik 130">
+              <a:extLst>
+                <a:ext uri="{FF2B5EF4-FFF2-40B4-BE49-F238E27FC236}">
+                  <a16:creationId xmlns:a16="http://schemas.microsoft.com/office/drawing/2014/main" id="{0A002F32-970D-F126-34F2-FCB3458195E9}"/>
+                </a:ext>
+              </a:extLst>
+            </p:cNvPr>
+            <p:cNvPicPr>
+              <a:picLocks noChangeAspect="1"/>
+            </p:cNvPicPr>
+            <p:nvPr/>
+          </p:nvPicPr>
+          <p:blipFill>
+            <a:blip r:embed="rId8"/>
+            <a:stretch>
+              <a:fillRect/>
+            </a:stretch>
+          </p:blipFill>
+          <p:spPr>
+            <a:xfrm>
+              <a:off x="8549479" y="3991273"/>
+              <a:ext cx="198919" cy="195335"/>
+            </a:xfrm>
+            <a:prstGeom prst="rect">
+              <a:avLst/>
+            </a:prstGeom>
+          </p:spPr>
+        </p:pic>
+        <p:grpSp>
+          <p:nvGrpSpPr>
+            <p:cNvPr id="132" name="Gruppieren 131">
+              <a:extLst>
+                <a:ext uri="{FF2B5EF4-FFF2-40B4-BE49-F238E27FC236}">
+                  <a16:creationId xmlns:a16="http://schemas.microsoft.com/office/drawing/2014/main" id="{3CB59501-75AA-0A15-27F0-EE2826AB8F73}"/>
+                </a:ext>
+              </a:extLst>
+            </p:cNvPr>
+            <p:cNvGrpSpPr/>
+            <p:nvPr/>
+          </p:nvGrpSpPr>
+          <p:grpSpPr>
+            <a:xfrm rot="559622">
+              <a:off x="8174198" y="3712748"/>
+              <a:ext cx="418250" cy="147871"/>
+              <a:chOff x="3664801" y="2485737"/>
+              <a:chExt cx="418250" cy="147871"/>
+            </a:xfrm>
+          </p:grpSpPr>
+          <p:sp>
+            <p:nvSpPr>
+              <p:cNvPr id="134" name="Rechteck 133">
+                <a:extLst>
+                  <a:ext uri="{FF2B5EF4-FFF2-40B4-BE49-F238E27FC236}">
+                    <a16:creationId xmlns:a16="http://schemas.microsoft.com/office/drawing/2014/main" id="{FF3CEF8B-2450-D8CF-C9B0-15868AFB0428}"/>
+                  </a:ext>
+                </a:extLst>
+              </p:cNvPr>
+              <p:cNvSpPr/>
+              <p:nvPr/>
+            </p:nvSpPr>
+            <p:spPr>
+              <a:xfrm>
+                <a:off x="3664801" y="2485737"/>
+                <a:ext cx="418250" cy="147871"/>
+              </a:xfrm>
+              <a:prstGeom prst="rect">
+                <a:avLst/>
+              </a:prstGeom>
+              <a:ln w="12700"/>
+            </p:spPr>
+            <p:style>
+              <a:lnRef idx="2">
+                <a:schemeClr val="dk1"/>
+              </a:lnRef>
+              <a:fillRef idx="1">
+                <a:schemeClr val="lt1"/>
+              </a:fillRef>
+              <a:effectRef idx="0">
+                <a:schemeClr val="dk1"/>
+              </a:effectRef>
+              <a:fontRef idx="minor">
+                <a:schemeClr val="dk1"/>
+              </a:fontRef>
+            </p:style>
+            <p:txBody>
+              <a:bodyPr rtlCol="0" anchor="ctr"/>
+              <a:lstStyle/>
+              <a:p>
+                <a:pPr algn="ctr"/>
+                <a:endParaRPr lang="de-DE"/>
+              </a:p>
+            </p:txBody>
+          </p:sp>
+          <p:grpSp>
+            <p:nvGrpSpPr>
+              <p:cNvPr id="135" name="Gruppieren 134">
+                <a:extLst>
+                  <a:ext uri="{FF2B5EF4-FFF2-40B4-BE49-F238E27FC236}">
+                    <a16:creationId xmlns:a16="http://schemas.microsoft.com/office/drawing/2014/main" id="{17DD7458-8DBB-DE33-A0E4-5CA67BD2CF4B}"/>
+                  </a:ext>
+                </a:extLst>
+              </p:cNvPr>
+              <p:cNvGrpSpPr>
+                <a:grpSpLocks noChangeAspect="1"/>
+              </p:cNvGrpSpPr>
+              <p:nvPr/>
+            </p:nvGrpSpPr>
+            <p:grpSpPr>
+              <a:xfrm>
+                <a:off x="3677500" y="2507962"/>
+                <a:ext cx="384335" cy="106087"/>
+                <a:chOff x="5533092" y="3218340"/>
+                <a:chExt cx="1789608" cy="493977"/>
+              </a:xfrm>
+            </p:grpSpPr>
+            <p:pic>
+              <p:nvPicPr>
+                <p:cNvPr id="136" name="Grafik 135">
+                  <a:extLst>
+                    <a:ext uri="{FF2B5EF4-FFF2-40B4-BE49-F238E27FC236}">
+                      <a16:creationId xmlns:a16="http://schemas.microsoft.com/office/drawing/2014/main" id="{8D17594E-F078-9E9B-8EEC-78EEDC725715}"/>
+                    </a:ext>
+                  </a:extLst>
+                </p:cNvPr>
+                <p:cNvPicPr>
+                  <a:picLocks noChangeAspect="1"/>
+                </p:cNvPicPr>
+                <p:nvPr/>
+              </p:nvPicPr>
+              <p:blipFill>
+                <a:blip r:embed="rId12"/>
+                <a:stretch>
+                  <a:fillRect/>
+                </a:stretch>
+              </p:blipFill>
+              <p:spPr>
+                <a:xfrm>
+                  <a:off x="5533092" y="3218340"/>
+                  <a:ext cx="728718" cy="468462"/>
+                </a:xfrm>
+                <a:prstGeom prst="rect">
+                  <a:avLst/>
+                </a:prstGeom>
+              </p:spPr>
+            </p:pic>
+            <p:pic>
+              <p:nvPicPr>
+                <p:cNvPr id="137" name="Grafik 136">
+                  <a:extLst>
+                    <a:ext uri="{FF2B5EF4-FFF2-40B4-BE49-F238E27FC236}">
+                      <a16:creationId xmlns:a16="http://schemas.microsoft.com/office/drawing/2014/main" id="{5E07E1EE-59E6-C9B3-322B-0B42B31F710A}"/>
+                    </a:ext>
+                  </a:extLst>
+                </p:cNvPr>
+                <p:cNvPicPr>
+                  <a:picLocks noChangeAspect="1"/>
+                </p:cNvPicPr>
+                <p:nvPr/>
+              </p:nvPicPr>
+              <p:blipFill>
+                <a:blip r:embed="rId13"/>
+                <a:stretch>
+                  <a:fillRect/>
+                </a:stretch>
+              </p:blipFill>
+              <p:spPr>
+                <a:xfrm>
+                  <a:off x="6261810" y="3226943"/>
+                  <a:ext cx="485889" cy="459859"/>
+                </a:xfrm>
+                <a:prstGeom prst="rect">
+                  <a:avLst/>
+                </a:prstGeom>
+              </p:spPr>
+            </p:pic>
+            <p:pic>
+              <p:nvPicPr>
+                <p:cNvPr id="138" name="Grafik 137">
+                  <a:extLst>
+                    <a:ext uri="{FF2B5EF4-FFF2-40B4-BE49-F238E27FC236}">
+                      <a16:creationId xmlns:a16="http://schemas.microsoft.com/office/drawing/2014/main" id="{3EEC51E6-63CF-0222-72A9-756981111A64}"/>
+                    </a:ext>
+                  </a:extLst>
+                </p:cNvPr>
+                <p:cNvPicPr>
+                  <a:picLocks noChangeAspect="1"/>
+                </p:cNvPicPr>
+                <p:nvPr/>
+              </p:nvPicPr>
+              <p:blipFill>
+                <a:blip r:embed="rId14"/>
+                <a:stretch>
+                  <a:fillRect/>
+                </a:stretch>
+              </p:blipFill>
+              <p:spPr>
+                <a:xfrm>
+                  <a:off x="6789226" y="3269433"/>
+                  <a:ext cx="533474" cy="442884"/>
+                </a:xfrm>
+                <a:prstGeom prst="rect">
+                  <a:avLst/>
+                </a:prstGeom>
+              </p:spPr>
+            </p:pic>
+          </p:grpSp>
+        </p:grpSp>
+        <p:cxnSp>
+          <p:nvCxnSpPr>
+            <p:cNvPr id="133" name="Gerader Verbinder 132">
+              <a:extLst>
+                <a:ext uri="{FF2B5EF4-FFF2-40B4-BE49-F238E27FC236}">
+                  <a16:creationId xmlns:a16="http://schemas.microsoft.com/office/drawing/2014/main" id="{104D138B-ABDF-D4D4-76B7-EE1F7B980B06}"/>
+                </a:ext>
+              </a:extLst>
+            </p:cNvPr>
+            <p:cNvCxnSpPr>
+              <a:cxnSpLocks/>
+            </p:cNvCxnSpPr>
+            <p:nvPr/>
+          </p:nvCxnSpPr>
+          <p:spPr>
+            <a:xfrm flipV="1">
+              <a:off x="8140202" y="3672968"/>
+              <a:ext cx="60654" cy="280189"/>
+            </a:xfrm>
+            <a:prstGeom prst="line">
+              <a:avLst/>
+            </a:prstGeom>
+            <a:ln w="12700"/>
+          </p:spPr>
+          <p:style>
+            <a:lnRef idx="2">
+              <a:schemeClr val="dk1"/>
+            </a:lnRef>
+            <a:fillRef idx="1">
+              <a:schemeClr val="lt1"/>
+            </a:fillRef>
+            <a:effectRef idx="0">
+              <a:schemeClr val="dk1"/>
+            </a:effectRef>
+            <a:fontRef idx="minor">
+              <a:schemeClr val="dk1"/>
+            </a:fontRef>
+          </p:style>
+        </p:cxnSp>
+        <p:pic>
+          <p:nvPicPr>
+            <p:cNvPr id="125" name="Grafik 124">
+              <a:extLst>
+                <a:ext uri="{FF2B5EF4-FFF2-40B4-BE49-F238E27FC236}">
+                  <a16:creationId xmlns:a16="http://schemas.microsoft.com/office/drawing/2014/main" id="{FB5E3DB4-855E-522D-0CCF-B64AABC89F61}"/>
+                </a:ext>
+              </a:extLst>
+            </p:cNvPr>
+            <p:cNvPicPr>
+              <a:picLocks noChangeAspect="1"/>
+            </p:cNvPicPr>
+            <p:nvPr/>
+          </p:nvPicPr>
+          <p:blipFill>
+            <a:blip r:embed="rId19"/>
+            <a:stretch>
+              <a:fillRect/>
+            </a:stretch>
+          </p:blipFill>
+          <p:spPr>
+            <a:xfrm>
+              <a:off x="8250198" y="3645605"/>
+              <a:ext cx="67588" cy="82608"/>
+            </a:xfrm>
+            <a:prstGeom prst="rect">
+              <a:avLst/>
+            </a:prstGeom>
+          </p:spPr>
+        </p:pic>
+        <p:pic>
+          <p:nvPicPr>
+            <p:cNvPr id="126" name="Grafik 125">
+              <a:extLst>
+                <a:ext uri="{FF2B5EF4-FFF2-40B4-BE49-F238E27FC236}">
+                  <a16:creationId xmlns:a16="http://schemas.microsoft.com/office/drawing/2014/main" id="{EF665CBC-D17F-2D2A-EBEA-30D0DFF77CDB}"/>
+                </a:ext>
+              </a:extLst>
+            </p:cNvPr>
+            <p:cNvPicPr>
+              <a:picLocks noChangeAspect="1"/>
+            </p:cNvPicPr>
+            <p:nvPr/>
+          </p:nvPicPr>
+          <p:blipFill>
+            <a:blip r:embed="rId19"/>
+            <a:stretch>
+              <a:fillRect/>
+            </a:stretch>
+          </p:blipFill>
+          <p:spPr>
+            <a:xfrm>
+              <a:off x="8395486" y="3642118"/>
+              <a:ext cx="67588" cy="82608"/>
+            </a:xfrm>
+            <a:prstGeom prst="rect">
+              <a:avLst/>
+            </a:prstGeom>
+          </p:spPr>
+        </p:pic>
+        <p:pic>
+          <p:nvPicPr>
+            <p:cNvPr id="127" name="Grafik 126">
+              <a:extLst>
+                <a:ext uri="{FF2B5EF4-FFF2-40B4-BE49-F238E27FC236}">
+                  <a16:creationId xmlns:a16="http://schemas.microsoft.com/office/drawing/2014/main" id="{BBB04561-CFDD-A85B-A170-6D4A038DD9C6}"/>
+                </a:ext>
+              </a:extLst>
+            </p:cNvPr>
+            <p:cNvPicPr>
+              <a:picLocks noChangeAspect="1"/>
+            </p:cNvPicPr>
+            <p:nvPr/>
+          </p:nvPicPr>
+          <p:blipFill>
+            <a:blip r:embed="rId19"/>
+            <a:stretch>
+              <a:fillRect/>
+            </a:stretch>
+          </p:blipFill>
+          <p:spPr>
+            <a:xfrm>
+              <a:off x="8512573" y="3683422"/>
+              <a:ext cx="67588" cy="82608"/>
+            </a:xfrm>
+            <a:prstGeom prst="rect">
+              <a:avLst/>
+            </a:prstGeom>
+          </p:spPr>
+        </p:pic>
+      </p:grpSp>
+      <p:sp>
+        <p:nvSpPr>
+          <p:cNvPr id="238" name="Freihandform: Form 237">
+            <a:extLst>
+              <a:ext uri="{FF2B5EF4-FFF2-40B4-BE49-F238E27FC236}">
+                <a16:creationId xmlns:a16="http://schemas.microsoft.com/office/drawing/2014/main" id="{C733D056-2A07-C372-4A21-268A1AB60559}"/>
+              </a:ext>
+            </a:extLst>
+          </p:cNvPr>
+          <p:cNvSpPr/>
+          <p:nvPr/>
+        </p:nvSpPr>
+        <p:spPr>
+          <a:xfrm>
+            <a:off x="3421261" y="4858251"/>
+            <a:ext cx="2476500" cy="554770"/>
+          </a:xfrm>
+          <a:custGeom>
+            <a:avLst/>
+            <a:gdLst>
+              <a:gd name="connsiteX0" fmla="*/ 0 w 2476500"/>
+              <a:gd name="connsiteY0" fmla="*/ 411480 h 554770"/>
+              <a:gd name="connsiteX1" fmla="*/ 38100 w 2476500"/>
+              <a:gd name="connsiteY1" fmla="*/ 419100 h 554770"/>
+              <a:gd name="connsiteX2" fmla="*/ 60960 w 2476500"/>
+              <a:gd name="connsiteY2" fmla="*/ 403860 h 554770"/>
+              <a:gd name="connsiteX3" fmla="*/ 83820 w 2476500"/>
+              <a:gd name="connsiteY3" fmla="*/ 396240 h 554770"/>
+              <a:gd name="connsiteX4" fmla="*/ 129540 w 2476500"/>
+              <a:gd name="connsiteY4" fmla="*/ 365760 h 554770"/>
+              <a:gd name="connsiteX5" fmla="*/ 190500 w 2476500"/>
+              <a:gd name="connsiteY5" fmla="*/ 350520 h 554770"/>
+              <a:gd name="connsiteX6" fmla="*/ 297180 w 2476500"/>
+              <a:gd name="connsiteY6" fmla="*/ 358140 h 554770"/>
+              <a:gd name="connsiteX7" fmla="*/ 358140 w 2476500"/>
+              <a:gd name="connsiteY7" fmla="*/ 381000 h 554770"/>
+              <a:gd name="connsiteX8" fmla="*/ 403860 w 2476500"/>
+              <a:gd name="connsiteY8" fmla="*/ 403860 h 554770"/>
+              <a:gd name="connsiteX9" fmla="*/ 426720 w 2476500"/>
+              <a:gd name="connsiteY9" fmla="*/ 441960 h 554770"/>
+              <a:gd name="connsiteX10" fmla="*/ 487680 w 2476500"/>
+              <a:gd name="connsiteY10" fmla="*/ 487680 h 554770"/>
+              <a:gd name="connsiteX11" fmla="*/ 518160 w 2476500"/>
+              <a:gd name="connsiteY11" fmla="*/ 510540 h 554770"/>
+              <a:gd name="connsiteX12" fmla="*/ 617220 w 2476500"/>
+              <a:gd name="connsiteY12" fmla="*/ 533400 h 554770"/>
+              <a:gd name="connsiteX13" fmla="*/ 640080 w 2476500"/>
+              <a:gd name="connsiteY13" fmla="*/ 541020 h 554770"/>
+              <a:gd name="connsiteX14" fmla="*/ 922020 w 2476500"/>
+              <a:gd name="connsiteY14" fmla="*/ 541020 h 554770"/>
+              <a:gd name="connsiteX15" fmla="*/ 975360 w 2476500"/>
+              <a:gd name="connsiteY15" fmla="*/ 502920 h 554770"/>
+              <a:gd name="connsiteX16" fmla="*/ 1036320 w 2476500"/>
+              <a:gd name="connsiteY16" fmla="*/ 449580 h 554770"/>
+              <a:gd name="connsiteX17" fmla="*/ 1074420 w 2476500"/>
+              <a:gd name="connsiteY17" fmla="*/ 381000 h 554770"/>
+              <a:gd name="connsiteX18" fmla="*/ 1104900 w 2476500"/>
+              <a:gd name="connsiteY18" fmla="*/ 342900 h 554770"/>
+              <a:gd name="connsiteX19" fmla="*/ 1120140 w 2476500"/>
+              <a:gd name="connsiteY19" fmla="*/ 320040 h 554770"/>
+              <a:gd name="connsiteX20" fmla="*/ 1143000 w 2476500"/>
+              <a:gd name="connsiteY20" fmla="*/ 251460 h 554770"/>
+              <a:gd name="connsiteX21" fmla="*/ 1150620 w 2476500"/>
+              <a:gd name="connsiteY21" fmla="*/ 228600 h 554770"/>
+              <a:gd name="connsiteX22" fmla="*/ 1165860 w 2476500"/>
+              <a:gd name="connsiteY22" fmla="*/ 205740 h 554770"/>
+              <a:gd name="connsiteX23" fmla="*/ 1219200 w 2476500"/>
+              <a:gd name="connsiteY23" fmla="*/ 137160 h 554770"/>
+              <a:gd name="connsiteX24" fmla="*/ 1234440 w 2476500"/>
+              <a:gd name="connsiteY24" fmla="*/ 114300 h 554770"/>
+              <a:gd name="connsiteX25" fmla="*/ 1257300 w 2476500"/>
+              <a:gd name="connsiteY25" fmla="*/ 91440 h 554770"/>
+              <a:gd name="connsiteX26" fmla="*/ 1295400 w 2476500"/>
+              <a:gd name="connsiteY26" fmla="*/ 38100 h 554770"/>
+              <a:gd name="connsiteX27" fmla="*/ 1318260 w 2476500"/>
+              <a:gd name="connsiteY27" fmla="*/ 22860 h 554770"/>
+              <a:gd name="connsiteX28" fmla="*/ 1386840 w 2476500"/>
+              <a:gd name="connsiteY28" fmla="*/ 0 h 554770"/>
+              <a:gd name="connsiteX29" fmla="*/ 1577340 w 2476500"/>
+              <a:gd name="connsiteY29" fmla="*/ 15240 h 554770"/>
+              <a:gd name="connsiteX30" fmla="*/ 1645920 w 2476500"/>
+              <a:gd name="connsiteY30" fmla="*/ 30480 h 554770"/>
+              <a:gd name="connsiteX31" fmla="*/ 1691640 w 2476500"/>
+              <a:gd name="connsiteY31" fmla="*/ 38100 h 554770"/>
+              <a:gd name="connsiteX32" fmla="*/ 1874520 w 2476500"/>
+              <a:gd name="connsiteY32" fmla="*/ 53340 h 554770"/>
+              <a:gd name="connsiteX33" fmla="*/ 1935480 w 2476500"/>
+              <a:gd name="connsiteY33" fmla="*/ 60960 h 554770"/>
+              <a:gd name="connsiteX34" fmla="*/ 1958340 w 2476500"/>
+              <a:gd name="connsiteY34" fmla="*/ 83820 h 554770"/>
+              <a:gd name="connsiteX35" fmla="*/ 1988820 w 2476500"/>
+              <a:gd name="connsiteY35" fmla="*/ 99060 h 554770"/>
+              <a:gd name="connsiteX36" fmla="*/ 1996440 w 2476500"/>
+              <a:gd name="connsiteY36" fmla="*/ 129540 h 554770"/>
+              <a:gd name="connsiteX37" fmla="*/ 2034540 w 2476500"/>
+              <a:gd name="connsiteY37" fmla="*/ 205740 h 554770"/>
+              <a:gd name="connsiteX38" fmla="*/ 2049780 w 2476500"/>
+              <a:gd name="connsiteY38" fmla="*/ 251460 h 554770"/>
+              <a:gd name="connsiteX39" fmla="*/ 2110740 w 2476500"/>
+              <a:gd name="connsiteY39" fmla="*/ 327660 h 554770"/>
+              <a:gd name="connsiteX40" fmla="*/ 2141220 w 2476500"/>
+              <a:gd name="connsiteY40" fmla="*/ 350520 h 554770"/>
+              <a:gd name="connsiteX41" fmla="*/ 2164080 w 2476500"/>
+              <a:gd name="connsiteY41" fmla="*/ 373380 h 554770"/>
+              <a:gd name="connsiteX42" fmla="*/ 2293620 w 2476500"/>
+              <a:gd name="connsiteY42" fmla="*/ 411480 h 554770"/>
+              <a:gd name="connsiteX43" fmla="*/ 2476500 w 2476500"/>
+              <a:gd name="connsiteY43" fmla="*/ 411480 h 554770"/>
+            </a:gdLst>
+            <a:ahLst/>
+            <a:cxnLst>
+              <a:cxn ang="0">
+                <a:pos x="connsiteX0" y="connsiteY0"/>
+              </a:cxn>
+              <a:cxn ang="0">
+                <a:pos x="connsiteX1" y="connsiteY1"/>
+              </a:cxn>
+              <a:cxn ang="0">
+                <a:pos x="connsiteX2" y="connsiteY2"/>
+              </a:cxn>
+              <a:cxn ang="0">
+                <a:pos x="connsiteX3" y="connsiteY3"/>
+              </a:cxn>
+              <a:cxn ang="0">
+                <a:pos x="connsiteX4" y="connsiteY4"/>
+              </a:cxn>
+              <a:cxn ang="0">
+                <a:pos x="connsiteX5" y="connsiteY5"/>
+              </a:cxn>
+              <a:cxn ang="0">
+                <a:pos x="connsiteX6" y="connsiteY6"/>
+              </a:cxn>
+              <a:cxn ang="0">
+                <a:pos x="connsiteX7" y="connsiteY7"/>
+              </a:cxn>
+              <a:cxn ang="0">
+                <a:pos x="connsiteX8" y="connsiteY8"/>
+              </a:cxn>
+              <a:cxn ang="0">
+                <a:pos x="connsiteX9" y="connsiteY9"/>
+              </a:cxn>
+              <a:cxn ang="0">
+                <a:pos x="connsiteX10" y="connsiteY10"/>
+              </a:cxn>
+              <a:cxn ang="0">
+                <a:pos x="connsiteX11" y="connsiteY11"/>
+              </a:cxn>
+              <a:cxn ang="0">
+                <a:pos x="connsiteX12" y="connsiteY12"/>
+              </a:cxn>
+              <a:cxn ang="0">
+                <a:pos x="connsiteX13" y="connsiteY13"/>
+              </a:cxn>
+              <a:cxn ang="0">
+                <a:pos x="connsiteX14" y="connsiteY14"/>
+              </a:cxn>
+              <a:cxn ang="0">
+                <a:pos x="connsiteX15" y="connsiteY15"/>
+              </a:cxn>
+              <a:cxn ang="0">
+                <a:pos x="connsiteX16" y="connsiteY16"/>
+              </a:cxn>
+              <a:cxn ang="0">
+                <a:pos x="connsiteX17" y="connsiteY17"/>
+              </a:cxn>
+              <a:cxn ang="0">
+                <a:pos x="connsiteX18" y="connsiteY18"/>
+              </a:cxn>
+              <a:cxn ang="0">
+                <a:pos x="connsiteX19" y="connsiteY19"/>
+              </a:cxn>
+              <a:cxn ang="0">
+                <a:pos x="connsiteX20" y="connsiteY20"/>
+              </a:cxn>
+              <a:cxn ang="0">
+                <a:pos x="connsiteX21" y="connsiteY21"/>
+              </a:cxn>
+              <a:cxn ang="0">
+                <a:pos x="connsiteX22" y="connsiteY22"/>
+              </a:cxn>
+              <a:cxn ang="0">
+                <a:pos x="connsiteX23" y="connsiteY23"/>
+              </a:cxn>
+              <a:cxn ang="0">
+                <a:pos x="connsiteX24" y="connsiteY24"/>
+              </a:cxn>
+              <a:cxn ang="0">
+                <a:pos x="connsiteX25" y="connsiteY25"/>
+              </a:cxn>
+              <a:cxn ang="0">
+                <a:pos x="connsiteX26" y="connsiteY26"/>
+              </a:cxn>
+              <a:cxn ang="0">
+                <a:pos x="connsiteX27" y="connsiteY27"/>
+              </a:cxn>
+              <a:cxn ang="0">
+                <a:pos x="connsiteX28" y="connsiteY28"/>
+              </a:cxn>
+              <a:cxn ang="0">
+                <a:pos x="connsiteX29" y="connsiteY29"/>
+              </a:cxn>
+              <a:cxn ang="0">
+                <a:pos x="connsiteX30" y="connsiteY30"/>
+              </a:cxn>
+              <a:cxn ang="0">
+                <a:pos x="connsiteX31" y="connsiteY31"/>
+              </a:cxn>
+              <a:cxn ang="0">
+                <a:pos x="connsiteX32" y="connsiteY32"/>
+              </a:cxn>
+              <a:cxn ang="0">
+                <a:pos x="connsiteX33" y="connsiteY33"/>
+              </a:cxn>
+              <a:cxn ang="0">
+                <a:pos x="connsiteX34" y="connsiteY34"/>
+              </a:cxn>
+              <a:cxn ang="0">
+                <a:pos x="connsiteX35" y="connsiteY35"/>
+              </a:cxn>
+              <a:cxn ang="0">
+                <a:pos x="connsiteX36" y="connsiteY36"/>
+              </a:cxn>
+              <a:cxn ang="0">
+                <a:pos x="connsiteX37" y="connsiteY37"/>
+              </a:cxn>
+              <a:cxn ang="0">
+                <a:pos x="connsiteX38" y="connsiteY38"/>
+              </a:cxn>
+              <a:cxn ang="0">
+                <a:pos x="connsiteX39" y="connsiteY39"/>
+              </a:cxn>
+              <a:cxn ang="0">
+                <a:pos x="connsiteX40" y="connsiteY40"/>
+              </a:cxn>
+              <a:cxn ang="0">
+                <a:pos x="connsiteX41" y="connsiteY41"/>
+              </a:cxn>
+              <a:cxn ang="0">
+                <a:pos x="connsiteX42" y="connsiteY42"/>
+              </a:cxn>
+              <a:cxn ang="0">
+                <a:pos x="connsiteX43" y="connsiteY43"/>
+              </a:cxn>
+            </a:cxnLst>
+            <a:rect l="l" t="t" r="r" b="b"/>
+            <a:pathLst>
+              <a:path w="2476500" h="554770">
+                <a:moveTo>
+                  <a:pt x="0" y="411480"/>
+                </a:moveTo>
+                <a:cubicBezTo>
+                  <a:pt x="12700" y="414020"/>
+                  <a:pt x="25249" y="420706"/>
+                  <a:pt x="38100" y="419100"/>
+                </a:cubicBezTo>
+                <a:cubicBezTo>
+                  <a:pt x="47187" y="417964"/>
+                  <a:pt x="52769" y="407956"/>
+                  <a:pt x="60960" y="403860"/>
+                </a:cubicBezTo>
+                <a:cubicBezTo>
+                  <a:pt x="68144" y="400268"/>
+                  <a:pt x="76200" y="398780"/>
+                  <a:pt x="83820" y="396240"/>
+                </a:cubicBezTo>
+                <a:cubicBezTo>
+                  <a:pt x="108661" y="371399"/>
+                  <a:pt x="99214" y="374031"/>
+                  <a:pt x="129540" y="365760"/>
+                </a:cubicBezTo>
+                <a:cubicBezTo>
+                  <a:pt x="149747" y="360249"/>
+                  <a:pt x="190500" y="350520"/>
+                  <a:pt x="190500" y="350520"/>
+                </a:cubicBezTo>
+                <a:cubicBezTo>
+                  <a:pt x="226060" y="353060"/>
+                  <a:pt x="261747" y="354203"/>
+                  <a:pt x="297180" y="358140"/>
+                </a:cubicBezTo>
+                <a:cubicBezTo>
+                  <a:pt x="328790" y="361652"/>
+                  <a:pt x="329021" y="368520"/>
+                  <a:pt x="358140" y="381000"/>
+                </a:cubicBezTo>
+                <a:cubicBezTo>
+                  <a:pt x="402307" y="399929"/>
+                  <a:pt x="359929" y="374572"/>
+                  <a:pt x="403860" y="403860"/>
+                </a:cubicBezTo>
+                <a:cubicBezTo>
+                  <a:pt x="411480" y="416560"/>
+                  <a:pt x="416247" y="431487"/>
+                  <a:pt x="426720" y="441960"/>
+                </a:cubicBezTo>
+                <a:cubicBezTo>
+                  <a:pt x="444681" y="459921"/>
+                  <a:pt x="467360" y="472440"/>
+                  <a:pt x="487680" y="487680"/>
+                </a:cubicBezTo>
+                <a:cubicBezTo>
+                  <a:pt x="497840" y="495300"/>
+                  <a:pt x="506112" y="506524"/>
+                  <a:pt x="518160" y="510540"/>
+                </a:cubicBezTo>
+                <a:cubicBezTo>
+                  <a:pt x="580919" y="531460"/>
+                  <a:pt x="547977" y="523508"/>
+                  <a:pt x="617220" y="533400"/>
+                </a:cubicBezTo>
+                <a:cubicBezTo>
+                  <a:pt x="624840" y="535940"/>
+                  <a:pt x="632357" y="538813"/>
+                  <a:pt x="640080" y="541020"/>
+                </a:cubicBezTo>
+                <a:cubicBezTo>
+                  <a:pt x="739276" y="569362"/>
+                  <a:pt x="761296" y="545890"/>
+                  <a:pt x="922020" y="541020"/>
+                </a:cubicBezTo>
+                <a:cubicBezTo>
+                  <a:pt x="962554" y="527509"/>
+                  <a:pt x="931968" y="541490"/>
+                  <a:pt x="975360" y="502920"/>
+                </a:cubicBezTo>
+                <a:cubicBezTo>
+                  <a:pt x="1001828" y="479393"/>
+                  <a:pt x="1015243" y="474873"/>
+                  <a:pt x="1036320" y="449580"/>
+                </a:cubicBezTo>
+                <a:cubicBezTo>
+                  <a:pt x="1057786" y="423821"/>
+                  <a:pt x="1053466" y="413927"/>
+                  <a:pt x="1074420" y="381000"/>
+                </a:cubicBezTo>
+                <a:cubicBezTo>
+                  <a:pt x="1083152" y="367279"/>
+                  <a:pt x="1095142" y="355911"/>
+                  <a:pt x="1104900" y="342900"/>
+                </a:cubicBezTo>
+                <a:cubicBezTo>
+                  <a:pt x="1110395" y="335574"/>
+                  <a:pt x="1115060" y="327660"/>
+                  <a:pt x="1120140" y="320040"/>
+                </a:cubicBezTo>
+                <a:cubicBezTo>
+                  <a:pt x="1132908" y="268967"/>
+                  <a:pt x="1121479" y="308848"/>
+                  <a:pt x="1143000" y="251460"/>
+                </a:cubicBezTo>
+                <a:cubicBezTo>
+                  <a:pt x="1145820" y="243939"/>
+                  <a:pt x="1147028" y="235784"/>
+                  <a:pt x="1150620" y="228600"/>
+                </a:cubicBezTo>
+                <a:cubicBezTo>
+                  <a:pt x="1154716" y="220409"/>
+                  <a:pt x="1160365" y="213066"/>
+                  <a:pt x="1165860" y="205740"/>
+                </a:cubicBezTo>
+                <a:cubicBezTo>
+                  <a:pt x="1183236" y="182572"/>
+                  <a:pt x="1203136" y="161257"/>
+                  <a:pt x="1219200" y="137160"/>
+                </a:cubicBezTo>
+                <a:cubicBezTo>
+                  <a:pt x="1224280" y="129540"/>
+                  <a:pt x="1228577" y="121335"/>
+                  <a:pt x="1234440" y="114300"/>
+                </a:cubicBezTo>
+                <a:cubicBezTo>
+                  <a:pt x="1241339" y="106021"/>
+                  <a:pt x="1250568" y="99855"/>
+                  <a:pt x="1257300" y="91440"/>
+                </a:cubicBezTo>
+                <a:cubicBezTo>
+                  <a:pt x="1270950" y="74378"/>
+                  <a:pt x="1280884" y="54431"/>
+                  <a:pt x="1295400" y="38100"/>
+                </a:cubicBezTo>
+                <a:cubicBezTo>
+                  <a:pt x="1301484" y="31255"/>
+                  <a:pt x="1310069" y="26956"/>
+                  <a:pt x="1318260" y="22860"/>
+                </a:cubicBezTo>
+                <a:cubicBezTo>
+                  <a:pt x="1346954" y="8513"/>
+                  <a:pt x="1357736" y="7276"/>
+                  <a:pt x="1386840" y="0"/>
+                </a:cubicBezTo>
+                <a:cubicBezTo>
+                  <a:pt x="1450340" y="5080"/>
+                  <a:pt x="1514073" y="7797"/>
+                  <a:pt x="1577340" y="15240"/>
+                </a:cubicBezTo>
+                <a:cubicBezTo>
+                  <a:pt x="1600597" y="17976"/>
+                  <a:pt x="1622957" y="25887"/>
+                  <a:pt x="1645920" y="30480"/>
+                </a:cubicBezTo>
+                <a:cubicBezTo>
+                  <a:pt x="1661070" y="33510"/>
+                  <a:pt x="1676325" y="36058"/>
+                  <a:pt x="1691640" y="38100"/>
+                </a:cubicBezTo>
+                <a:cubicBezTo>
+                  <a:pt x="1783294" y="50321"/>
+                  <a:pt x="1761968" y="43553"/>
+                  <a:pt x="1874520" y="53340"/>
+                </a:cubicBezTo>
+                <a:cubicBezTo>
+                  <a:pt x="1894921" y="55114"/>
+                  <a:pt x="1915160" y="58420"/>
+                  <a:pt x="1935480" y="60960"/>
+                </a:cubicBezTo>
+                <a:cubicBezTo>
+                  <a:pt x="1943100" y="68580"/>
+                  <a:pt x="1949571" y="77556"/>
+                  <a:pt x="1958340" y="83820"/>
+                </a:cubicBezTo>
+                <a:cubicBezTo>
+                  <a:pt x="1967583" y="90422"/>
+                  <a:pt x="1981548" y="90334"/>
+                  <a:pt x="1988820" y="99060"/>
+                </a:cubicBezTo>
+                <a:cubicBezTo>
+                  <a:pt x="1995524" y="107105"/>
+                  <a:pt x="1992315" y="119914"/>
+                  <a:pt x="1996440" y="129540"/>
+                </a:cubicBezTo>
+                <a:cubicBezTo>
+                  <a:pt x="2007627" y="155642"/>
+                  <a:pt x="2025560" y="178799"/>
+                  <a:pt x="2034540" y="205740"/>
+                </a:cubicBezTo>
+                <a:cubicBezTo>
+                  <a:pt x="2039620" y="220980"/>
+                  <a:pt x="2040869" y="238094"/>
+                  <a:pt x="2049780" y="251460"/>
+                </a:cubicBezTo>
+                <a:cubicBezTo>
+                  <a:pt x="2068028" y="278832"/>
+                  <a:pt x="2085462" y="305993"/>
+                  <a:pt x="2110740" y="327660"/>
+                </a:cubicBezTo>
+                <a:cubicBezTo>
+                  <a:pt x="2120383" y="335925"/>
+                  <a:pt x="2131577" y="342255"/>
+                  <a:pt x="2141220" y="350520"/>
+                </a:cubicBezTo>
+                <a:cubicBezTo>
+                  <a:pt x="2149402" y="357533"/>
+                  <a:pt x="2154592" y="368271"/>
+                  <a:pt x="2164080" y="373380"/>
+                </a:cubicBezTo>
+                <a:cubicBezTo>
+                  <a:pt x="2204788" y="395300"/>
+                  <a:pt x="2247448" y="409991"/>
+                  <a:pt x="2293620" y="411480"/>
+                </a:cubicBezTo>
+                <a:cubicBezTo>
+                  <a:pt x="2354548" y="413445"/>
+                  <a:pt x="2415540" y="411480"/>
+                  <a:pt x="2476500" y="411480"/>
+                </a:cubicBezTo>
+              </a:path>
+            </a:pathLst>
+          </a:custGeom>
+          <a:noFill/>
+          <a:ln>
+            <a:prstDash val="sysDash"/>
+            <a:extLst>
+              <a:ext uri="{C807C97D-BFC1-408E-A445-0C87EB9F89A2}">
+                <ask:lineSketchStyleProps xmlns:ask="http://schemas.microsoft.com/office/drawing/2018/sketchyshapes" sd="1219033472">
+                  <a:custGeom>
+                    <a:avLst/>
+                    <a:gdLst>
+                      <a:gd name="connsiteX0" fmla="*/ 3383102 w 3588842"/>
+                      <a:gd name="connsiteY0" fmla="*/ 0 h 1380093"/>
+                      <a:gd name="connsiteX1" fmla="*/ 3482162 w 3588842"/>
+                      <a:gd name="connsiteY1" fmla="*/ 22860 h 1380093"/>
+                      <a:gd name="connsiteX2" fmla="*/ 3588842 w 3588842"/>
+                      <a:gd name="connsiteY2" fmla="*/ 144780 h 1380093"/>
+                      <a:gd name="connsiteX3" fmla="*/ 3527882 w 3588842"/>
+                      <a:gd name="connsiteY3" fmla="*/ 266700 h 1380093"/>
+                      <a:gd name="connsiteX4" fmla="*/ 3436442 w 3588842"/>
+                      <a:gd name="connsiteY4" fmla="*/ 312420 h 1380093"/>
+                      <a:gd name="connsiteX5" fmla="*/ 3345002 w 3588842"/>
+                      <a:gd name="connsiteY5" fmla="*/ 365760 h 1380093"/>
+                      <a:gd name="connsiteX6" fmla="*/ 2918282 w 3588842"/>
+                      <a:gd name="connsiteY6" fmla="*/ 419100 h 1380093"/>
+                      <a:gd name="connsiteX7" fmla="*/ 1950542 w 3588842"/>
+                      <a:gd name="connsiteY7" fmla="*/ 312420 h 1380093"/>
+                      <a:gd name="connsiteX8" fmla="*/ 1721942 w 3588842"/>
+                      <a:gd name="connsiteY8" fmla="*/ 198120 h 1380093"/>
+                      <a:gd name="connsiteX9" fmla="*/ 1417142 w 3588842"/>
+                      <a:gd name="connsiteY9" fmla="*/ 137160 h 1380093"/>
+                      <a:gd name="connsiteX10" fmla="*/ 1279982 w 3588842"/>
+                      <a:gd name="connsiteY10" fmla="*/ 167640 h 1380093"/>
+                      <a:gd name="connsiteX11" fmla="*/ 1188542 w 3588842"/>
+                      <a:gd name="connsiteY11" fmla="*/ 190500 h 1380093"/>
+                      <a:gd name="connsiteX12" fmla="*/ 1135202 w 3588842"/>
+                      <a:gd name="connsiteY12" fmla="*/ 205740 h 1380093"/>
+                      <a:gd name="connsiteX13" fmla="*/ 1074242 w 3588842"/>
+                      <a:gd name="connsiteY13" fmla="*/ 236220 h 1380093"/>
+                      <a:gd name="connsiteX14" fmla="*/ 1020902 w 3588842"/>
+                      <a:gd name="connsiteY14" fmla="*/ 266700 h 1380093"/>
+                      <a:gd name="connsiteX15" fmla="*/ 883742 w 3588842"/>
+                      <a:gd name="connsiteY15" fmla="*/ 320040 h 1380093"/>
+                      <a:gd name="connsiteX16" fmla="*/ 815162 w 3588842"/>
+                      <a:gd name="connsiteY16" fmla="*/ 342900 h 1380093"/>
+                      <a:gd name="connsiteX17" fmla="*/ 586562 w 3588842"/>
+                      <a:gd name="connsiteY17" fmla="*/ 373380 h 1380093"/>
+                      <a:gd name="connsiteX18" fmla="*/ 533222 w 3588842"/>
+                      <a:gd name="connsiteY18" fmla="*/ 388620 h 1380093"/>
+                      <a:gd name="connsiteX19" fmla="*/ 457022 w 3588842"/>
+                      <a:gd name="connsiteY19" fmla="*/ 419100 h 1380093"/>
+                      <a:gd name="connsiteX20" fmla="*/ 426542 w 3588842"/>
+                      <a:gd name="connsiteY20" fmla="*/ 434340 h 1380093"/>
+                      <a:gd name="connsiteX21" fmla="*/ 373202 w 3588842"/>
+                      <a:gd name="connsiteY21" fmla="*/ 457200 h 1380093"/>
+                      <a:gd name="connsiteX22" fmla="*/ 297002 w 3588842"/>
+                      <a:gd name="connsiteY22" fmla="*/ 495300 h 1380093"/>
+                      <a:gd name="connsiteX23" fmla="*/ 213182 w 3588842"/>
+                      <a:gd name="connsiteY23" fmla="*/ 556260 h 1380093"/>
+                      <a:gd name="connsiteX24" fmla="*/ 197942 w 3588842"/>
+                      <a:gd name="connsiteY24" fmla="*/ 586740 h 1380093"/>
+                      <a:gd name="connsiteX25" fmla="*/ 167462 w 3588842"/>
+                      <a:gd name="connsiteY25" fmla="*/ 609600 h 1380093"/>
+                      <a:gd name="connsiteX26" fmla="*/ 144602 w 3588842"/>
+                      <a:gd name="connsiteY26" fmla="*/ 632460 h 1380093"/>
+                      <a:gd name="connsiteX27" fmla="*/ 83642 w 3588842"/>
+                      <a:gd name="connsiteY27" fmla="*/ 708660 h 1380093"/>
+                      <a:gd name="connsiteX28" fmla="*/ 22682 w 3588842"/>
+                      <a:gd name="connsiteY28" fmla="*/ 792480 h 1380093"/>
+                      <a:gd name="connsiteX29" fmla="*/ 37922 w 3588842"/>
+                      <a:gd name="connsiteY29" fmla="*/ 1242060 h 1380093"/>
+                      <a:gd name="connsiteX30" fmla="*/ 76022 w 3588842"/>
+                      <a:gd name="connsiteY30" fmla="*/ 1318260 h 1380093"/>
+                      <a:gd name="connsiteX31" fmla="*/ 98882 w 3588842"/>
+                      <a:gd name="connsiteY31" fmla="*/ 1333500 h 1380093"/>
+                      <a:gd name="connsiteX32" fmla="*/ 152222 w 3588842"/>
+                      <a:gd name="connsiteY32" fmla="*/ 1371600 h 1380093"/>
+                      <a:gd name="connsiteX33" fmla="*/ 205562 w 3588842"/>
+                      <a:gd name="connsiteY33" fmla="*/ 1379220 h 1380093"/>
+                      <a:gd name="connsiteX34" fmla="*/ 388442 w 3588842"/>
+                      <a:gd name="connsiteY34" fmla="*/ 1379220 h 1380093"/>
+                    </a:gdLst>
+                    <a:ahLst/>
+                    <a:cxnLst>
+                      <a:cxn ang="0">
+                        <a:pos x="connsiteX0" y="connsiteY0"/>
+                      </a:cxn>
+                      <a:cxn ang="0">
+                        <a:pos x="connsiteX1" y="connsiteY1"/>
+                      </a:cxn>
+                      <a:cxn ang="0">
+                        <a:pos x="connsiteX2" y="connsiteY2"/>
+                      </a:cxn>
+                      <a:cxn ang="0">
+                        <a:pos x="connsiteX3" y="connsiteY3"/>
+                      </a:cxn>
+                      <a:cxn ang="0">
+                        <a:pos x="connsiteX4" y="connsiteY4"/>
+                      </a:cxn>
+                      <a:cxn ang="0">
+                        <a:pos x="connsiteX5" y="connsiteY5"/>
+                      </a:cxn>
+                      <a:cxn ang="0">
+                        <a:pos x="connsiteX6" y="connsiteY6"/>
+                      </a:cxn>
+                      <a:cxn ang="0">
+                        <a:pos x="connsiteX7" y="connsiteY7"/>
+                      </a:cxn>
+                      <a:cxn ang="0">
+                        <a:pos x="connsiteX8" y="connsiteY8"/>
+                      </a:cxn>
+                      <a:cxn ang="0">
+                        <a:pos x="connsiteX9" y="connsiteY9"/>
+                      </a:cxn>
+                      <a:cxn ang="0">
+                        <a:pos x="connsiteX10" y="connsiteY10"/>
+                      </a:cxn>
+                      <a:cxn ang="0">
+                        <a:pos x="connsiteX11" y="connsiteY11"/>
+                      </a:cxn>
+                      <a:cxn ang="0">
+                        <a:pos x="connsiteX12" y="connsiteY12"/>
+                      </a:cxn>
+                      <a:cxn ang="0">
+                        <a:pos x="connsiteX13" y="connsiteY13"/>
+                      </a:cxn>
+                      <a:cxn ang="0">
+                        <a:pos x="connsiteX14" y="connsiteY14"/>
+                      </a:cxn>
+                      <a:cxn ang="0">
+                        <a:pos x="connsiteX15" y="connsiteY15"/>
+                      </a:cxn>
+                      <a:cxn ang="0">
+                        <a:pos x="connsiteX16" y="connsiteY16"/>
+                      </a:cxn>
+                      <a:cxn ang="0">
+                        <a:pos x="connsiteX17" y="connsiteY17"/>
+                      </a:cxn>
+                      <a:cxn ang="0">
+                        <a:pos x="connsiteX18" y="connsiteY18"/>
+                      </a:cxn>
+                      <a:cxn ang="0">
+                        <a:pos x="connsiteX19" y="connsiteY19"/>
+                      </a:cxn>
+                      <a:cxn ang="0">
+                        <a:pos x="connsiteX20" y="connsiteY20"/>
+                      </a:cxn>
+                      <a:cxn ang="0">
+                        <a:pos x="connsiteX21" y="connsiteY21"/>
+                      </a:cxn>
+                      <a:cxn ang="0">
+                        <a:pos x="connsiteX22" y="connsiteY22"/>
+                      </a:cxn>
+                      <a:cxn ang="0">
+                        <a:pos x="connsiteX23" y="connsiteY23"/>
+                      </a:cxn>
+                      <a:cxn ang="0">
+                        <a:pos x="connsiteX24" y="connsiteY24"/>
+                      </a:cxn>
+                      <a:cxn ang="0">
+                        <a:pos x="connsiteX25" y="connsiteY25"/>
+                      </a:cxn>
+                      <a:cxn ang="0">
+                        <a:pos x="connsiteX26" y="connsiteY26"/>
+                      </a:cxn>
+                      <a:cxn ang="0">
+                        <a:pos x="connsiteX27" y="connsiteY27"/>
+                      </a:cxn>
+                      <a:cxn ang="0">
+                        <a:pos x="connsiteX28" y="connsiteY28"/>
+                      </a:cxn>
+                      <a:cxn ang="0">
+                        <a:pos x="connsiteX29" y="connsiteY29"/>
+                      </a:cxn>
+                      <a:cxn ang="0">
+                        <a:pos x="connsiteX30" y="connsiteY30"/>
+                      </a:cxn>
+                      <a:cxn ang="0">
+                        <a:pos x="connsiteX31" y="connsiteY31"/>
+                      </a:cxn>
+                      <a:cxn ang="0">
+                        <a:pos x="connsiteX32" y="connsiteY32"/>
+                      </a:cxn>
+                      <a:cxn ang="0">
+                        <a:pos x="connsiteX33" y="connsiteY33"/>
+                      </a:cxn>
+                      <a:cxn ang="0">
+                        <a:pos x="connsiteX34" y="connsiteY34"/>
+                      </a:cxn>
+                    </a:cxnLst>
+                    <a:rect l="l" t="t" r="r" b="b"/>
+                    <a:pathLst>
+                      <a:path w="3588842" h="1380093" extrusionOk="0">
+                        <a:moveTo>
+                          <a:pt x="3383102" y="0"/>
+                        </a:moveTo>
+                        <a:cubicBezTo>
+                          <a:pt x="3414902" y="6867"/>
+                          <a:pt x="3443625" y="10793"/>
+                          <a:pt x="3482162" y="22860"/>
+                        </a:cubicBezTo>
+                        <a:cubicBezTo>
+                          <a:pt x="3540074" y="51237"/>
+                          <a:pt x="3554756" y="96331"/>
+                          <a:pt x="3588842" y="144780"/>
+                        </a:cubicBezTo>
+                        <a:cubicBezTo>
+                          <a:pt x="3560696" y="193063"/>
+                          <a:pt x="3557979" y="235660"/>
+                          <a:pt x="3527882" y="266700"/>
+                        </a:cubicBezTo>
+                        <a:cubicBezTo>
+                          <a:pt x="3496785" y="287443"/>
+                          <a:pt x="3472502" y="299101"/>
+                          <a:pt x="3436442" y="312420"/>
+                        </a:cubicBezTo>
+                        <a:cubicBezTo>
+                          <a:pt x="3410760" y="329861"/>
+                          <a:pt x="3379278" y="351010"/>
+                          <a:pt x="3345002" y="365760"/>
+                        </a:cubicBezTo>
+                        <a:cubicBezTo>
+                          <a:pt x="3162646" y="428744"/>
+                          <a:pt x="3111256" y="416360"/>
+                          <a:pt x="2918282" y="419100"/>
+                        </a:cubicBezTo>
+                        <a:cubicBezTo>
+                          <a:pt x="2497818" y="386522"/>
+                          <a:pt x="2296288" y="463786"/>
+                          <a:pt x="1950542" y="312420"/>
+                        </a:cubicBezTo>
+                        <a:cubicBezTo>
+                          <a:pt x="1890332" y="296264"/>
+                          <a:pt x="1809447" y="230221"/>
+                          <a:pt x="1721942" y="198120"/>
+                        </a:cubicBezTo>
+                        <a:cubicBezTo>
+                          <a:pt x="1571914" y="144079"/>
+                          <a:pt x="1546285" y="154493"/>
+                          <a:pt x="1417142" y="137160"/>
+                        </a:cubicBezTo>
+                        <a:cubicBezTo>
+                          <a:pt x="1324100" y="161524"/>
+                          <a:pt x="1395677" y="159391"/>
+                          <a:pt x="1279982" y="167640"/>
+                        </a:cubicBezTo>
+                        <a:cubicBezTo>
+                          <a:pt x="1252634" y="180471"/>
+                          <a:pt x="1220657" y="184624"/>
+                          <a:pt x="1188542" y="190500"/>
+                        </a:cubicBezTo>
+                        <a:cubicBezTo>
+                          <a:pt x="1174356" y="191969"/>
+                          <a:pt x="1154040" y="195683"/>
+                          <a:pt x="1135202" y="205740"/>
+                        </a:cubicBezTo>
+                        <a:cubicBezTo>
+                          <a:pt x="1076724" y="241954"/>
+                          <a:pt x="1136189" y="190232"/>
+                          <a:pt x="1074242" y="236220"/>
+                        </a:cubicBezTo>
+                        <a:cubicBezTo>
+                          <a:pt x="1054660" y="245288"/>
+                          <a:pt x="1036822" y="252658"/>
+                          <a:pt x="1020902" y="266700"/>
+                        </a:cubicBezTo>
+                        <a:cubicBezTo>
+                          <a:pt x="960784" y="293091"/>
+                          <a:pt x="944418" y="300453"/>
+                          <a:pt x="883742" y="320040"/>
+                        </a:cubicBezTo>
+                        <a:cubicBezTo>
+                          <a:pt x="858738" y="331493"/>
+                          <a:pt x="839628" y="340431"/>
+                          <a:pt x="815162" y="342900"/>
+                        </a:cubicBezTo>
+                        <a:cubicBezTo>
+                          <a:pt x="802491" y="362947"/>
+                          <a:pt x="655881" y="353552"/>
+                          <a:pt x="586562" y="373380"/>
+                        </a:cubicBezTo>
+                        <a:cubicBezTo>
+                          <a:pt x="567826" y="379130"/>
+                          <a:pt x="548790" y="383658"/>
+                          <a:pt x="533222" y="388620"/>
+                        </a:cubicBezTo>
+                        <a:cubicBezTo>
+                          <a:pt x="463316" y="454785"/>
+                          <a:pt x="515717" y="403462"/>
+                          <a:pt x="457022" y="419100"/>
+                        </a:cubicBezTo>
+                        <a:cubicBezTo>
+                          <a:pt x="446402" y="421801"/>
+                          <a:pt x="434035" y="429479"/>
+                          <a:pt x="426542" y="434340"/>
+                        </a:cubicBezTo>
+                        <a:cubicBezTo>
+                          <a:pt x="412809" y="445683"/>
+                          <a:pt x="388938" y="454300"/>
+                          <a:pt x="373202" y="457200"/>
+                        </a:cubicBezTo>
+                        <a:cubicBezTo>
+                          <a:pt x="344832" y="474662"/>
+                          <a:pt x="313305" y="470209"/>
+                          <a:pt x="297002" y="495300"/>
+                        </a:cubicBezTo>
+                        <a:cubicBezTo>
+                          <a:pt x="249517" y="546282"/>
+                          <a:pt x="274618" y="518142"/>
+                          <a:pt x="213182" y="556260"/>
+                        </a:cubicBezTo>
+                        <a:cubicBezTo>
+                          <a:pt x="209782" y="567479"/>
+                          <a:pt x="203226" y="578578"/>
+                          <a:pt x="197942" y="586740"/>
+                        </a:cubicBezTo>
+                        <a:cubicBezTo>
+                          <a:pt x="189307" y="597537"/>
+                          <a:pt x="176764" y="600261"/>
+                          <a:pt x="167462" y="609600"/>
+                        </a:cubicBezTo>
+                        <a:cubicBezTo>
+                          <a:pt x="160736" y="615519"/>
+                          <a:pt x="151678" y="624034"/>
+                          <a:pt x="144602" y="632460"/>
+                        </a:cubicBezTo>
+                        <a:cubicBezTo>
+                          <a:pt x="120647" y="656162"/>
+                          <a:pt x="105800" y="681796"/>
+                          <a:pt x="83642" y="708660"/>
+                        </a:cubicBezTo>
+                        <a:cubicBezTo>
+                          <a:pt x="21688" y="777532"/>
+                          <a:pt x="62425" y="744485"/>
+                          <a:pt x="22682" y="792480"/>
+                        </a:cubicBezTo>
+                        <a:cubicBezTo>
+                          <a:pt x="9000" y="949438"/>
+                          <a:pt x="-727" y="872825"/>
+                          <a:pt x="37922" y="1242060"/>
+                        </a:cubicBezTo>
+                        <a:cubicBezTo>
+                          <a:pt x="43782" y="1252204"/>
+                          <a:pt x="61147" y="1301042"/>
+                          <a:pt x="76022" y="1318260"/>
+                        </a:cubicBezTo>
+                        <a:cubicBezTo>
+                          <a:pt x="83770" y="1324776"/>
+                          <a:pt x="92239" y="1329015"/>
+                          <a:pt x="98882" y="1333500"/>
+                        </a:cubicBezTo>
+                        <a:cubicBezTo>
+                          <a:pt x="99846" y="1334414"/>
+                          <a:pt x="146122" y="1369966"/>
+                          <a:pt x="152222" y="1371600"/>
+                        </a:cubicBezTo>
+                        <a:cubicBezTo>
+                          <a:pt x="170689" y="1378011"/>
+                          <a:pt x="187358" y="1378303"/>
+                          <a:pt x="205562" y="1379220"/>
+                        </a:cubicBezTo>
+                        <a:cubicBezTo>
+                          <a:pt x="259295" y="1388327"/>
+                          <a:pt x="344736" y="1383092"/>
+                          <a:pt x="388442" y="1379220"/>
+                        </a:cubicBezTo>
+                      </a:path>
+                    </a:pathLst>
+                  </a:custGeom>
+                  <ask:type>
+                    <ask:lineSketchNone/>
+                  </ask:type>
+                </ask:lineSketchStyleProps>
+              </a:ext>
+            </a:extLst>
+          </a:ln>
+        </p:spPr>
+        <p:style>
+          <a:lnRef idx="2">
+            <a:schemeClr val="accent1">
+              <a:shade val="15000"/>
+            </a:schemeClr>
+          </a:lnRef>
+          <a:fillRef idx="1">
+            <a:schemeClr val="accent1"/>
+          </a:fillRef>
+          <a:effectRef idx="0">
+            <a:schemeClr val="accent1"/>
+          </a:effectRef>
+          <a:fontRef idx="minor">
+            <a:schemeClr val="lt1"/>
+          </a:fontRef>
+        </p:style>
+        <p:txBody>
+          <a:bodyPr rtlCol="0" anchor="ctr"/>
+          <a:lstStyle/>
+          <a:p>
+            <a:pPr algn="ctr"/>
+            <a:endParaRPr lang="de-DE"/>
+          </a:p>
+        </p:txBody>
+      </p:sp>
+      <p:sp>
+        <p:nvSpPr>
+          <p:cNvPr id="242" name="Textfeld 241">
+            <a:extLst>
+              <a:ext uri="{FF2B5EF4-FFF2-40B4-BE49-F238E27FC236}">
+                <a16:creationId xmlns:a16="http://schemas.microsoft.com/office/drawing/2014/main" id="{0D231C0D-6463-C864-9484-DD6F16BD0BB8}"/>
+              </a:ext>
+            </a:extLst>
+          </p:cNvPr>
+          <p:cNvSpPr txBox="1"/>
+          <p:nvPr/>
+        </p:nvSpPr>
+        <p:spPr>
+          <a:xfrm>
+            <a:off x="3009474" y="188905"/>
+            <a:ext cx="950901" cy="369332"/>
+          </a:xfrm>
+          <a:prstGeom prst="rect">
+            <a:avLst/>
+          </a:prstGeom>
+          <a:noFill/>
+        </p:spPr>
+        <p:txBody>
+          <a:bodyPr wrap="none" rtlCol="0">
+            <a:spAutoFit/>
+          </a:bodyPr>
+          <a:lstStyle/>
+          <a:p>
+            <a:r>
+              <a:rPr lang="de-DE" dirty="0"/>
+              <a:t>DPMDP</a:t>
+            </a:r>
+          </a:p>
+        </p:txBody>
+      </p:sp>
+      <p:grpSp>
+        <p:nvGrpSpPr>
+          <p:cNvPr id="247" name="Gruppieren 246">
+            <a:extLst>
+              <a:ext uri="{FF2B5EF4-FFF2-40B4-BE49-F238E27FC236}">
+                <a16:creationId xmlns:a16="http://schemas.microsoft.com/office/drawing/2014/main" id="{4E3316D7-8356-538C-278D-A4E4E92DC663}"/>
+              </a:ext>
+            </a:extLst>
+          </p:cNvPr>
+          <p:cNvGrpSpPr/>
+          <p:nvPr/>
+        </p:nvGrpSpPr>
+        <p:grpSpPr>
+          <a:xfrm>
+            <a:off x="7920773" y="3310980"/>
+            <a:ext cx="1198602" cy="573833"/>
+            <a:chOff x="6447292" y="1311006"/>
+            <a:chExt cx="1705213" cy="943107"/>
+          </a:xfrm>
+        </p:grpSpPr>
+        <p:pic>
+          <p:nvPicPr>
+            <p:cNvPr id="246" name="Grafik 245">
+              <a:extLst>
+                <a:ext uri="{FF2B5EF4-FFF2-40B4-BE49-F238E27FC236}">
+                  <a16:creationId xmlns:a16="http://schemas.microsoft.com/office/drawing/2014/main" id="{AF6D52A4-C5DD-F696-BBA8-61A35492DB52}"/>
+                </a:ext>
+              </a:extLst>
+            </p:cNvPr>
+            <p:cNvPicPr>
+              <a:picLocks noChangeAspect="1"/>
+            </p:cNvPicPr>
+            <p:nvPr/>
+          </p:nvPicPr>
+          <p:blipFill>
+            <a:blip r:embed="rId21"/>
+            <a:stretch>
+              <a:fillRect/>
+            </a:stretch>
+          </p:blipFill>
+          <p:spPr>
+            <a:xfrm flipH="1">
+              <a:off x="6447292" y="1311006"/>
+              <a:ext cx="1705213" cy="943107"/>
+            </a:xfrm>
+            <a:prstGeom prst="rect">
+              <a:avLst/>
+            </a:prstGeom>
+          </p:spPr>
+        </p:pic>
+        <p:pic>
+          <p:nvPicPr>
+            <p:cNvPr id="244" name="Grafik 243">
+              <a:extLst>
+                <a:ext uri="{FF2B5EF4-FFF2-40B4-BE49-F238E27FC236}">
+                  <a16:creationId xmlns:a16="http://schemas.microsoft.com/office/drawing/2014/main" id="{F3BB4FEA-4FC0-B790-5A42-0035B2814BE6}"/>
+                </a:ext>
+              </a:extLst>
+            </p:cNvPr>
+            <p:cNvPicPr>
+              <a:picLocks noChangeAspect="1"/>
+            </p:cNvPicPr>
+            <p:nvPr/>
+          </p:nvPicPr>
+          <p:blipFill>
+            <a:blip r:embed="rId22"/>
+            <a:stretch>
+              <a:fillRect/>
+            </a:stretch>
+          </p:blipFill>
+          <p:spPr>
+            <a:xfrm>
+              <a:off x="6935813" y="1782559"/>
+              <a:ext cx="614547" cy="274490"/>
+            </a:xfrm>
+            <a:prstGeom prst="rect">
+              <a:avLst/>
+            </a:prstGeom>
+          </p:spPr>
+        </p:pic>
+      </p:grpSp>
+      <p:sp>
+        <p:nvSpPr>
+          <p:cNvPr id="11" name="Textfeld 10">
+            <a:extLst>
+              <a:ext uri="{FF2B5EF4-FFF2-40B4-BE49-F238E27FC236}">
+                <a16:creationId xmlns:a16="http://schemas.microsoft.com/office/drawing/2014/main" id="{35FE5353-7A03-06C6-B759-0F725520E30E}"/>
+              </a:ext>
+            </a:extLst>
+          </p:cNvPr>
+          <p:cNvSpPr txBox="1"/>
+          <p:nvPr/>
+        </p:nvSpPr>
+        <p:spPr>
+          <a:xfrm>
+            <a:off x="177010" y="185066"/>
+            <a:ext cx="891591" cy="215444"/>
+          </a:xfrm>
+          <a:prstGeom prst="rect">
+            <a:avLst/>
+          </a:prstGeom>
+          <a:noFill/>
+        </p:spPr>
+        <p:txBody>
+          <a:bodyPr wrap="none" rtlCol="0">
+            <a:spAutoFit/>
+          </a:bodyPr>
+          <a:lstStyle/>
+          <a:p>
+            <a:r>
+              <a:rPr lang="en-US" sz="800" noProof="0" dirty="0"/>
+              <a:t>Design #251228</a:t>
+            </a:r>
+          </a:p>
+        </p:txBody>
+      </p:sp>
+      <p:sp>
+        <p:nvSpPr>
+          <p:cNvPr id="7" name="Zylinder 6">
+            <a:extLst>
+              <a:ext uri="{FF2B5EF4-FFF2-40B4-BE49-F238E27FC236}">
+                <a16:creationId xmlns:a16="http://schemas.microsoft.com/office/drawing/2014/main" id="{55D439C3-42B8-FDB5-468E-D49C7176395B}"/>
+              </a:ext>
+            </a:extLst>
+          </p:cNvPr>
+          <p:cNvSpPr/>
+          <p:nvPr/>
+        </p:nvSpPr>
+        <p:spPr>
+          <a:xfrm>
+            <a:off x="377630" y="2997331"/>
+            <a:ext cx="684245" cy="391898"/>
+          </a:xfrm>
+          <a:prstGeom prst="can">
+            <a:avLst/>
+          </a:prstGeom>
+        </p:spPr>
+        <p:style>
+          <a:lnRef idx="2">
+            <a:schemeClr val="accent3">
+              <a:shade val="15000"/>
+            </a:schemeClr>
+          </a:lnRef>
+          <a:fillRef idx="1">
+            <a:schemeClr val="accent3"/>
+          </a:fillRef>
+          <a:effectRef idx="0">
+            <a:schemeClr val="accent3"/>
+          </a:effectRef>
+          <a:fontRef idx="minor">
+            <a:schemeClr val="lt1"/>
+          </a:fontRef>
+        </p:style>
+        <p:txBody>
+          <a:bodyPr rtlCol="0" anchor="ctr"/>
+          <a:lstStyle/>
+          <a:p>
+            <a:pPr algn="ctr"/>
+            <a:r>
+              <a:rPr lang="de-DE" sz="800" dirty="0"/>
+              <a:t>MWDI ES</a:t>
+            </a:r>
+          </a:p>
+        </p:txBody>
+      </p:sp>
+      <p:sp>
+        <p:nvSpPr>
+          <p:cNvPr id="21" name="Zylinder 20">
+            <a:extLst>
+              <a:ext uri="{FF2B5EF4-FFF2-40B4-BE49-F238E27FC236}">
+                <a16:creationId xmlns:a16="http://schemas.microsoft.com/office/drawing/2014/main" id="{EDD8DF57-C4DC-0274-04C7-AE0C3064004D}"/>
+              </a:ext>
+            </a:extLst>
+          </p:cNvPr>
+          <p:cNvSpPr/>
+          <p:nvPr/>
+        </p:nvSpPr>
+        <p:spPr>
+          <a:xfrm>
+            <a:off x="2790567" y="3032193"/>
+            <a:ext cx="684245" cy="391898"/>
+          </a:xfrm>
+          <a:prstGeom prst="can">
+            <a:avLst/>
+          </a:prstGeom>
+        </p:spPr>
+        <p:style>
+          <a:lnRef idx="2">
+            <a:schemeClr val="accent3">
+              <a:shade val="15000"/>
+            </a:schemeClr>
+          </a:lnRef>
+          <a:fillRef idx="1">
+            <a:schemeClr val="accent3"/>
+          </a:fillRef>
+          <a:effectRef idx="0">
+            <a:schemeClr val="accent3"/>
+          </a:effectRef>
+          <a:fontRef idx="minor">
+            <a:schemeClr val="lt1"/>
+          </a:fontRef>
+        </p:style>
+        <p:txBody>
+          <a:bodyPr tIns="108000" rtlCol="0" anchor="ctr"/>
+          <a:lstStyle/>
+          <a:p>
+            <a:pPr algn="ctr"/>
+            <a:r>
+              <a:rPr lang="de-DE" sz="800" dirty="0"/>
+              <a:t>MWDI ES</a:t>
+            </a:r>
+            <a:br>
+              <a:rPr lang="de-DE" sz="800" dirty="0"/>
+            </a:br>
+            <a:r>
+              <a:rPr lang="de-DE" sz="800" dirty="0"/>
+              <a:t>Replica</a:t>
+            </a:r>
+          </a:p>
+        </p:txBody>
+      </p:sp>
+      <p:sp>
+        <p:nvSpPr>
+          <p:cNvPr id="26" name="Pfeil: eingekerbt nach rechts 25">
+            <a:extLst>
+              <a:ext uri="{FF2B5EF4-FFF2-40B4-BE49-F238E27FC236}">
+                <a16:creationId xmlns:a16="http://schemas.microsoft.com/office/drawing/2014/main" id="{3BFD74B8-D723-4F5F-DE79-EC607AF52C54}"/>
+              </a:ext>
+            </a:extLst>
+          </p:cNvPr>
+          <p:cNvSpPr/>
+          <p:nvPr/>
+        </p:nvSpPr>
+        <p:spPr>
+          <a:xfrm>
+            <a:off x="1692675" y="3088191"/>
+            <a:ext cx="684244" cy="232413"/>
+          </a:xfrm>
+          <a:prstGeom prst="notchedRightArrow">
+            <a:avLst/>
+          </a:prstGeom>
+        </p:spPr>
+        <p:style>
+          <a:lnRef idx="2">
+            <a:schemeClr val="accent3">
+              <a:shade val="15000"/>
+            </a:schemeClr>
+          </a:lnRef>
+          <a:fillRef idx="1">
+            <a:schemeClr val="accent3"/>
+          </a:fillRef>
+          <a:effectRef idx="0">
+            <a:schemeClr val="accent3"/>
+          </a:effectRef>
+          <a:fontRef idx="minor">
+            <a:schemeClr val="lt1"/>
+          </a:fontRef>
+        </p:style>
+        <p:txBody>
+          <a:bodyPr rtlCol="0" anchor="ctr"/>
+          <a:lstStyle/>
+          <a:p>
+            <a:pPr algn="ctr"/>
+            <a:endParaRPr lang="de-DE" sz="800"/>
+          </a:p>
+        </p:txBody>
+      </p:sp>
+      <p:sp>
+        <p:nvSpPr>
+          <p:cNvPr id="61" name="Textfeld 60">
+            <a:extLst>
+              <a:ext uri="{FF2B5EF4-FFF2-40B4-BE49-F238E27FC236}">
+                <a16:creationId xmlns:a16="http://schemas.microsoft.com/office/drawing/2014/main" id="{02096C68-F162-ABF8-D72C-D9F0171913A1}"/>
+              </a:ext>
+            </a:extLst>
+          </p:cNvPr>
+          <p:cNvSpPr txBox="1"/>
+          <p:nvPr/>
+        </p:nvSpPr>
+        <p:spPr>
+          <a:xfrm>
+            <a:off x="1667895" y="2872747"/>
+            <a:ext cx="656296" cy="215444"/>
+          </a:xfrm>
+          <a:prstGeom prst="rect">
+            <a:avLst/>
+          </a:prstGeom>
+          <a:noFill/>
+        </p:spPr>
+        <p:txBody>
+          <a:bodyPr wrap="square" rtlCol="0">
+            <a:spAutoFit/>
+          </a:bodyPr>
+          <a:lstStyle/>
+          <a:p>
+            <a:pPr algn="ctr"/>
+            <a:r>
+              <a:rPr lang="en-US" sz="800" dirty="0"/>
+              <a:t>replication</a:t>
+            </a:r>
+          </a:p>
+        </p:txBody>
+      </p:sp>
+      <p:sp>
+        <p:nvSpPr>
+          <p:cNvPr id="37" name="Legende: Linie 36">
+            <a:extLst>
+              <a:ext uri="{FF2B5EF4-FFF2-40B4-BE49-F238E27FC236}">
+                <a16:creationId xmlns:a16="http://schemas.microsoft.com/office/drawing/2014/main" id="{ED299136-9B06-034B-3D67-7B84CCFDDD0B}"/>
+              </a:ext>
+            </a:extLst>
+          </p:cNvPr>
+          <p:cNvSpPr/>
+          <p:nvPr/>
+        </p:nvSpPr>
+        <p:spPr>
+          <a:xfrm>
+            <a:off x="4730611" y="2213275"/>
+            <a:ext cx="1250577" cy="215444"/>
+          </a:xfrm>
+          <a:prstGeom prst="borderCallout1">
+            <a:avLst>
+              <a:gd name="adj1" fmla="val 51908"/>
+              <a:gd name="adj2" fmla="val -1600"/>
+              <a:gd name="adj3" fmla="val 138539"/>
+              <a:gd name="adj4" fmla="val -35132"/>
+            </a:avLst>
+          </a:prstGeom>
+          <a:noFill/>
+          <a:ln w="6350">
+            <a:solidFill>
+              <a:schemeClr val="accent1">
+                <a:shade val="15000"/>
+              </a:schemeClr>
+            </a:solidFill>
+          </a:ln>
+        </p:spPr>
+        <p:txBody>
+          <a:bodyPr wrap="square" rtlCol="0">
+            <a:spAutoFit/>
+          </a:bodyPr>
+          <a:lstStyle/>
+          <a:p>
+            <a:r>
+              <a:rPr lang="de-DE" sz="800" dirty="0"/>
+              <a:t>p1ProcessDevice</a:t>
+            </a:r>
+            <a:endParaRPr lang="de-DE" sz="800" dirty="0">
+              <a:solidFill>
+                <a:schemeClr val="tx1"/>
+              </a:solidFill>
+            </a:endParaRPr>
+          </a:p>
+        </p:txBody>
+      </p:sp>
+      <p:sp>
+        <p:nvSpPr>
+          <p:cNvPr id="41" name="Freihandform: Form 40">
+            <a:extLst>
+              <a:ext uri="{FF2B5EF4-FFF2-40B4-BE49-F238E27FC236}">
+                <a16:creationId xmlns:a16="http://schemas.microsoft.com/office/drawing/2014/main" id="{E650083B-E936-4C04-65CE-5FF8579AB1E7}"/>
+              </a:ext>
+            </a:extLst>
+          </p:cNvPr>
+          <p:cNvSpPr/>
+          <p:nvPr/>
+        </p:nvSpPr>
+        <p:spPr>
+          <a:xfrm>
+            <a:off x="171450" y="2828925"/>
+            <a:ext cx="4758788" cy="2464594"/>
+          </a:xfrm>
+          <a:custGeom>
+            <a:avLst/>
+            <a:gdLst>
+              <a:gd name="connsiteX0" fmla="*/ 3629025 w 4758788"/>
+              <a:gd name="connsiteY0" fmla="*/ 21431 h 2464594"/>
+              <a:gd name="connsiteX1" fmla="*/ 3664744 w 4758788"/>
+              <a:gd name="connsiteY1" fmla="*/ 14288 h 2464594"/>
+              <a:gd name="connsiteX2" fmla="*/ 3893344 w 4758788"/>
+              <a:gd name="connsiteY2" fmla="*/ 0 h 2464594"/>
+              <a:gd name="connsiteX3" fmla="*/ 4064794 w 4758788"/>
+              <a:gd name="connsiteY3" fmla="*/ 7144 h 2464594"/>
+              <a:gd name="connsiteX4" fmla="*/ 4129088 w 4758788"/>
+              <a:gd name="connsiteY4" fmla="*/ 14288 h 2464594"/>
+              <a:gd name="connsiteX5" fmla="*/ 4214813 w 4758788"/>
+              <a:gd name="connsiteY5" fmla="*/ 21431 h 2464594"/>
+              <a:gd name="connsiteX6" fmla="*/ 4279106 w 4758788"/>
+              <a:gd name="connsiteY6" fmla="*/ 35719 h 2464594"/>
+              <a:gd name="connsiteX7" fmla="*/ 4379119 w 4758788"/>
+              <a:gd name="connsiteY7" fmla="*/ 42863 h 2464594"/>
+              <a:gd name="connsiteX8" fmla="*/ 4421981 w 4758788"/>
+              <a:gd name="connsiteY8" fmla="*/ 50006 h 2464594"/>
+              <a:gd name="connsiteX9" fmla="*/ 4529138 w 4758788"/>
+              <a:gd name="connsiteY9" fmla="*/ 64294 h 2464594"/>
+              <a:gd name="connsiteX10" fmla="*/ 4579144 w 4758788"/>
+              <a:gd name="connsiteY10" fmla="*/ 78581 h 2464594"/>
+              <a:gd name="connsiteX11" fmla="*/ 4629150 w 4758788"/>
+              <a:gd name="connsiteY11" fmla="*/ 107156 h 2464594"/>
+              <a:gd name="connsiteX12" fmla="*/ 4700588 w 4758788"/>
+              <a:gd name="connsiteY12" fmla="*/ 135731 h 2464594"/>
+              <a:gd name="connsiteX13" fmla="*/ 4722019 w 4758788"/>
+              <a:gd name="connsiteY13" fmla="*/ 164306 h 2464594"/>
+              <a:gd name="connsiteX14" fmla="*/ 4736306 w 4758788"/>
+              <a:gd name="connsiteY14" fmla="*/ 207169 h 2464594"/>
+              <a:gd name="connsiteX15" fmla="*/ 4750594 w 4758788"/>
+              <a:gd name="connsiteY15" fmla="*/ 242888 h 2464594"/>
+              <a:gd name="connsiteX16" fmla="*/ 4750594 w 4758788"/>
+              <a:gd name="connsiteY16" fmla="*/ 342900 h 2464594"/>
+              <a:gd name="connsiteX17" fmla="*/ 4650581 w 4758788"/>
+              <a:gd name="connsiteY17" fmla="*/ 485775 h 2464594"/>
+              <a:gd name="connsiteX18" fmla="*/ 4521994 w 4758788"/>
+              <a:gd name="connsiteY18" fmla="*/ 607219 h 2464594"/>
+              <a:gd name="connsiteX19" fmla="*/ 4400550 w 4758788"/>
+              <a:gd name="connsiteY19" fmla="*/ 685800 h 2464594"/>
+              <a:gd name="connsiteX20" fmla="*/ 4200525 w 4758788"/>
+              <a:gd name="connsiteY20" fmla="*/ 757238 h 2464594"/>
+              <a:gd name="connsiteX21" fmla="*/ 4014788 w 4758788"/>
+              <a:gd name="connsiteY21" fmla="*/ 842963 h 2464594"/>
+              <a:gd name="connsiteX22" fmla="*/ 3864769 w 4758788"/>
+              <a:gd name="connsiteY22" fmla="*/ 878681 h 2464594"/>
+              <a:gd name="connsiteX23" fmla="*/ 3700463 w 4758788"/>
+              <a:gd name="connsiteY23" fmla="*/ 928688 h 2464594"/>
+              <a:gd name="connsiteX24" fmla="*/ 3500438 w 4758788"/>
+              <a:gd name="connsiteY24" fmla="*/ 978694 h 2464594"/>
+              <a:gd name="connsiteX25" fmla="*/ 3078956 w 4758788"/>
+              <a:gd name="connsiteY25" fmla="*/ 1085850 h 2464594"/>
+              <a:gd name="connsiteX26" fmla="*/ 2686050 w 4758788"/>
+              <a:gd name="connsiteY26" fmla="*/ 1121569 h 2464594"/>
+              <a:gd name="connsiteX27" fmla="*/ 2414588 w 4758788"/>
+              <a:gd name="connsiteY27" fmla="*/ 1150144 h 2464594"/>
+              <a:gd name="connsiteX28" fmla="*/ 1835944 w 4758788"/>
+              <a:gd name="connsiteY28" fmla="*/ 1164431 h 2464594"/>
+              <a:gd name="connsiteX29" fmla="*/ 1678781 w 4758788"/>
+              <a:gd name="connsiteY29" fmla="*/ 1171575 h 2464594"/>
+              <a:gd name="connsiteX30" fmla="*/ 1571625 w 4758788"/>
+              <a:gd name="connsiteY30" fmla="*/ 1185863 h 2464594"/>
+              <a:gd name="connsiteX31" fmla="*/ 1057275 w 4758788"/>
+              <a:gd name="connsiteY31" fmla="*/ 1207294 h 2464594"/>
+              <a:gd name="connsiteX32" fmla="*/ 878681 w 4758788"/>
+              <a:gd name="connsiteY32" fmla="*/ 1243013 h 2464594"/>
+              <a:gd name="connsiteX33" fmla="*/ 764381 w 4758788"/>
+              <a:gd name="connsiteY33" fmla="*/ 1264444 h 2464594"/>
+              <a:gd name="connsiteX34" fmla="*/ 578644 w 4758788"/>
+              <a:gd name="connsiteY34" fmla="*/ 1328738 h 2464594"/>
+              <a:gd name="connsiteX35" fmla="*/ 500063 w 4758788"/>
+              <a:gd name="connsiteY35" fmla="*/ 1357313 h 2464594"/>
+              <a:gd name="connsiteX36" fmla="*/ 450056 w 4758788"/>
+              <a:gd name="connsiteY36" fmla="*/ 1371600 h 2464594"/>
+              <a:gd name="connsiteX37" fmla="*/ 400050 w 4758788"/>
+              <a:gd name="connsiteY37" fmla="*/ 1414463 h 2464594"/>
+              <a:gd name="connsiteX38" fmla="*/ 257175 w 4758788"/>
+              <a:gd name="connsiteY38" fmla="*/ 1485900 h 2464594"/>
+              <a:gd name="connsiteX39" fmla="*/ 164306 w 4758788"/>
+              <a:gd name="connsiteY39" fmla="*/ 1585913 h 2464594"/>
+              <a:gd name="connsiteX40" fmla="*/ 78581 w 4758788"/>
+              <a:gd name="connsiteY40" fmla="*/ 1678781 h 2464594"/>
+              <a:gd name="connsiteX41" fmla="*/ 35719 w 4758788"/>
+              <a:gd name="connsiteY41" fmla="*/ 1764506 h 2464594"/>
+              <a:gd name="connsiteX42" fmla="*/ 0 w 4758788"/>
+              <a:gd name="connsiteY42" fmla="*/ 1871663 h 2464594"/>
+              <a:gd name="connsiteX43" fmla="*/ 7144 w 4758788"/>
+              <a:gd name="connsiteY43" fmla="*/ 2050256 h 2464594"/>
+              <a:gd name="connsiteX44" fmla="*/ 71438 w 4758788"/>
+              <a:gd name="connsiteY44" fmla="*/ 2200275 h 2464594"/>
+              <a:gd name="connsiteX45" fmla="*/ 150019 w 4758788"/>
+              <a:gd name="connsiteY45" fmla="*/ 2314575 h 2464594"/>
+              <a:gd name="connsiteX46" fmla="*/ 207169 w 4758788"/>
+              <a:gd name="connsiteY46" fmla="*/ 2371725 h 2464594"/>
+              <a:gd name="connsiteX47" fmla="*/ 235744 w 4758788"/>
+              <a:gd name="connsiteY47" fmla="*/ 2400300 h 2464594"/>
+              <a:gd name="connsiteX48" fmla="*/ 264319 w 4758788"/>
+              <a:gd name="connsiteY48" fmla="*/ 2414588 h 2464594"/>
+              <a:gd name="connsiteX49" fmla="*/ 321469 w 4758788"/>
+              <a:gd name="connsiteY49" fmla="*/ 2450306 h 2464594"/>
+              <a:gd name="connsiteX50" fmla="*/ 414338 w 4758788"/>
+              <a:gd name="connsiteY50" fmla="*/ 2464594 h 2464594"/>
+              <a:gd name="connsiteX51" fmla="*/ 757238 w 4758788"/>
+              <a:gd name="connsiteY51" fmla="*/ 2457450 h 2464594"/>
+            </a:gdLst>
+            <a:ahLst/>
+            <a:cxnLst>
+              <a:cxn ang="0">
+                <a:pos x="connsiteX0" y="connsiteY0"/>
+              </a:cxn>
+              <a:cxn ang="0">
+                <a:pos x="connsiteX1" y="connsiteY1"/>
+              </a:cxn>
+              <a:cxn ang="0">
+                <a:pos x="connsiteX2" y="connsiteY2"/>
+              </a:cxn>
+              <a:cxn ang="0">
+                <a:pos x="connsiteX3" y="connsiteY3"/>
+              </a:cxn>
+              <a:cxn ang="0">
+                <a:pos x="connsiteX4" y="connsiteY4"/>
+              </a:cxn>
+              <a:cxn ang="0">
+                <a:pos x="connsiteX5" y="connsiteY5"/>
+              </a:cxn>
+              <a:cxn ang="0">
+                <a:pos x="connsiteX6" y="connsiteY6"/>
+              </a:cxn>
+              <a:cxn ang="0">
+                <a:pos x="connsiteX7" y="connsiteY7"/>
+              </a:cxn>
+              <a:cxn ang="0">
+                <a:pos x="connsiteX8" y="connsiteY8"/>
+              </a:cxn>
+              <a:cxn ang="0">
+                <a:pos x="connsiteX9" y="connsiteY9"/>
+              </a:cxn>
+              <a:cxn ang="0">
+                <a:pos x="connsiteX10" y="connsiteY10"/>
+              </a:cxn>
+              <a:cxn ang="0">
+                <a:pos x="connsiteX11" y="connsiteY11"/>
+              </a:cxn>
+              <a:cxn ang="0">
+                <a:pos x="connsiteX12" y="connsiteY12"/>
+              </a:cxn>
+              <a:cxn ang="0">
+                <a:pos x="connsiteX13" y="connsiteY13"/>
+              </a:cxn>
+              <a:cxn ang="0">
+                <a:pos x="connsiteX14" y="connsiteY14"/>
+              </a:cxn>
+              <a:cxn ang="0">
+                <a:pos x="connsiteX15" y="connsiteY15"/>
+              </a:cxn>
+              <a:cxn ang="0">
+                <a:pos x="connsiteX16" y="connsiteY16"/>
+              </a:cxn>
+              <a:cxn ang="0">
+                <a:pos x="connsiteX17" y="connsiteY17"/>
+              </a:cxn>
+              <a:cxn ang="0">
+                <a:pos x="connsiteX18" y="connsiteY18"/>
+              </a:cxn>
+              <a:cxn ang="0">
+                <a:pos x="connsiteX19" y="connsiteY19"/>
+              </a:cxn>
+              <a:cxn ang="0">
+                <a:pos x="connsiteX20" y="connsiteY20"/>
+              </a:cxn>
+              <a:cxn ang="0">
+                <a:pos x="connsiteX21" y="connsiteY21"/>
+              </a:cxn>
+              <a:cxn ang="0">
+                <a:pos x="connsiteX22" y="connsiteY22"/>
+              </a:cxn>
+              <a:cxn ang="0">
+                <a:pos x="connsiteX23" y="connsiteY23"/>
+              </a:cxn>
+              <a:cxn ang="0">
+                <a:pos x="connsiteX24" y="connsiteY24"/>
+              </a:cxn>
+              <a:cxn ang="0">
+                <a:pos x="connsiteX25" y="connsiteY25"/>
+              </a:cxn>
+              <a:cxn ang="0">
+                <a:pos x="connsiteX26" y="connsiteY26"/>
+              </a:cxn>
+              <a:cxn ang="0">
+                <a:pos x="connsiteX27" y="connsiteY27"/>
+              </a:cxn>
+              <a:cxn ang="0">
+                <a:pos x="connsiteX28" y="connsiteY28"/>
+              </a:cxn>
+              <a:cxn ang="0">
+                <a:pos x="connsiteX29" y="connsiteY29"/>
+              </a:cxn>
+              <a:cxn ang="0">
+                <a:pos x="connsiteX30" y="connsiteY30"/>
+              </a:cxn>
+              <a:cxn ang="0">
+                <a:pos x="connsiteX31" y="connsiteY31"/>
+              </a:cxn>
+              <a:cxn ang="0">
+                <a:pos x="connsiteX32" y="connsiteY32"/>
+              </a:cxn>
+              <a:cxn ang="0">
+                <a:pos x="connsiteX33" y="connsiteY33"/>
+              </a:cxn>
+              <a:cxn ang="0">
+                <a:pos x="connsiteX34" y="connsiteY34"/>
+              </a:cxn>
+              <a:cxn ang="0">
+                <a:pos x="connsiteX35" y="connsiteY35"/>
+              </a:cxn>
+              <a:cxn ang="0">
+                <a:pos x="connsiteX36" y="connsiteY36"/>
+              </a:cxn>
+              <a:cxn ang="0">
+                <a:pos x="connsiteX37" y="connsiteY37"/>
+              </a:cxn>
+              <a:cxn ang="0">
+                <a:pos x="connsiteX38" y="connsiteY38"/>
+              </a:cxn>
+              <a:cxn ang="0">
+                <a:pos x="connsiteX39" y="connsiteY39"/>
+              </a:cxn>
+              <a:cxn ang="0">
+                <a:pos x="connsiteX40" y="connsiteY40"/>
+              </a:cxn>
+              <a:cxn ang="0">
+                <a:pos x="connsiteX41" y="connsiteY41"/>
+              </a:cxn>
+              <a:cxn ang="0">
+                <a:pos x="connsiteX42" y="connsiteY42"/>
+              </a:cxn>
+              <a:cxn ang="0">
+                <a:pos x="connsiteX43" y="connsiteY43"/>
+              </a:cxn>
+              <a:cxn ang="0">
+                <a:pos x="connsiteX44" y="connsiteY44"/>
+              </a:cxn>
+              <a:cxn ang="0">
+                <a:pos x="connsiteX45" y="connsiteY45"/>
+              </a:cxn>
+              <a:cxn ang="0">
+                <a:pos x="connsiteX46" y="connsiteY46"/>
+              </a:cxn>
+              <a:cxn ang="0">
+                <a:pos x="connsiteX47" y="connsiteY47"/>
+              </a:cxn>
+              <a:cxn ang="0">
+                <a:pos x="connsiteX48" y="connsiteY48"/>
+              </a:cxn>
+              <a:cxn ang="0">
+                <a:pos x="connsiteX49" y="connsiteY49"/>
+              </a:cxn>
+              <a:cxn ang="0">
+                <a:pos x="connsiteX50" y="connsiteY50"/>
+              </a:cxn>
+              <a:cxn ang="0">
+                <a:pos x="connsiteX51" y="connsiteY51"/>
+              </a:cxn>
+            </a:cxnLst>
+            <a:rect l="l" t="t" r="r" b="b"/>
+            <a:pathLst>
+              <a:path w="4758788" h="2464594">
+                <a:moveTo>
+                  <a:pt x="3629025" y="21431"/>
+                </a:moveTo>
+                <a:cubicBezTo>
+                  <a:pt x="3640931" y="19050"/>
+                  <a:pt x="3652685" y="15707"/>
+                  <a:pt x="3664744" y="14288"/>
+                </a:cubicBezTo>
+                <a:cubicBezTo>
+                  <a:pt x="3730409" y="6563"/>
+                  <a:pt x="3834215" y="2957"/>
+                  <a:pt x="3893344" y="0"/>
+                </a:cubicBezTo>
+                <a:lnTo>
+                  <a:pt x="4064794" y="7144"/>
+                </a:lnTo>
+                <a:cubicBezTo>
+                  <a:pt x="4086318" y="8449"/>
+                  <a:pt x="4107622" y="12244"/>
+                  <a:pt x="4129088" y="14288"/>
+                </a:cubicBezTo>
+                <a:cubicBezTo>
+                  <a:pt x="4157633" y="17006"/>
+                  <a:pt x="4186238" y="19050"/>
+                  <a:pt x="4214813" y="21431"/>
+                </a:cubicBezTo>
+                <a:cubicBezTo>
+                  <a:pt x="4236244" y="26194"/>
+                  <a:pt x="4257337" y="32879"/>
+                  <a:pt x="4279106" y="35719"/>
+                </a:cubicBezTo>
+                <a:cubicBezTo>
+                  <a:pt x="4312248" y="40042"/>
+                  <a:pt x="4345862" y="39537"/>
+                  <a:pt x="4379119" y="42863"/>
+                </a:cubicBezTo>
+                <a:cubicBezTo>
+                  <a:pt x="4393531" y="44304"/>
+                  <a:pt x="4407642" y="47958"/>
+                  <a:pt x="4421981" y="50006"/>
+                </a:cubicBezTo>
+                <a:cubicBezTo>
+                  <a:pt x="4450996" y="54151"/>
+                  <a:pt x="4499456" y="58897"/>
+                  <a:pt x="4529138" y="64294"/>
+                </a:cubicBezTo>
+                <a:cubicBezTo>
+                  <a:pt x="4536327" y="65601"/>
+                  <a:pt x="4570404" y="74211"/>
+                  <a:pt x="4579144" y="78581"/>
+                </a:cubicBezTo>
+                <a:cubicBezTo>
+                  <a:pt x="4596315" y="87167"/>
+                  <a:pt x="4611779" y="98981"/>
+                  <a:pt x="4629150" y="107156"/>
+                </a:cubicBezTo>
+                <a:cubicBezTo>
+                  <a:pt x="4652356" y="118076"/>
+                  <a:pt x="4700588" y="135731"/>
+                  <a:pt x="4700588" y="135731"/>
+                </a:cubicBezTo>
+                <a:cubicBezTo>
+                  <a:pt x="4707732" y="145256"/>
+                  <a:pt x="4716695" y="153657"/>
+                  <a:pt x="4722019" y="164306"/>
+                </a:cubicBezTo>
+                <a:cubicBezTo>
+                  <a:pt x="4728754" y="177777"/>
+                  <a:pt x="4731159" y="193015"/>
+                  <a:pt x="4736306" y="207169"/>
+                </a:cubicBezTo>
+                <a:cubicBezTo>
+                  <a:pt x="4740688" y="219221"/>
+                  <a:pt x="4745831" y="230982"/>
+                  <a:pt x="4750594" y="242888"/>
+                </a:cubicBezTo>
+                <a:cubicBezTo>
+                  <a:pt x="4756098" y="275908"/>
+                  <a:pt x="4765892" y="309522"/>
+                  <a:pt x="4750594" y="342900"/>
+                </a:cubicBezTo>
+                <a:cubicBezTo>
+                  <a:pt x="4695670" y="462732"/>
+                  <a:pt x="4703834" y="427196"/>
+                  <a:pt x="4650581" y="485775"/>
+                </a:cubicBezTo>
+                <a:cubicBezTo>
+                  <a:pt x="4585155" y="557743"/>
+                  <a:pt x="4621800" y="532365"/>
+                  <a:pt x="4521994" y="607219"/>
+                </a:cubicBezTo>
+                <a:cubicBezTo>
+                  <a:pt x="4481251" y="637776"/>
+                  <a:pt x="4448574" y="666331"/>
+                  <a:pt x="4400550" y="685800"/>
+                </a:cubicBezTo>
+                <a:cubicBezTo>
+                  <a:pt x="4334937" y="712400"/>
+                  <a:pt x="4264808" y="727569"/>
+                  <a:pt x="4200525" y="757238"/>
+                </a:cubicBezTo>
+                <a:cubicBezTo>
+                  <a:pt x="4138613" y="785813"/>
+                  <a:pt x="4078911" y="819770"/>
+                  <a:pt x="4014788" y="842963"/>
+                </a:cubicBezTo>
+                <a:cubicBezTo>
+                  <a:pt x="3966449" y="860447"/>
+                  <a:pt x="3914362" y="865156"/>
+                  <a:pt x="3864769" y="878681"/>
+                </a:cubicBezTo>
+                <a:cubicBezTo>
+                  <a:pt x="3809537" y="893744"/>
+                  <a:pt x="3755670" y="913533"/>
+                  <a:pt x="3700463" y="928688"/>
+                </a:cubicBezTo>
+                <a:cubicBezTo>
+                  <a:pt x="3634188" y="946881"/>
+                  <a:pt x="3566802" y="960827"/>
+                  <a:pt x="3500438" y="978694"/>
+                </a:cubicBezTo>
+                <a:cubicBezTo>
+                  <a:pt x="3345951" y="1020286"/>
+                  <a:pt x="3244795" y="1061895"/>
+                  <a:pt x="3078956" y="1085850"/>
+                </a:cubicBezTo>
+                <a:cubicBezTo>
+                  <a:pt x="2948798" y="1104651"/>
+                  <a:pt x="2816658" y="1106204"/>
+                  <a:pt x="2686050" y="1121569"/>
+                </a:cubicBezTo>
+                <a:cubicBezTo>
+                  <a:pt x="2625200" y="1128728"/>
+                  <a:pt x="2469027" y="1148009"/>
+                  <a:pt x="2414588" y="1150144"/>
+                </a:cubicBezTo>
+                <a:cubicBezTo>
+                  <a:pt x="2221796" y="1157704"/>
+                  <a:pt x="2028802" y="1158814"/>
+                  <a:pt x="1835944" y="1164431"/>
+                </a:cubicBezTo>
+                <a:cubicBezTo>
+                  <a:pt x="1783524" y="1165958"/>
+                  <a:pt x="1731169" y="1169194"/>
+                  <a:pt x="1678781" y="1171575"/>
+                </a:cubicBezTo>
+                <a:cubicBezTo>
+                  <a:pt x="1643062" y="1176338"/>
+                  <a:pt x="1607600" y="1183795"/>
+                  <a:pt x="1571625" y="1185863"/>
+                </a:cubicBezTo>
+                <a:cubicBezTo>
+                  <a:pt x="1400309" y="1195709"/>
+                  <a:pt x="1057275" y="1207294"/>
+                  <a:pt x="1057275" y="1207294"/>
+                </a:cubicBezTo>
+                <a:cubicBezTo>
+                  <a:pt x="874687" y="1237724"/>
+                  <a:pt x="1071638" y="1203090"/>
+                  <a:pt x="878681" y="1243013"/>
+                </a:cubicBezTo>
+                <a:cubicBezTo>
+                  <a:pt x="840721" y="1250867"/>
+                  <a:pt x="801653" y="1253795"/>
+                  <a:pt x="764381" y="1264444"/>
+                </a:cubicBezTo>
+                <a:cubicBezTo>
+                  <a:pt x="701385" y="1282443"/>
+                  <a:pt x="640456" y="1307020"/>
+                  <a:pt x="578644" y="1328738"/>
+                </a:cubicBezTo>
+                <a:cubicBezTo>
+                  <a:pt x="552348" y="1337977"/>
+                  <a:pt x="526862" y="1349656"/>
+                  <a:pt x="500063" y="1357313"/>
+                </a:cubicBezTo>
+                <a:lnTo>
+                  <a:pt x="450056" y="1371600"/>
+                </a:lnTo>
+                <a:cubicBezTo>
+                  <a:pt x="433387" y="1385888"/>
+                  <a:pt x="418937" y="1403271"/>
+                  <a:pt x="400050" y="1414463"/>
+                </a:cubicBezTo>
+                <a:cubicBezTo>
+                  <a:pt x="354243" y="1441608"/>
+                  <a:pt x="257175" y="1485900"/>
+                  <a:pt x="257175" y="1485900"/>
+                </a:cubicBezTo>
+                <a:cubicBezTo>
+                  <a:pt x="137945" y="1625003"/>
+                  <a:pt x="295366" y="1443931"/>
+                  <a:pt x="164306" y="1585913"/>
+                </a:cubicBezTo>
+                <a:cubicBezTo>
+                  <a:pt x="42378" y="1718001"/>
+                  <a:pt x="231883" y="1525482"/>
+                  <a:pt x="78581" y="1678781"/>
+                </a:cubicBezTo>
+                <a:cubicBezTo>
+                  <a:pt x="64294" y="1707356"/>
+                  <a:pt x="46936" y="1734592"/>
+                  <a:pt x="35719" y="1764506"/>
+                </a:cubicBezTo>
+                <a:cubicBezTo>
+                  <a:pt x="8201" y="1837888"/>
+                  <a:pt x="19877" y="1802093"/>
+                  <a:pt x="0" y="1871663"/>
+                </a:cubicBezTo>
+                <a:cubicBezTo>
+                  <a:pt x="2381" y="1931194"/>
+                  <a:pt x="1583" y="1990937"/>
+                  <a:pt x="7144" y="2050256"/>
+                </a:cubicBezTo>
+                <a:cubicBezTo>
+                  <a:pt x="11205" y="2093572"/>
+                  <a:pt x="57678" y="2176196"/>
+                  <a:pt x="71438" y="2200275"/>
+                </a:cubicBezTo>
+                <a:cubicBezTo>
+                  <a:pt x="102686" y="2254958"/>
+                  <a:pt x="103497" y="2261849"/>
+                  <a:pt x="150019" y="2314575"/>
+                </a:cubicBezTo>
+                <a:cubicBezTo>
+                  <a:pt x="167844" y="2334776"/>
+                  <a:pt x="188119" y="2352675"/>
+                  <a:pt x="207169" y="2371725"/>
+                </a:cubicBezTo>
+                <a:cubicBezTo>
+                  <a:pt x="216694" y="2381250"/>
+                  <a:pt x="223696" y="2394276"/>
+                  <a:pt x="235744" y="2400300"/>
+                </a:cubicBezTo>
+                <a:cubicBezTo>
+                  <a:pt x="245269" y="2405063"/>
+                  <a:pt x="255120" y="2409222"/>
+                  <a:pt x="264319" y="2414588"/>
+                </a:cubicBezTo>
+                <a:cubicBezTo>
+                  <a:pt x="283723" y="2425907"/>
+                  <a:pt x="299230" y="2447129"/>
+                  <a:pt x="321469" y="2450306"/>
+                </a:cubicBezTo>
+                <a:cubicBezTo>
+                  <a:pt x="385814" y="2459499"/>
+                  <a:pt x="354866" y="2454682"/>
+                  <a:pt x="414338" y="2464594"/>
+                </a:cubicBezTo>
+                <a:cubicBezTo>
+                  <a:pt x="690548" y="2456470"/>
+                  <a:pt x="576228" y="2457450"/>
+                  <a:pt x="757238" y="2457450"/>
+                </a:cubicBezTo>
+              </a:path>
+            </a:pathLst>
+          </a:custGeom>
+          <a:noFill/>
+          <a:ln>
+            <a:prstDash val="dash"/>
+          </a:ln>
+        </p:spPr>
+        <p:style>
+          <a:lnRef idx="2">
+            <a:schemeClr val="accent1">
+              <a:shade val="15000"/>
+            </a:schemeClr>
+          </a:lnRef>
+          <a:fillRef idx="1">
+            <a:schemeClr val="accent1"/>
+          </a:fillRef>
+          <a:effectRef idx="0">
+            <a:schemeClr val="accent1"/>
+          </a:effectRef>
+          <a:fontRef idx="minor">
+            <a:schemeClr val="lt1"/>
+          </a:fontRef>
+        </p:style>
+        <p:txBody>
+          <a:bodyPr rtlCol="0" anchor="ctr"/>
+          <a:lstStyle/>
+          <a:p>
+            <a:pPr algn="ctr"/>
+            <a:endParaRPr lang="de-DE"/>
+          </a:p>
+        </p:txBody>
+      </p:sp>
+      <p:pic>
+        <p:nvPicPr>
+          <p:cNvPr id="18" name="Grafik 17">
+            <a:extLst>
+              <a:ext uri="{FF2B5EF4-FFF2-40B4-BE49-F238E27FC236}">
+                <a16:creationId xmlns:a16="http://schemas.microsoft.com/office/drawing/2014/main" id="{EC0EFDD8-452B-C734-A115-B02F72C9697B}"/>
+              </a:ext>
+            </a:extLst>
+          </p:cNvPr>
+          <p:cNvPicPr>
+            <a:picLocks noChangeAspect="1"/>
+          </p:cNvPicPr>
+          <p:nvPr/>
+        </p:nvPicPr>
+        <p:blipFill>
+          <a:blip r:embed="rId23"/>
+          <a:stretch>
+            <a:fillRect/>
+          </a:stretch>
+        </p:blipFill>
+        <p:spPr>
+          <a:xfrm>
+            <a:off x="9068411" y="4193356"/>
+            <a:ext cx="2177884" cy="1101507"/>
+          </a:xfrm>
+          <a:prstGeom prst="rect">
+            <a:avLst/>
+          </a:prstGeom>
+        </p:spPr>
+      </p:pic>
+      <p:sp>
+        <p:nvSpPr>
+          <p:cNvPr id="20" name="Textfeld 19">
+            <a:extLst>
+              <a:ext uri="{FF2B5EF4-FFF2-40B4-BE49-F238E27FC236}">
+                <a16:creationId xmlns:a16="http://schemas.microsoft.com/office/drawing/2014/main" id="{0E08141E-D93D-CCFC-9795-C011CD6D18AC}"/>
+              </a:ext>
+            </a:extLst>
+          </p:cNvPr>
+          <p:cNvSpPr txBox="1"/>
+          <p:nvPr/>
+        </p:nvSpPr>
+        <p:spPr>
+          <a:xfrm>
+            <a:off x="9106905" y="5356830"/>
+            <a:ext cx="857927" cy="461665"/>
+          </a:xfrm>
+          <a:prstGeom prst="rect">
+            <a:avLst/>
+          </a:prstGeom>
+          <a:noFill/>
+        </p:spPr>
+        <p:txBody>
+          <a:bodyPr wrap="none" rtlCol="0">
+            <a:spAutoFit/>
+          </a:bodyPr>
+          <a:lstStyle/>
+          <a:p>
+            <a:r>
+              <a:rPr lang="en-US" sz="800" noProof="0" dirty="0"/>
+              <a:t>Storing</a:t>
+            </a:r>
+          </a:p>
+          <a:p>
+            <a:r>
+              <a:rPr lang="en-US" sz="800" noProof="0" dirty="0"/>
+              <a:t>- </a:t>
+            </a:r>
+            <a:r>
+              <a:rPr lang="en-US" sz="800" dirty="0"/>
+              <a:t>p1Storing</a:t>
+            </a:r>
+          </a:p>
+          <a:p>
+            <a:r>
+              <a:rPr lang="en-US" sz="800" noProof="0" dirty="0"/>
+              <a:t>- p1MaintainDs</a:t>
+            </a:r>
+          </a:p>
+        </p:txBody>
+      </p:sp>
+      <p:pic>
+        <p:nvPicPr>
+          <p:cNvPr id="22" name="Grafik 21">
+            <a:extLst>
+              <a:ext uri="{FF2B5EF4-FFF2-40B4-BE49-F238E27FC236}">
+                <a16:creationId xmlns:a16="http://schemas.microsoft.com/office/drawing/2014/main" id="{612EC0BE-79DC-0DB7-BA37-B70D4D9B2C9B}"/>
+              </a:ext>
+            </a:extLst>
+          </p:cNvPr>
+          <p:cNvPicPr>
+            <a:picLocks noChangeAspect="1"/>
+          </p:cNvPicPr>
+          <p:nvPr/>
+        </p:nvPicPr>
+        <p:blipFill>
+          <a:blip r:embed="rId24"/>
+          <a:stretch>
+            <a:fillRect/>
+          </a:stretch>
+        </p:blipFill>
+        <p:spPr>
+          <a:xfrm>
+            <a:off x="10824658" y="4914895"/>
+            <a:ext cx="1128101" cy="1057595"/>
+          </a:xfrm>
+          <a:prstGeom prst="rect">
+            <a:avLst/>
+          </a:prstGeom>
+        </p:spPr>
+      </p:pic>
+      <p:sp>
+        <p:nvSpPr>
+          <p:cNvPr id="23" name="Textfeld 22">
+            <a:extLst>
+              <a:ext uri="{FF2B5EF4-FFF2-40B4-BE49-F238E27FC236}">
+                <a16:creationId xmlns:a16="http://schemas.microsoft.com/office/drawing/2014/main" id="{33A3828D-EEB9-6E56-BE92-8BDE01FA864D}"/>
+              </a:ext>
+            </a:extLst>
+          </p:cNvPr>
+          <p:cNvSpPr txBox="1"/>
+          <p:nvPr/>
+        </p:nvSpPr>
+        <p:spPr>
+          <a:xfrm>
+            <a:off x="10824658" y="6016402"/>
+            <a:ext cx="506870" cy="338554"/>
+          </a:xfrm>
+          <a:prstGeom prst="rect">
+            <a:avLst/>
+          </a:prstGeom>
+          <a:noFill/>
+        </p:spPr>
+        <p:txBody>
+          <a:bodyPr wrap="none" rtlCol="0">
+            <a:spAutoFit/>
+          </a:bodyPr>
+          <a:lstStyle/>
+          <a:p>
+            <a:r>
+              <a:rPr lang="en-US" sz="800" noProof="0" dirty="0"/>
+              <a:t>Serving</a:t>
+            </a:r>
+          </a:p>
+          <a:p>
+            <a:r>
+              <a:rPr lang="en-US" sz="800" noProof="0" dirty="0"/>
+              <a:t>- </a:t>
+            </a:r>
+            <a:r>
+              <a:rPr lang="en-US" sz="800" noProof="0" dirty="0" err="1"/>
+              <a:t>t.b.d.</a:t>
+            </a:r>
+            <a:endParaRPr lang="en-US" sz="800" noProof="0" dirty="0"/>
+          </a:p>
+        </p:txBody>
+      </p:sp>
+      <p:sp>
+        <p:nvSpPr>
+          <p:cNvPr id="15" name="Zylinder 14">
+            <a:extLst>
+              <a:ext uri="{FF2B5EF4-FFF2-40B4-BE49-F238E27FC236}">
+                <a16:creationId xmlns:a16="http://schemas.microsoft.com/office/drawing/2014/main" id="{2927D718-4865-206C-FBF5-9925DAE985FB}"/>
+              </a:ext>
+            </a:extLst>
+          </p:cNvPr>
+          <p:cNvSpPr/>
+          <p:nvPr/>
+        </p:nvSpPr>
+        <p:spPr>
+          <a:xfrm>
+            <a:off x="10989405" y="4093504"/>
+            <a:ext cx="684245" cy="391898"/>
+          </a:xfrm>
+          <a:prstGeom prst="can">
+            <a:avLst/>
+          </a:prstGeom>
+        </p:spPr>
+        <p:style>
+          <a:lnRef idx="2">
+            <a:schemeClr val="accent3">
+              <a:shade val="15000"/>
+            </a:schemeClr>
+          </a:lnRef>
+          <a:fillRef idx="1">
+            <a:schemeClr val="accent3"/>
+          </a:fillRef>
+          <a:effectRef idx="0">
+            <a:schemeClr val="accent3"/>
+          </a:effectRef>
+          <a:fontRef idx="minor">
+            <a:schemeClr val="lt1"/>
+          </a:fontRef>
+        </p:style>
+        <p:txBody>
+          <a:bodyPr rtlCol="0" anchor="ctr"/>
+          <a:lstStyle/>
+          <a:p>
+            <a:pPr algn="ctr"/>
+            <a:r>
+              <a:rPr lang="de-DE" sz="800" dirty="0" err="1"/>
+              <a:t>DataStore</a:t>
+            </a:r>
+            <a:endParaRPr lang="de-DE" sz="800" dirty="0"/>
+          </a:p>
+        </p:txBody>
+      </p:sp>
+      <p:pic>
+        <p:nvPicPr>
+          <p:cNvPr id="5" name="Grafik 4">
+            <a:extLst>
+              <a:ext uri="{FF2B5EF4-FFF2-40B4-BE49-F238E27FC236}">
+                <a16:creationId xmlns:a16="http://schemas.microsoft.com/office/drawing/2014/main" id="{542C1DFB-67E6-4676-673D-E6884939D21F}"/>
+              </a:ext>
+            </a:extLst>
+          </p:cNvPr>
+          <p:cNvPicPr>
+            <a:picLocks noChangeAspect="1"/>
+          </p:cNvPicPr>
+          <p:nvPr/>
+        </p:nvPicPr>
+        <p:blipFill>
+          <a:blip r:embed="rId11"/>
+          <a:stretch>
+            <a:fillRect/>
+          </a:stretch>
+        </p:blipFill>
+        <p:spPr>
+          <a:xfrm>
+            <a:off x="10475680" y="4699708"/>
+            <a:ext cx="149626" cy="149626"/>
+          </a:xfrm>
+          <a:prstGeom prst="rect">
+            <a:avLst/>
+          </a:prstGeom>
+        </p:spPr>
+      </p:pic>
+      <p:pic>
+        <p:nvPicPr>
+          <p:cNvPr id="16" name="Grafik 15">
+            <a:extLst>
+              <a:ext uri="{FF2B5EF4-FFF2-40B4-BE49-F238E27FC236}">
+                <a16:creationId xmlns:a16="http://schemas.microsoft.com/office/drawing/2014/main" id="{80F6D973-BCB0-6E9D-BE3F-DDF94F636F3E}"/>
+              </a:ext>
+            </a:extLst>
+          </p:cNvPr>
+          <p:cNvPicPr>
+            <a:picLocks noChangeAspect="1"/>
+          </p:cNvPicPr>
+          <p:nvPr/>
+        </p:nvPicPr>
+        <p:blipFill>
+          <a:blip r:embed="rId11"/>
+          <a:stretch>
+            <a:fillRect/>
+          </a:stretch>
+        </p:blipFill>
+        <p:spPr>
+          <a:xfrm>
+            <a:off x="10254127" y="4718459"/>
+            <a:ext cx="149626" cy="149626"/>
+          </a:xfrm>
+          <a:prstGeom prst="rect">
+            <a:avLst/>
+          </a:prstGeom>
+        </p:spPr>
+      </p:pic>
+      <p:pic>
+        <p:nvPicPr>
+          <p:cNvPr id="17" name="Grafik 16">
+            <a:extLst>
+              <a:ext uri="{FF2B5EF4-FFF2-40B4-BE49-F238E27FC236}">
+                <a16:creationId xmlns:a16="http://schemas.microsoft.com/office/drawing/2014/main" id="{0219635F-F1D3-4821-DECB-310D5E9E3EE4}"/>
+              </a:ext>
+            </a:extLst>
+          </p:cNvPr>
+          <p:cNvPicPr>
+            <a:picLocks noChangeAspect="1"/>
+          </p:cNvPicPr>
+          <p:nvPr/>
+        </p:nvPicPr>
+        <p:blipFill>
+          <a:blip r:embed="rId11"/>
+          <a:stretch>
+            <a:fillRect/>
+          </a:stretch>
+        </p:blipFill>
+        <p:spPr>
+          <a:xfrm>
+            <a:off x="10065252" y="4930145"/>
+            <a:ext cx="149626" cy="149626"/>
+          </a:xfrm>
+          <a:prstGeom prst="rect">
+            <a:avLst/>
+          </a:prstGeom>
+        </p:spPr>
+      </p:pic>
+      <p:pic>
+        <p:nvPicPr>
+          <p:cNvPr id="24" name="Grafik 23">
+            <a:extLst>
+              <a:ext uri="{FF2B5EF4-FFF2-40B4-BE49-F238E27FC236}">
+                <a16:creationId xmlns:a16="http://schemas.microsoft.com/office/drawing/2014/main" id="{DE4924A2-AADC-7911-FEC5-7A8A0EE2B90D}"/>
+              </a:ext>
+            </a:extLst>
+          </p:cNvPr>
+          <p:cNvPicPr>
+            <a:picLocks noChangeAspect="1"/>
+          </p:cNvPicPr>
+          <p:nvPr/>
+        </p:nvPicPr>
+        <p:blipFill>
+          <a:blip r:embed="rId11"/>
+          <a:stretch>
+            <a:fillRect/>
+          </a:stretch>
+        </p:blipFill>
+        <p:spPr>
+          <a:xfrm>
+            <a:off x="10092601" y="5108431"/>
+            <a:ext cx="149626" cy="149626"/>
+          </a:xfrm>
+          <a:prstGeom prst="rect">
+            <a:avLst/>
+          </a:prstGeom>
+        </p:spPr>
+      </p:pic>
+      <p:pic>
+        <p:nvPicPr>
+          <p:cNvPr id="25" name="Grafik 24">
+            <a:extLst>
+              <a:ext uri="{FF2B5EF4-FFF2-40B4-BE49-F238E27FC236}">
+                <a16:creationId xmlns:a16="http://schemas.microsoft.com/office/drawing/2014/main" id="{B7355421-1DF4-8616-0697-192A01CED720}"/>
+              </a:ext>
+            </a:extLst>
+          </p:cNvPr>
+          <p:cNvPicPr>
+            <a:picLocks noChangeAspect="1"/>
+          </p:cNvPicPr>
+          <p:nvPr/>
+        </p:nvPicPr>
+        <p:blipFill>
+          <a:blip r:embed="rId11"/>
+          <a:stretch>
+            <a:fillRect/>
+          </a:stretch>
+        </p:blipFill>
+        <p:spPr>
+          <a:xfrm>
+            <a:off x="9216053" y="5025069"/>
+            <a:ext cx="149626" cy="149626"/>
+          </a:xfrm>
+          <a:prstGeom prst="rect">
+            <a:avLst/>
+          </a:prstGeom>
+        </p:spPr>
+      </p:pic>
+      <p:pic>
+        <p:nvPicPr>
+          <p:cNvPr id="27" name="Grafik 26">
+            <a:extLst>
+              <a:ext uri="{FF2B5EF4-FFF2-40B4-BE49-F238E27FC236}">
+                <a16:creationId xmlns:a16="http://schemas.microsoft.com/office/drawing/2014/main" id="{A86623E0-9C0F-7748-1E9A-0AAEE6C1E042}"/>
+              </a:ext>
+            </a:extLst>
+          </p:cNvPr>
+          <p:cNvPicPr>
+            <a:picLocks noChangeAspect="1"/>
+          </p:cNvPicPr>
+          <p:nvPr/>
+        </p:nvPicPr>
+        <p:blipFill>
+          <a:blip r:embed="rId11"/>
+          <a:stretch>
+            <a:fillRect/>
+          </a:stretch>
+        </p:blipFill>
+        <p:spPr>
+          <a:xfrm>
+            <a:off x="11087719" y="4673917"/>
+            <a:ext cx="149626" cy="149626"/>
+          </a:xfrm>
+          <a:prstGeom prst="rect">
+            <a:avLst/>
+          </a:prstGeom>
+        </p:spPr>
+      </p:pic>
+      <p:pic>
+        <p:nvPicPr>
+          <p:cNvPr id="28" name="Grafik 27">
+            <a:extLst>
+              <a:ext uri="{FF2B5EF4-FFF2-40B4-BE49-F238E27FC236}">
+                <a16:creationId xmlns:a16="http://schemas.microsoft.com/office/drawing/2014/main" id="{C8F8A822-997E-FE15-AE01-C83EF9AAC0BD}"/>
+              </a:ext>
+            </a:extLst>
+          </p:cNvPr>
+          <p:cNvPicPr>
+            <a:picLocks noChangeAspect="1"/>
+          </p:cNvPicPr>
+          <p:nvPr/>
+        </p:nvPicPr>
+        <p:blipFill>
+          <a:blip r:embed="rId11"/>
+          <a:stretch>
+            <a:fillRect/>
+          </a:stretch>
+        </p:blipFill>
+        <p:spPr>
+          <a:xfrm>
+            <a:off x="10912399" y="4662901"/>
+            <a:ext cx="149626" cy="149626"/>
+          </a:xfrm>
+          <a:prstGeom prst="rect">
+            <a:avLst/>
+          </a:prstGeom>
+        </p:spPr>
+      </p:pic>
+      <p:pic>
+        <p:nvPicPr>
+          <p:cNvPr id="57" name="Grafik 56">
+            <a:extLst>
+              <a:ext uri="{FF2B5EF4-FFF2-40B4-BE49-F238E27FC236}">
+                <a16:creationId xmlns:a16="http://schemas.microsoft.com/office/drawing/2014/main" id="{0DD1082E-A760-A286-69C9-60515C43205B}"/>
+              </a:ext>
+            </a:extLst>
+          </p:cNvPr>
+          <p:cNvPicPr>
+            <a:picLocks noChangeAspect="1"/>
+          </p:cNvPicPr>
+          <p:nvPr/>
+        </p:nvPicPr>
+        <p:blipFill>
+          <a:blip r:embed="rId11"/>
+          <a:stretch>
+            <a:fillRect/>
+          </a:stretch>
+        </p:blipFill>
+        <p:spPr>
+          <a:xfrm>
+            <a:off x="10256487" y="4902348"/>
+            <a:ext cx="149626" cy="149626"/>
+          </a:xfrm>
+          <a:prstGeom prst="rect">
+            <a:avLst/>
+          </a:prstGeom>
+        </p:spPr>
+      </p:pic>
+      <p:pic>
+        <p:nvPicPr>
+          <p:cNvPr id="59" name="Grafik 58">
+            <a:extLst>
+              <a:ext uri="{FF2B5EF4-FFF2-40B4-BE49-F238E27FC236}">
+                <a16:creationId xmlns:a16="http://schemas.microsoft.com/office/drawing/2014/main" id="{8B70A580-CA7D-64DE-E057-7BFF60BD68F9}"/>
+              </a:ext>
+            </a:extLst>
+          </p:cNvPr>
+          <p:cNvPicPr>
+            <a:picLocks noChangeAspect="1"/>
+          </p:cNvPicPr>
+          <p:nvPr/>
+        </p:nvPicPr>
+        <p:blipFill>
+          <a:blip r:embed="rId11"/>
+          <a:stretch>
+            <a:fillRect/>
+          </a:stretch>
+        </p:blipFill>
+        <p:spPr>
+          <a:xfrm>
+            <a:off x="10286431" y="5079771"/>
+            <a:ext cx="149626" cy="149626"/>
+          </a:xfrm>
+          <a:prstGeom prst="rect">
+            <a:avLst/>
+          </a:prstGeom>
+        </p:spPr>
+      </p:pic>
+      <p:pic>
+        <p:nvPicPr>
+          <p:cNvPr id="60" name="Grafik 59">
+            <a:extLst>
+              <a:ext uri="{FF2B5EF4-FFF2-40B4-BE49-F238E27FC236}">
+                <a16:creationId xmlns:a16="http://schemas.microsoft.com/office/drawing/2014/main" id="{405D2335-19A3-BC55-DCC0-486FD70AF6DB}"/>
+              </a:ext>
+            </a:extLst>
+          </p:cNvPr>
+          <p:cNvPicPr>
+            <a:picLocks noChangeAspect="1"/>
+          </p:cNvPicPr>
+          <p:nvPr/>
+        </p:nvPicPr>
+        <p:blipFill>
+          <a:blip r:embed="rId11"/>
+          <a:stretch>
+            <a:fillRect/>
+          </a:stretch>
+        </p:blipFill>
+        <p:spPr>
+          <a:xfrm>
+            <a:off x="9696056" y="4940464"/>
+            <a:ext cx="149626" cy="149626"/>
+          </a:xfrm>
+          <a:prstGeom prst="rect">
+            <a:avLst/>
+          </a:prstGeom>
+        </p:spPr>
+      </p:pic>
+      <p:pic>
+        <p:nvPicPr>
+          <p:cNvPr id="62" name="Grafik 61">
+            <a:extLst>
+              <a:ext uri="{FF2B5EF4-FFF2-40B4-BE49-F238E27FC236}">
+                <a16:creationId xmlns:a16="http://schemas.microsoft.com/office/drawing/2014/main" id="{F87205AF-307E-5AE5-E61F-83ED02ECC67F}"/>
+              </a:ext>
+            </a:extLst>
+          </p:cNvPr>
+          <p:cNvPicPr>
+            <a:picLocks noChangeAspect="1"/>
+          </p:cNvPicPr>
+          <p:nvPr/>
+        </p:nvPicPr>
+        <p:blipFill>
+          <a:blip r:embed="rId11"/>
+          <a:stretch>
+            <a:fillRect/>
+          </a:stretch>
+        </p:blipFill>
+        <p:spPr>
+          <a:xfrm>
+            <a:off x="9216053" y="4850866"/>
+            <a:ext cx="149626" cy="149626"/>
+          </a:xfrm>
+          <a:prstGeom prst="rect">
+            <a:avLst/>
+          </a:prstGeom>
+        </p:spPr>
+      </p:pic>
+      <p:pic>
+        <p:nvPicPr>
+          <p:cNvPr id="63" name="Grafik 62">
+            <a:extLst>
+              <a:ext uri="{FF2B5EF4-FFF2-40B4-BE49-F238E27FC236}">
+                <a16:creationId xmlns:a16="http://schemas.microsoft.com/office/drawing/2014/main" id="{B11EFDF4-8B16-452B-83AC-008C3AAD7127}"/>
+              </a:ext>
+            </a:extLst>
+          </p:cNvPr>
+          <p:cNvPicPr>
+            <a:picLocks noChangeAspect="1"/>
+          </p:cNvPicPr>
+          <p:nvPr/>
+        </p:nvPicPr>
+        <p:blipFill>
+          <a:blip r:embed="rId11"/>
+          <a:stretch>
+            <a:fillRect/>
+          </a:stretch>
+        </p:blipFill>
+        <p:spPr>
+          <a:xfrm>
+            <a:off x="9202103" y="4678315"/>
+            <a:ext cx="149626" cy="149626"/>
+          </a:xfrm>
+          <a:prstGeom prst="rect">
+            <a:avLst/>
+          </a:prstGeom>
+        </p:spPr>
+      </p:pic>
+      <p:pic>
+        <p:nvPicPr>
+          <p:cNvPr id="70" name="Grafik 69">
+            <a:extLst>
+              <a:ext uri="{FF2B5EF4-FFF2-40B4-BE49-F238E27FC236}">
+                <a16:creationId xmlns:a16="http://schemas.microsoft.com/office/drawing/2014/main" id="{BBC9383C-EF01-8D5A-7FE8-C8DEA87F5A67}"/>
+              </a:ext>
+            </a:extLst>
+          </p:cNvPr>
+          <p:cNvPicPr>
+            <a:picLocks noChangeAspect="1"/>
+          </p:cNvPicPr>
+          <p:nvPr/>
+        </p:nvPicPr>
+        <p:blipFill>
+          <a:blip r:embed="rId11"/>
+          <a:stretch>
+            <a:fillRect/>
+          </a:stretch>
+        </p:blipFill>
+        <p:spPr>
+          <a:xfrm>
+            <a:off x="9871722" y="4929429"/>
+            <a:ext cx="149626" cy="149626"/>
+          </a:xfrm>
+          <a:prstGeom prst="rect">
+            <a:avLst/>
+          </a:prstGeom>
+        </p:spPr>
+      </p:pic>
+      <p:sp>
+        <p:nvSpPr>
+          <p:cNvPr id="75" name="Rechteck 74">
+            <a:extLst>
+              <a:ext uri="{FF2B5EF4-FFF2-40B4-BE49-F238E27FC236}">
+                <a16:creationId xmlns:a16="http://schemas.microsoft.com/office/drawing/2014/main" id="{B53F0E8B-C7DF-8961-07BE-0157C07E3FD8}"/>
+              </a:ext>
+            </a:extLst>
+          </p:cNvPr>
+          <p:cNvSpPr/>
+          <p:nvPr/>
+        </p:nvSpPr>
+        <p:spPr>
+          <a:xfrm>
+            <a:off x="1394849" y="2431489"/>
+            <a:ext cx="1297138" cy="984928"/>
+          </a:xfrm>
+          <a:prstGeom prst="rect">
+            <a:avLst/>
+          </a:prstGeom>
+          <a:noFill/>
+          <a:ln w="6350">
+            <a:prstDash val="dash"/>
+          </a:ln>
+        </p:spPr>
+        <p:style>
+          <a:lnRef idx="2">
+            <a:schemeClr val="accent1">
+              <a:shade val="15000"/>
+            </a:schemeClr>
+          </a:lnRef>
+          <a:fillRef idx="1">
+            <a:schemeClr val="accent1"/>
+          </a:fillRef>
+          <a:effectRef idx="0">
+            <a:schemeClr val="accent1"/>
+          </a:effectRef>
+          <a:fontRef idx="minor">
+            <a:schemeClr val="lt1"/>
+          </a:fontRef>
+        </p:style>
+        <p:txBody>
+          <a:bodyPr lIns="36000" tIns="0" rIns="0" bIns="0" rtlCol="0" anchor="t"/>
+          <a:lstStyle/>
+          <a:p>
+            <a:r>
+              <a:rPr lang="de-DE" sz="800" dirty="0">
+                <a:solidFill>
+                  <a:schemeClr val="tx1"/>
+                </a:solidFill>
+              </a:rPr>
+              <a:t>p1UpdateMwdiReplica</a:t>
+            </a:r>
+          </a:p>
+        </p:txBody>
+      </p:sp>
+      <p:sp>
+        <p:nvSpPr>
+          <p:cNvPr id="85" name="Legende: Linie 84">
+            <a:extLst>
+              <a:ext uri="{FF2B5EF4-FFF2-40B4-BE49-F238E27FC236}">
+                <a16:creationId xmlns:a16="http://schemas.microsoft.com/office/drawing/2014/main" id="{306D5500-4F03-25BA-53AA-861AB72BD44F}"/>
+              </a:ext>
+            </a:extLst>
+          </p:cNvPr>
+          <p:cNvSpPr/>
+          <p:nvPr/>
+        </p:nvSpPr>
+        <p:spPr>
+          <a:xfrm>
+            <a:off x="2324191" y="1591459"/>
+            <a:ext cx="3182167" cy="338554"/>
+          </a:xfrm>
+          <a:prstGeom prst="borderCallout1">
+            <a:avLst>
+              <a:gd name="adj1" fmla="val 51908"/>
+              <a:gd name="adj2" fmla="val -1600"/>
+              <a:gd name="adj3" fmla="val 244103"/>
+              <a:gd name="adj4" fmla="val -6285"/>
+            </a:avLst>
+          </a:prstGeom>
+          <a:noFill/>
+          <a:ln w="6350">
+            <a:solidFill>
+              <a:schemeClr val="accent1">
+                <a:shade val="15000"/>
+              </a:schemeClr>
+            </a:solidFill>
+          </a:ln>
+        </p:spPr>
+        <p:txBody>
+          <a:bodyPr wrap="square" rtlCol="0">
+            <a:spAutoFit/>
+          </a:bodyPr>
+          <a:lstStyle/>
+          <a:p>
+            <a:r>
+              <a:rPr lang="de-DE" sz="800" dirty="0" err="1">
+                <a:solidFill>
+                  <a:schemeClr val="tx1"/>
+                </a:solidFill>
+              </a:rPr>
+              <a:t>started</a:t>
+            </a:r>
+            <a:r>
+              <a:rPr lang="de-DE" sz="800" dirty="0">
+                <a:solidFill>
+                  <a:schemeClr val="tx1"/>
+                </a:solidFill>
+              </a:rPr>
+              <a:t> </a:t>
+            </a:r>
+            <a:r>
+              <a:rPr lang="de-DE" sz="800" dirty="0" err="1"/>
+              <a:t>by</a:t>
+            </a:r>
+            <a:r>
+              <a:rPr lang="de-DE" sz="800" dirty="0"/>
+              <a:t> /v1/</a:t>
+            </a:r>
+            <a:r>
+              <a:rPr lang="de-DE" sz="800" dirty="0" err="1"/>
+              <a:t>embed-yourself</a:t>
+            </a:r>
+            <a:endParaRPr lang="de-DE" sz="800" dirty="0"/>
+          </a:p>
+          <a:p>
+            <a:r>
+              <a:rPr lang="de-DE" sz="800" dirty="0" err="1"/>
+              <a:t>initiating</a:t>
+            </a:r>
+            <a:r>
+              <a:rPr lang="de-DE" sz="800" dirty="0"/>
+              <a:t> an </a:t>
+            </a:r>
+            <a:r>
+              <a:rPr lang="de-DE" sz="800" dirty="0" err="1"/>
+              <a:t>instance</a:t>
+            </a:r>
+            <a:r>
+              <a:rPr lang="de-DE" sz="800" dirty="0"/>
+              <a:t> </a:t>
+            </a:r>
+            <a:r>
+              <a:rPr lang="de-DE" sz="800" dirty="0" err="1"/>
+              <a:t>of</a:t>
+            </a:r>
+            <a:r>
+              <a:rPr lang="de-DE" sz="800" dirty="0"/>
+              <a:t> p1ProcessDevice </a:t>
+            </a:r>
+            <a:r>
+              <a:rPr lang="de-DE" sz="800" dirty="0" err="1"/>
+              <a:t>for</a:t>
+            </a:r>
+            <a:r>
+              <a:rPr lang="de-DE" sz="800" dirty="0"/>
+              <a:t> </a:t>
+            </a:r>
+            <a:r>
+              <a:rPr lang="de-DE" sz="800" dirty="0" err="1"/>
+              <a:t>every</a:t>
+            </a:r>
+            <a:r>
+              <a:rPr lang="de-DE" sz="800" dirty="0"/>
+              <a:t> </a:t>
+            </a:r>
+            <a:r>
+              <a:rPr lang="de-DE" sz="800" dirty="0" err="1"/>
+              <a:t>updated</a:t>
+            </a:r>
+            <a:r>
+              <a:rPr lang="de-DE" sz="800" dirty="0"/>
+              <a:t> </a:t>
+            </a:r>
+            <a:r>
+              <a:rPr lang="de-DE" sz="800" dirty="0">
+                <a:solidFill>
+                  <a:schemeClr val="tx1"/>
+                </a:solidFill>
+              </a:rPr>
+              <a:t>CC</a:t>
+            </a:r>
+          </a:p>
+        </p:txBody>
+      </p:sp>
+    </p:spTree>
+    <p:extLst>
+      <p:ext uri="{BB962C8B-B14F-4D97-AF65-F5344CB8AC3E}">
+        <p14:creationId xmlns:p14="http://schemas.microsoft.com/office/powerpoint/2010/main" val="3468756874"/>
+      </p:ext>
+    </p:extLst>
+  </p:cSld>
+  <p:clrMapOvr>
+    <a:masterClrMapping/>
+  </p:clrMapOvr>
+</p:sld>
+</file>
+
+<file path=ppt/slides/slide2.xml><?xml version="1.0" encoding="utf-8"?>
 <p:sld xmlns:a="http://schemas.openxmlformats.org/drawingml/2006/main" xmlns:r="http://schemas.openxmlformats.org/officeDocument/2006/relationships" xmlns:p="http://schemas.openxmlformats.org/presentationml/2006/main">
   <p:cSld>
     <p:spTree>
@@ -11746,7 +16371,7 @@
 </p:sld>
 </file>
 
-<file path=ppt/slides/slide2.xml><?xml version="1.0" encoding="utf-8"?>
+<file path=ppt/slides/slide3.xml><?xml version="1.0" encoding="utf-8"?>
 <p:sld xmlns:a="http://schemas.openxmlformats.org/drawingml/2006/main" xmlns:r="http://schemas.openxmlformats.org/officeDocument/2006/relationships" xmlns:p="http://schemas.openxmlformats.org/presentationml/2006/main">
   <p:cSld>
     <p:spTree>
@@ -16435,7 +21060,7 @@
 </p:sld>
 </file>
 
-<file path=ppt/slides/slide3.xml><?xml version="1.0" encoding="utf-8"?>
+<file path=ppt/slides/slide4.xml><?xml version="1.0" encoding="utf-8"?>
 <p:sld xmlns:a="http://schemas.openxmlformats.org/drawingml/2006/main" xmlns:r="http://schemas.openxmlformats.org/officeDocument/2006/relationships" xmlns:p="http://schemas.openxmlformats.org/presentationml/2006/main">
   <p:cSld>
     <p:spTree>
@@ -24639,7 +29264,7 @@
 </p:sld>
 </file>
 
-<file path=ppt/slides/slide4.xml><?xml version="1.0" encoding="utf-8"?>
+<file path=ppt/slides/slide5.xml><?xml version="1.0" encoding="utf-8"?>
 <p:sld xmlns:a="http://schemas.openxmlformats.org/drawingml/2006/main" xmlns:r="http://schemas.openxmlformats.org/officeDocument/2006/relationships" xmlns:p="http://schemas.openxmlformats.org/presentationml/2006/main">
   <p:cSld>
     <p:spTree>
@@ -25341,7 +29966,7 @@
 </p:sld>
 </file>
 
-<file path=ppt/slides/slide5.xml><?xml version="1.0" encoding="utf-8"?>
+<file path=ppt/slides/slide6.xml><?xml version="1.0" encoding="utf-8"?>
 <p:sld xmlns:a="http://schemas.openxmlformats.org/drawingml/2006/main" xmlns:r="http://schemas.openxmlformats.org/officeDocument/2006/relationships" xmlns:p="http://schemas.openxmlformats.org/presentationml/2006/main">
   <p:cSld>
     <p:spTree>
@@ -30359,7 +34984,7 @@
 </p:sld>
 </file>
 
-<file path=ppt/slides/slide6.xml><?xml version="1.0" encoding="utf-8"?>
+<file path=ppt/slides/slide7.xml><?xml version="1.0" encoding="utf-8"?>
 <p:sld xmlns:a="http://schemas.openxmlformats.org/drawingml/2006/main" xmlns:r="http://schemas.openxmlformats.org/officeDocument/2006/relationships" xmlns:p="http://schemas.openxmlformats.org/presentationml/2006/main">
   <p:cSld>
     <p:spTree>
@@ -38974,7 +43599,7 @@
 </p:sld>
 </file>
 
-<file path=ppt/slides/slide7.xml><?xml version="1.0" encoding="utf-8"?>
+<file path=ppt/slides/slide8.xml><?xml version="1.0" encoding="utf-8"?>
 <p:sld xmlns:a="http://schemas.openxmlformats.org/drawingml/2006/main" xmlns:r="http://schemas.openxmlformats.org/officeDocument/2006/relationships" xmlns:p="http://schemas.openxmlformats.org/presentationml/2006/main">
   <p:cSld>
     <p:spTree>
@@ -39315,7 +43940,7 @@
 </p:sld>
 </file>
 
-<file path=ppt/slides/slide8.xml><?xml version="1.0" encoding="utf-8"?>
+<file path=ppt/slides/slide9.xml><?xml version="1.0" encoding="utf-8"?>
 <p:sld xmlns:a="http://schemas.openxmlformats.org/drawingml/2006/main" xmlns:r="http://schemas.openxmlformats.org/officeDocument/2006/relationships" xmlns:p="http://schemas.openxmlformats.org/presentationml/2006/main">
   <p:cSld>
     <p:spTree>
@@ -46839,6 +51464,12 @@
 </p:tagLst>
 </file>
 
+<file path=ppt/tags/tag9.xml><?xml version="1.0" encoding="utf-8"?>
+<p:tagLst xmlns:a="http://schemas.openxmlformats.org/drawingml/2006/main" xmlns:r="http://schemas.openxmlformats.org/officeDocument/2006/relationships" xmlns:p="http://schemas.openxmlformats.org/presentationml/2006/main">
+  <p:tag name="THINKCELLSHAPEDONOTDELETE" val="thinkcellActiveDocDoNotDelete"/>
+</p:tagLst>
+</file>
+
 <file path=ppt/theme/theme1.xml><?xml version="1.0" encoding="utf-8"?>
 <a:theme xmlns:a="http://schemas.openxmlformats.org/drawingml/2006/main" name="Office">
   <a:themeElements>

</xml_diff>